<commit_message>
Changelogs: - Minori modifiche (commenti e non solo)
</commit_message>
<xml_diff>
--- a/Progetto Interfacce Uomo-Macchina.pptx
+++ b/Progetto Interfacce Uomo-Macchina.pptx
@@ -17054,7 +17054,7 @@
               <a:buNone/>
             </a:pPr>
             <a:r>
-              <a:rPr lang="en-US" sz="3000">
+              <a:rPr lang="en-US" sz="3000" dirty="0">
                 <a:solidFill>
                   <a:srgbClr val="F8FAFC"/>
                 </a:solidFill>
@@ -17063,9 +17063,57 @@
                 <a:cs typeface="Poppins SemiBold"/>
                 <a:sym typeface="Poppins SemiBold"/>
               </a:rPr>
-              <a:t>Altri esperimenti (scartati)</a:t>
-            </a:r>
-            <a:endParaRPr/>
+              <a:t>Altro - </a:t>
+            </a:r>
+            <a:r>
+              <a:rPr lang="en-US" sz="3000" dirty="0" err="1">
+                <a:solidFill>
+                  <a:srgbClr val="F8FAFC"/>
+                </a:solidFill>
+                <a:latin typeface="Poppins SemiBold"/>
+                <a:ea typeface="Poppins SemiBold"/>
+                <a:cs typeface="Poppins SemiBold"/>
+                <a:sym typeface="Poppins SemiBold"/>
+              </a:rPr>
+              <a:t>Esperimenti</a:t>
+            </a:r>
+            <a:r>
+              <a:rPr lang="en-US" sz="3000" dirty="0">
+                <a:solidFill>
+                  <a:srgbClr val="F8FAFC"/>
+                </a:solidFill>
+                <a:latin typeface="Poppins SemiBold"/>
+                <a:ea typeface="Poppins SemiBold"/>
+                <a:cs typeface="Poppins SemiBold"/>
+                <a:sym typeface="Poppins SemiBold"/>
+              </a:rPr>
+              <a:t> (</a:t>
+            </a:r>
+            <a:r>
+              <a:rPr lang="en-US" sz="3000" dirty="0" err="1">
+                <a:solidFill>
+                  <a:srgbClr val="F8FAFC"/>
+                </a:solidFill>
+                <a:latin typeface="Poppins SemiBold"/>
+                <a:ea typeface="Poppins SemiBold"/>
+                <a:cs typeface="Poppins SemiBold"/>
+                <a:sym typeface="Poppins SemiBold"/>
+              </a:rPr>
+              <a:t>scartati</a:t>
+            </a:r>
+            <a:r>
+              <a:rPr lang="en-US" sz="3000" dirty="0">
+                <a:solidFill>
+                  <a:srgbClr val="F8FAFC"/>
+                </a:solidFill>
+                <a:latin typeface="Poppins SemiBold"/>
+                <a:ea typeface="Poppins SemiBold"/>
+                <a:cs typeface="Poppins SemiBold"/>
+                <a:sym typeface="Poppins SemiBold"/>
+              </a:rPr>
+              <a:t>) e screenshots</a:t>
+            </a:r>
+            <a:endParaRPr dirty="0"/>
           </a:p>
         </p:txBody>
       </p:sp>
@@ -17078,7 +17126,7 @@
         <p:spPr>
           <a:xfrm>
             <a:off x="571500" y="1350200"/>
-            <a:ext cx="6130200" cy="2326791"/>
+            <a:ext cx="4287883" cy="2758069"/>
           </a:xfrm>
           <a:prstGeom prst="rect">
             <a:avLst/>
@@ -17811,6 +17859,104 @@
               <a:cs typeface="Inter"/>
               <a:sym typeface="Inter"/>
             </a:endParaRPr>
+          </a:p>
+        </p:txBody>
+      </p:sp>
+      <p:pic>
+        <p:nvPicPr>
+          <p:cNvPr id="3" name="Immagine 2">
+            <a:extLst>
+              <a:ext uri="{FF2B5EF4-FFF2-40B4-BE49-F238E27FC236}">
+                <a16:creationId xmlns:a16="http://schemas.microsoft.com/office/drawing/2014/main" id="{D7C588C3-6093-5D04-637C-77B80EAB4566}"/>
+              </a:ext>
+            </a:extLst>
+          </p:cNvPr>
+          <p:cNvPicPr>
+            <a:picLocks noChangeAspect="1"/>
+          </p:cNvPicPr>
+          <p:nvPr/>
+        </p:nvPicPr>
+        <p:blipFill>
+          <a:blip r:embed="rId4"/>
+          <a:stretch>
+            <a:fillRect/>
+          </a:stretch>
+        </p:blipFill>
+        <p:spPr>
+          <a:xfrm>
+            <a:off x="5111167" y="1601349"/>
+            <a:ext cx="6331896" cy="3762782"/>
+          </a:xfrm>
+          <a:prstGeom prst="roundRect">
+            <a:avLst>
+              <a:gd name="adj" fmla="val 16667"/>
+            </a:avLst>
+          </a:prstGeom>
+          <a:ln>
+            <a:noFill/>
+          </a:ln>
+          <a:effectLst>
+            <a:outerShdw blurRad="76200" dist="38100" dir="7800000" algn="tl" rotWithShape="0">
+              <a:srgbClr val="000000">
+                <a:alpha val="40000"/>
+              </a:srgbClr>
+            </a:outerShdw>
+          </a:effectLst>
+          <a:scene3d>
+            <a:camera prst="orthographicFront"/>
+            <a:lightRig rig="contrasting" dir="t">
+              <a:rot lat="0" lon="0" rev="4200000"/>
+            </a:lightRig>
+          </a:scene3d>
+          <a:sp3d prstMaterial="plastic">
+            <a:bevelT w="381000" h="114300" prst="relaxedInset"/>
+            <a:contourClr>
+              <a:srgbClr val="969696"/>
+            </a:contourClr>
+          </a:sp3d>
+        </p:spPr>
+      </p:pic>
+      <p:sp>
+        <p:nvSpPr>
+          <p:cNvPr id="7" name="CasellaDiTesto 6">
+            <a:extLst>
+              <a:ext uri="{FF2B5EF4-FFF2-40B4-BE49-F238E27FC236}">
+                <a16:creationId xmlns:a16="http://schemas.microsoft.com/office/drawing/2014/main" id="{28D02567-1529-5595-B43E-822C849CE8D1}"/>
+              </a:ext>
+            </a:extLst>
+          </p:cNvPr>
+          <p:cNvSpPr txBox="1"/>
+          <p:nvPr/>
+        </p:nvSpPr>
+        <p:spPr>
+          <a:xfrm>
+            <a:off x="6421873" y="5499977"/>
+            <a:ext cx="3947118" cy="307777"/>
+          </a:xfrm>
+          <a:prstGeom prst="rect">
+            <a:avLst/>
+          </a:prstGeom>
+          <a:noFill/>
+        </p:spPr>
+        <p:txBody>
+          <a:bodyPr wrap="square">
+            <a:spAutoFit/>
+          </a:bodyPr>
+          <a:lstStyle/>
+          <a:p>
+            <a:r>
+              <a:rPr lang="en-US" sz="1400" dirty="0">
+                <a:solidFill>
+                  <a:srgbClr val="CBD5E1"/>
+                </a:solidFill>
+                <a:latin typeface="Inter"/>
+                <a:ea typeface="Inter"/>
+                <a:cs typeface="Inter"/>
+                <a:sym typeface="Inter"/>
+              </a:rPr>
+              <a:t>Matrice di confusion finale (senza HR e IBI)</a:t>
+            </a:r>
+            <a:endParaRPr lang="it-IT" dirty="0"/>
           </a:p>
         </p:txBody>
       </p:sp>

</xml_diff>

<commit_message>
Changelogs: - Corretto testo codice exp. - Aggiornato screenshot exp. - Aggiornato PowerPoint.
</commit_message>
<xml_diff>
--- a/Progetto Interfacce Uomo-Macchina.pptx
+++ b/Progetto Interfacce Uomo-Macchina.pptx
@@ -19177,7 +19177,7 @@
         </p:nvSpPr>
         <p:spPr>
           <a:xfrm>
-            <a:off x="571499" y="4600907"/>
+            <a:off x="571500" y="4513265"/>
             <a:ext cx="4287883" cy="1661993"/>
           </a:xfrm>
           <a:prstGeom prst="rect">
@@ -19228,7 +19228,7 @@
                 <a:cs typeface="Inter"/>
                 <a:sym typeface="Inter"/>
               </a:rPr>
-              <a:t> con LOSO (al posto di K-Fold)</a:t>
+              <a:t> con LOSO</a:t>
             </a:r>
           </a:p>
           <a:p>
@@ -19254,7 +19254,7 @@
                 <a:cs typeface="Inter"/>
                 <a:sym typeface="Inter"/>
               </a:rPr>
-              <a:t>Sono state inoltre testate versioni con LOSO al posto di K-Fold, con </a:t>
+              <a:t>Sono state inoltre testate versioni con LOSO (</a:t>
             </a:r>
             <a:r>
               <a:rPr lang="it-IT" sz="1350" dirty="0" err="1">
@@ -19266,6 +19266,30 @@
                 <a:cs typeface="Inter"/>
                 <a:sym typeface="Inter"/>
               </a:rPr>
+              <a:t>Leave</a:t>
+            </a:r>
+            <a:r>
+              <a:rPr lang="it-IT" sz="1350" dirty="0">
+                <a:solidFill>
+                  <a:srgbClr val="CBD5E1"/>
+                </a:solidFill>
+                <a:latin typeface="Inter"/>
+                <a:ea typeface="Inter"/>
+                <a:cs typeface="Inter"/>
+                <a:sym typeface="Inter"/>
+              </a:rPr>
+              <a:t>-One-Subject-Out), con </a:t>
+            </a:r>
+            <a:r>
+              <a:rPr lang="it-IT" sz="1350" dirty="0" err="1">
+                <a:solidFill>
+                  <a:srgbClr val="CBD5E1"/>
+                </a:solidFill>
+                <a:latin typeface="Inter"/>
+                <a:ea typeface="Inter"/>
+                <a:cs typeface="Inter"/>
+                <a:sym typeface="Inter"/>
+              </a:rPr>
               <a:t>GentleBoost</a:t>
             </a:r>
             <a:r>
@@ -19304,15 +19328,107 @@
               </a:rPr>
               <a:t>, che non soffrono di Data Leakage ma raggiungono risultati non al livello del Paper.</a:t>
             </a:r>
+          </a:p>
+        </p:txBody>
+      </p:sp>
+      <p:sp>
+        <p:nvSpPr>
+          <p:cNvPr id="6" name="CasellaDiTesto 5">
+            <a:extLst>
+              <a:ext uri="{FF2B5EF4-FFF2-40B4-BE49-F238E27FC236}">
+                <a16:creationId xmlns:a16="http://schemas.microsoft.com/office/drawing/2014/main" id="{5EFC5A06-B844-15E6-F0F9-A6EAE5150CD7}"/>
+              </a:ext>
+            </a:extLst>
+          </p:cNvPr>
+          <p:cNvSpPr txBox="1"/>
+          <p:nvPr/>
+        </p:nvSpPr>
+        <p:spPr>
+          <a:xfrm>
+            <a:off x="5991903" y="6490353"/>
+            <a:ext cx="4223418" cy="307777"/>
+          </a:xfrm>
+          <a:prstGeom prst="rect">
+            <a:avLst/>
+          </a:prstGeom>
+          <a:noFill/>
+        </p:spPr>
+        <p:txBody>
+          <a:bodyPr wrap="square">
+            <a:spAutoFit/>
+          </a:bodyPr>
+          <a:lstStyle/>
+          <a:p>
+            <a:r>
+              <a:rPr lang="en-US" sz="1400" dirty="0">
+                <a:solidFill>
+                  <a:srgbClr val="CBD5E1"/>
+                </a:solidFill>
+                <a:latin typeface="Inter"/>
+                <a:ea typeface="Inter"/>
+                <a:cs typeface="Inter"/>
+                <a:sym typeface="Inter"/>
+              </a:rPr>
+              <a:t>Matrice di </a:t>
+            </a:r>
+            <a:r>
+              <a:rPr lang="en-US" sz="1400" dirty="0" err="1">
+                <a:solidFill>
+                  <a:srgbClr val="CBD5E1"/>
+                </a:solidFill>
+                <a:latin typeface="Inter"/>
+                <a:ea typeface="Inter"/>
+                <a:cs typeface="Inter"/>
+                <a:sym typeface="Inter"/>
+              </a:rPr>
+              <a:t>confusione</a:t>
+            </a:r>
+            <a:r>
+              <a:rPr lang="en-US" sz="1400" dirty="0">
+                <a:solidFill>
+                  <a:srgbClr val="CBD5E1"/>
+                </a:solidFill>
+                <a:latin typeface="Inter"/>
+                <a:ea typeface="Inter"/>
+                <a:cs typeface="Inter"/>
+                <a:sym typeface="Inter"/>
+              </a:rPr>
+              <a:t> con </a:t>
+            </a:r>
+            <a:r>
+              <a:rPr lang="en-US" sz="1400" dirty="0" err="1">
+                <a:solidFill>
+                  <a:srgbClr val="CBD5E1"/>
+                </a:solidFill>
+                <a:latin typeface="Inter"/>
+                <a:ea typeface="Inter"/>
+                <a:cs typeface="Inter"/>
+                <a:sym typeface="Inter"/>
+              </a:rPr>
+              <a:t>GentleBoost</a:t>
+            </a:r>
+            <a:r>
+              <a:rPr lang="en-US" sz="1400" dirty="0">
+                <a:solidFill>
+                  <a:srgbClr val="CBD5E1"/>
+                </a:solidFill>
+                <a:latin typeface="Inter"/>
+                <a:ea typeface="Inter"/>
+                <a:cs typeface="Inter"/>
+                <a:sym typeface="Inter"/>
+              </a:rPr>
+              <a:t> e LOSO</a:t>
+            </a:r>
+            <a:endParaRPr lang="it-IT" dirty="0"/>
           </a:p>
         </p:txBody>
       </p:sp>
       <p:pic>
         <p:nvPicPr>
-          <p:cNvPr id="5" name="Immagine 4">
+          <p:cNvPr id="8" name="Immagine 7">
             <a:extLst>
               <a:ext uri="{FF2B5EF4-FFF2-40B4-BE49-F238E27FC236}">
-                <a16:creationId xmlns:a16="http://schemas.microsoft.com/office/drawing/2014/main" id="{45DE4265-5AFB-7A9F-7FC9-D05C9DFDE82F}"/>
+                <a16:creationId xmlns:a16="http://schemas.microsoft.com/office/drawing/2014/main" id="{86A96034-F068-7441-D27D-728C13871E88}"/>
               </a:ext>
             </a:extLst>
           </p:cNvPr>
@@ -19329,8 +19445,8 @@
         </p:blipFill>
         <p:spPr>
           <a:xfrm>
-            <a:off x="5887810" y="4190707"/>
-            <a:ext cx="4431607" cy="2239777"/>
+            <a:off x="5582792" y="4225541"/>
+            <a:ext cx="5041640" cy="2237443"/>
           </a:xfrm>
           <a:prstGeom prst="roundRect">
             <a:avLst>
@@ -19361,98 +19477,6 @@
           </a:sp3d>
         </p:spPr>
       </p:pic>
-      <p:sp>
-        <p:nvSpPr>
-          <p:cNvPr id="6" name="CasellaDiTesto 5">
-            <a:extLst>
-              <a:ext uri="{FF2B5EF4-FFF2-40B4-BE49-F238E27FC236}">
-                <a16:creationId xmlns:a16="http://schemas.microsoft.com/office/drawing/2014/main" id="{5EFC5A06-B844-15E6-F0F9-A6EAE5150CD7}"/>
-              </a:ext>
-            </a:extLst>
-          </p:cNvPr>
-          <p:cNvSpPr txBox="1"/>
-          <p:nvPr/>
-        </p:nvSpPr>
-        <p:spPr>
-          <a:xfrm>
-            <a:off x="6155268" y="6521703"/>
-            <a:ext cx="4223418" cy="307777"/>
-          </a:xfrm>
-          <a:prstGeom prst="rect">
-            <a:avLst/>
-          </a:prstGeom>
-          <a:noFill/>
-        </p:spPr>
-        <p:txBody>
-          <a:bodyPr wrap="square">
-            <a:spAutoFit/>
-          </a:bodyPr>
-          <a:lstStyle/>
-          <a:p>
-            <a:r>
-              <a:rPr lang="en-US" sz="1400" dirty="0">
-                <a:solidFill>
-                  <a:srgbClr val="CBD5E1"/>
-                </a:solidFill>
-                <a:latin typeface="Inter"/>
-                <a:ea typeface="Inter"/>
-                <a:cs typeface="Inter"/>
-                <a:sym typeface="Inter"/>
-              </a:rPr>
-              <a:t>Matrice di </a:t>
-            </a:r>
-            <a:r>
-              <a:rPr lang="en-US" sz="1400" dirty="0" err="1">
-                <a:solidFill>
-                  <a:srgbClr val="CBD5E1"/>
-                </a:solidFill>
-                <a:latin typeface="Inter"/>
-                <a:ea typeface="Inter"/>
-                <a:cs typeface="Inter"/>
-                <a:sym typeface="Inter"/>
-              </a:rPr>
-              <a:t>confusioe</a:t>
-            </a:r>
-            <a:r>
-              <a:rPr lang="en-US" sz="1400" dirty="0">
-                <a:solidFill>
-                  <a:srgbClr val="CBD5E1"/>
-                </a:solidFill>
-                <a:latin typeface="Inter"/>
-                <a:ea typeface="Inter"/>
-                <a:cs typeface="Inter"/>
-                <a:sym typeface="Inter"/>
-              </a:rPr>
-              <a:t> con </a:t>
-            </a:r>
-            <a:r>
-              <a:rPr lang="en-US" sz="1400" dirty="0" err="1">
-                <a:solidFill>
-                  <a:srgbClr val="CBD5E1"/>
-                </a:solidFill>
-                <a:latin typeface="Inter"/>
-                <a:ea typeface="Inter"/>
-                <a:cs typeface="Inter"/>
-                <a:sym typeface="Inter"/>
-              </a:rPr>
-              <a:t>GentleBoost</a:t>
-            </a:r>
-            <a:r>
-              <a:rPr lang="en-US" sz="1400" dirty="0">
-                <a:solidFill>
-                  <a:srgbClr val="CBD5E1"/>
-                </a:solidFill>
-                <a:latin typeface="Inter"/>
-                <a:ea typeface="Inter"/>
-                <a:cs typeface="Inter"/>
-                <a:sym typeface="Inter"/>
-              </a:rPr>
-              <a:t> e LOSO</a:t>
-            </a:r>
-            <a:endParaRPr lang="it-IT" dirty="0"/>
-          </a:p>
-        </p:txBody>
-      </p:sp>
     </p:spTree>
   </p:cSld>
   <p:clrMapOvr>
@@ -20556,8 +20580,8 @@
         </p:blipFill>
         <p:spPr>
           <a:xfrm>
-            <a:off x="571500" y="2277516"/>
-            <a:ext cx="5286375" cy="3255466"/>
+            <a:off x="571500" y="2277515"/>
+            <a:ext cx="5286375" cy="3490237"/>
           </a:xfrm>
           <a:prstGeom prst="rect">
             <a:avLst/>
@@ -20584,7 +20608,7 @@
         <p:spPr>
           <a:xfrm>
             <a:off x="6334125" y="2277516"/>
-            <a:ext cx="5286375" cy="3255466"/>
+            <a:ext cx="5286375" cy="3490238"/>
           </a:xfrm>
           <a:prstGeom prst="rect">
             <a:avLst/>
@@ -21136,7 +21160,31 @@
                 <a:cs typeface="Inter"/>
                 <a:sym typeface="Inter"/>
               </a:rPr>
-              <a:t> del 76,5% (</a:t>
+              <a:t> del </a:t>
+            </a:r>
+            <a:r>
+              <a:rPr lang="en-US" sz="1350" b="1" i="0" u="none" strike="noStrike" cap="none" dirty="0">
+                <a:solidFill>
+                  <a:srgbClr val="CBD5E1"/>
+                </a:solidFill>
+                <a:latin typeface="Inter"/>
+                <a:ea typeface="Inter"/>
+                <a:cs typeface="Inter"/>
+                <a:sym typeface="Inter"/>
+              </a:rPr>
+              <a:t>76,5%</a:t>
+            </a:r>
+            <a:r>
+              <a:rPr lang="en-US" sz="1350" b="0" i="0" u="none" strike="noStrike" cap="none" dirty="0">
+                <a:solidFill>
+                  <a:srgbClr val="CBD5E1"/>
+                </a:solidFill>
+                <a:latin typeface="Inter"/>
+                <a:ea typeface="Inter"/>
+                <a:cs typeface="Inter"/>
+                <a:sym typeface="Inter"/>
+              </a:rPr>
+              <a:t> (</a:t>
             </a:r>
             <a:r>
               <a:rPr lang="en-US" sz="1350" b="0" i="0" u="none" strike="noStrike" cap="none" dirty="0" err="1">
@@ -21237,7 +21285,7 @@
         <p:spPr>
           <a:xfrm>
             <a:off x="6724650" y="3210966"/>
-            <a:ext cx="4505400" cy="997196"/>
+            <a:ext cx="4505400" cy="2326791"/>
           </a:xfrm>
           <a:prstGeom prst="rect">
             <a:avLst/>
@@ -21469,34 +21517,7 @@
               </a:rPr>
               <a:t>.</a:t>
             </a:r>
-            <a:endParaRPr dirty="0"/>
           </a:p>
-        </p:txBody>
-      </p:sp>
-      <p:sp>
-        <p:nvSpPr>
-          <p:cNvPr id="109" name="Google Shape;109;p15"/>
-          <p:cNvSpPr txBox="1"/>
-          <p:nvPr/>
-        </p:nvSpPr>
-        <p:spPr>
-          <a:xfrm>
-            <a:off x="6724650" y="4162322"/>
-            <a:ext cx="4505400" cy="997196"/>
-          </a:xfrm>
-          <a:prstGeom prst="rect">
-            <a:avLst/>
-          </a:prstGeom>
-          <a:noFill/>
-          <a:ln>
-            <a:noFill/>
-          </a:ln>
-        </p:spPr>
-        <p:txBody>
-          <a:bodyPr spcFirstLastPara="1" wrap="square" lIns="0" tIns="0" rIns="0" bIns="0" anchor="t" anchorCtr="0">
-            <a:spAutoFit/>
-          </a:bodyPr>
-          <a:lstStyle/>
           <a:p>
             <a:pPr marL="0" marR="0" lvl="0" indent="0" algn="l" rtl="0">
               <a:lnSpc>
@@ -21517,7 +21538,6 @@
                 </a:solidFill>
                 <a:latin typeface="Inter"/>
                 <a:ea typeface="Inter"/>
-                <a:cs typeface="Inter"/>
                 <a:sym typeface="Inter"/>
               </a:rPr>
               <a:t>Questo</a:t>
@@ -21529,7 +21549,6 @@
                 </a:solidFill>
                 <a:latin typeface="Inter"/>
                 <a:ea typeface="Inter"/>
-                <a:cs typeface="Inter"/>
                 <a:sym typeface="Inter"/>
               </a:rPr>
               <a:t> </a:t>
@@ -21541,7 +21560,6 @@
                 </a:solidFill>
                 <a:latin typeface="Inter"/>
                 <a:ea typeface="Inter"/>
-                <a:cs typeface="Inter"/>
                 <a:sym typeface="Inter"/>
               </a:rPr>
               <a:t>può</a:t>
@@ -21553,7 +21571,6 @@
                 </a:solidFill>
                 <a:latin typeface="Inter"/>
                 <a:ea typeface="Inter"/>
-                <a:cs typeface="Inter"/>
                 <a:sym typeface="Inter"/>
               </a:rPr>
               <a:t> </a:t>
@@ -21565,7 +21582,6 @@
                 </a:solidFill>
                 <a:latin typeface="Inter"/>
                 <a:ea typeface="Inter"/>
-                <a:cs typeface="Inter"/>
                 <a:sym typeface="Inter"/>
               </a:rPr>
               <a:t>essere</a:t>
@@ -21577,7 +21593,6 @@
                 </a:solidFill>
                 <a:latin typeface="Inter"/>
                 <a:ea typeface="Inter"/>
-                <a:cs typeface="Inter"/>
                 <a:sym typeface="Inter"/>
               </a:rPr>
               <a:t> </a:t>
@@ -21589,7 +21604,6 @@
                 </a:solidFill>
                 <a:latin typeface="Inter"/>
                 <a:ea typeface="Inter"/>
-                <a:cs typeface="Inter"/>
                 <a:sym typeface="Inter"/>
               </a:rPr>
               <a:t>migliorato</a:t>
@@ -21601,7 +21615,50 @@
                 </a:solidFill>
                 <a:latin typeface="Inter"/>
                 <a:ea typeface="Inter"/>
-                <a:cs typeface="Inter"/>
+                <a:sym typeface="Inter"/>
+              </a:rPr>
+              <a:t> (per </a:t>
+            </a:r>
+            <a:r>
+              <a:rPr lang="en-US" sz="1350" dirty="0" err="1">
+                <a:solidFill>
+                  <a:srgbClr val="CBD5E1"/>
+                </a:solidFill>
+                <a:latin typeface="Inter"/>
+                <a:ea typeface="Inter"/>
+                <a:sym typeface="Inter"/>
+              </a:rPr>
+              <a:t>esempio</a:t>
+            </a:r>
+            <a:r>
+              <a:rPr lang="en-US" sz="1350" dirty="0">
+                <a:solidFill>
+                  <a:srgbClr val="CBD5E1"/>
+                </a:solidFill>
+                <a:latin typeface="Inter"/>
+                <a:ea typeface="Inter"/>
+                <a:sym typeface="Inter"/>
+              </a:rPr>
+              <a:t>) </a:t>
+            </a:r>
+            <a:r>
+              <a:rPr lang="en-US" sz="1350" dirty="0" err="1">
+                <a:solidFill>
+                  <a:srgbClr val="CBD5E1"/>
+                </a:solidFill>
+                <a:latin typeface="Inter"/>
+                <a:ea typeface="Inter"/>
+                <a:sym typeface="Inter"/>
+              </a:rPr>
+              <a:t>tramite</a:t>
+            </a:r>
+            <a:r>
+              <a:rPr lang="en-US" sz="1350" dirty="0">
+                <a:solidFill>
+                  <a:srgbClr val="CBD5E1"/>
+                </a:solidFill>
+                <a:latin typeface="Inter"/>
+                <a:ea typeface="Inter"/>
                 <a:sym typeface="Inter"/>
               </a:rPr>
               <a:t> </a:t>
@@ -21613,10 +21670,9 @@
                 </a:solidFill>
                 <a:latin typeface="Inter"/>
                 <a:ea typeface="Inter"/>
-                <a:cs typeface="Inter"/>
-                <a:sym typeface="Inter"/>
-              </a:rPr>
-              <a:t>tramite</a:t>
+                <a:sym typeface="Inter"/>
+              </a:rPr>
+              <a:t>l’estrazione</a:t>
             </a:r>
             <a:r>
               <a:rPr lang="en-US" sz="1350" dirty="0">
@@ -21625,7 +21681,50 @@
                 </a:solidFill>
                 <a:latin typeface="Inter"/>
                 <a:ea typeface="Inter"/>
-                <a:cs typeface="Inter"/>
+                <a:sym typeface="Inter"/>
+              </a:rPr>
+              <a:t> di </a:t>
+            </a:r>
+            <a:r>
+              <a:rPr lang="en-US" sz="1350" dirty="0" err="1">
+                <a:solidFill>
+                  <a:srgbClr val="CBD5E1"/>
+                </a:solidFill>
+                <a:latin typeface="Inter"/>
+                <a:ea typeface="Inter"/>
+                <a:sym typeface="Inter"/>
+              </a:rPr>
+              <a:t>più</a:t>
+            </a:r>
+            <a:r>
+              <a:rPr lang="en-US" sz="1350" dirty="0">
+                <a:solidFill>
+                  <a:srgbClr val="CBD5E1"/>
+                </a:solidFill>
+                <a:latin typeface="Inter"/>
+                <a:ea typeface="Inter"/>
+                <a:sym typeface="Inter"/>
+              </a:rPr>
+              <a:t> features </a:t>
+            </a:r>
+            <a:r>
+              <a:rPr lang="en-US" sz="1350" dirty="0" err="1">
+                <a:solidFill>
+                  <a:srgbClr val="CBD5E1"/>
+                </a:solidFill>
+                <a:latin typeface="Inter"/>
+                <a:ea typeface="Inter"/>
+                <a:sym typeface="Inter"/>
+              </a:rPr>
+              <a:t>utilizzando</a:t>
+            </a:r>
+            <a:r>
+              <a:rPr lang="en-US" sz="1350" dirty="0">
+                <a:solidFill>
+                  <a:srgbClr val="CBD5E1"/>
+                </a:solidFill>
+                <a:latin typeface="Inter"/>
+                <a:ea typeface="Inter"/>
                 <a:sym typeface="Inter"/>
               </a:rPr>
               <a:t> </a:t>
@@ -21637,10 +21736,9 @@
                 </a:solidFill>
                 <a:latin typeface="Inter"/>
                 <a:ea typeface="Inter"/>
-                <a:cs typeface="Inter"/>
-                <a:sym typeface="Inter"/>
-              </a:rPr>
-              <a:t>l’estrazioni</a:t>
+                <a:sym typeface="Inter"/>
+              </a:rPr>
+              <a:t>finestre</a:t>
             </a:r>
             <a:r>
               <a:rPr lang="en-US" sz="1350" dirty="0">
@@ -21649,7 +21747,6 @@
                 </a:solidFill>
                 <a:latin typeface="Inter"/>
                 <a:ea typeface="Inter"/>
-                <a:cs typeface="Inter"/>
                 <a:sym typeface="Inter"/>
               </a:rPr>
               <a:t> di </a:t>
@@ -21661,10 +21758,9 @@
                 </a:solidFill>
                 <a:latin typeface="Inter"/>
                 <a:ea typeface="Inter"/>
-                <a:cs typeface="Inter"/>
-                <a:sym typeface="Inter"/>
-              </a:rPr>
-              <a:t>più</a:t>
+                <a:sym typeface="Inter"/>
+              </a:rPr>
+              <a:t>lunghezze</a:t>
             </a:r>
             <a:r>
               <a:rPr lang="en-US" sz="1350" dirty="0">
@@ -21673,10 +21769,9 @@
                 </a:solidFill>
                 <a:latin typeface="Inter"/>
                 <a:ea typeface="Inter"/>
-                <a:cs typeface="Inter"/>
-                <a:sym typeface="Inter"/>
-              </a:rPr>
-              <a:t> features </a:t>
+                <a:sym typeface="Inter"/>
+              </a:rPr>
+              <a:t> diverse (come da 60 a 30 secondi) è </a:t>
             </a:r>
             <a:r>
               <a:rPr lang="en-US" sz="1350" dirty="0" err="1">
@@ -21685,10 +21780,9 @@
                 </a:solidFill>
                 <a:latin typeface="Inter"/>
                 <a:ea typeface="Inter"/>
-                <a:cs typeface="Inter"/>
-                <a:sym typeface="Inter"/>
-              </a:rPr>
-              <a:t>utilizzando</a:t>
+                <a:sym typeface="Inter"/>
+              </a:rPr>
+              <a:t>utilizzo</a:t>
             </a:r>
             <a:r>
               <a:rPr lang="en-US" sz="1350" dirty="0">
@@ -21697,10 +21791,9 @@
                 </a:solidFill>
                 <a:latin typeface="Inter"/>
                 <a:ea typeface="Inter"/>
-                <a:cs typeface="Inter"/>
-                <a:sym typeface="Inter"/>
-              </a:rPr>
-              <a:t> </a:t>
+                <a:sym typeface="Inter"/>
+              </a:rPr>
+              <a:t> di </a:t>
             </a:r>
             <a:r>
               <a:rPr lang="en-US" sz="1350" dirty="0" err="1">
@@ -21709,10 +21802,9 @@
                 </a:solidFill>
                 <a:latin typeface="Inter"/>
                 <a:ea typeface="Inter"/>
-                <a:cs typeface="Inter"/>
-                <a:sym typeface="Inter"/>
-              </a:rPr>
-              <a:t>finestre</a:t>
+                <a:sym typeface="Inter"/>
+              </a:rPr>
+              <a:t>RusBoost</a:t>
             </a:r>
             <a:r>
               <a:rPr lang="en-US" sz="1350" dirty="0">
@@ -21721,43 +21813,6 @@
                 </a:solidFill>
                 <a:latin typeface="Inter"/>
                 <a:ea typeface="Inter"/>
-                <a:cs typeface="Inter"/>
-                <a:sym typeface="Inter"/>
-              </a:rPr>
-              <a:t> di </a:t>
-            </a:r>
-            <a:r>
-              <a:rPr lang="en-US" sz="1350" dirty="0" err="1">
-                <a:solidFill>
-                  <a:srgbClr val="CBD5E1"/>
-                </a:solidFill>
-                <a:latin typeface="Inter"/>
-                <a:ea typeface="Inter"/>
-                <a:cs typeface="Inter"/>
-                <a:sym typeface="Inter"/>
-              </a:rPr>
-              <a:t>lunghezze</a:t>
-            </a:r>
-            <a:r>
-              <a:rPr lang="en-US" sz="1350" dirty="0">
-                <a:solidFill>
-                  <a:srgbClr val="CBD5E1"/>
-                </a:solidFill>
-                <a:latin typeface="Inter"/>
-                <a:ea typeface="Inter"/>
-                <a:cs typeface="Inter"/>
-                <a:sym typeface="Inter"/>
-              </a:rPr>
-              <a:t> diverse (come da 60 a 30 secondi)</a:t>
-            </a:r>
-            <a:r>
-              <a:rPr lang="en-US" sz="1350" b="0" i="0" u="none" strike="noStrike" cap="none" dirty="0">
-                <a:solidFill>
-                  <a:srgbClr val="CBD5E1"/>
-                </a:solidFill>
-                <a:latin typeface="Inter"/>
-                <a:ea typeface="Inter"/>
-                <a:cs typeface="Inter"/>
                 <a:sym typeface="Inter"/>
               </a:rPr>
               <a:t>.</a:t>
@@ -24332,8 +24387,9 @@
             <a:r>
               <a:rPr lang="en-US" sz="1500" b="0" i="0" u="none" strike="noStrike" cap="none" dirty="0" err="1">
                 <a:solidFill>
-                  <a:schemeClr val="bg1">
-                    <a:lumMod val="85000"/>
+                  <a:schemeClr val="bg2">
+                    <a:lumMod val="20000"/>
+                    <a:lumOff val="80000"/>
                   </a:schemeClr>
                 </a:solidFill>
                 <a:latin typeface="Inter"/>
@@ -24346,8 +24402,9 @@
             <a:r>
               <a:rPr lang="en-US" sz="1500" b="0" i="0" u="none" strike="noStrike" cap="none" dirty="0">
                 <a:solidFill>
-                  <a:schemeClr val="bg1">
-                    <a:lumMod val="85000"/>
+                  <a:schemeClr val="bg2">
+                    <a:lumMod val="20000"/>
+                    <a:lumOff val="80000"/>
                   </a:schemeClr>
                 </a:solidFill>
                 <a:latin typeface="Inter"/>
@@ -24360,8 +24417,9 @@
             <a:r>
               <a:rPr lang="en-US" sz="1500" b="0" i="0" u="none" strike="noStrike" cap="none" dirty="0" err="1">
                 <a:solidFill>
-                  <a:schemeClr val="bg1">
-                    <a:lumMod val="85000"/>
+                  <a:schemeClr val="bg2">
+                    <a:lumMod val="20000"/>
+                    <a:lumOff val="80000"/>
                   </a:schemeClr>
                 </a:solidFill>
                 <a:latin typeface="Inter"/>
@@ -24374,8 +24432,9 @@
             <a:r>
               <a:rPr lang="en-US" sz="1500" b="0" i="0" u="none" strike="noStrike" cap="none" dirty="0">
                 <a:solidFill>
-                  <a:schemeClr val="bg1">
-                    <a:lumMod val="85000"/>
+                  <a:schemeClr val="bg2">
+                    <a:lumMod val="20000"/>
+                    <a:lumOff val="80000"/>
                   </a:schemeClr>
                 </a:solidFill>
                 <a:latin typeface="Inter"/>
@@ -24388,8 +24447,9 @@
             <a:r>
               <a:rPr lang="en-US" sz="1500" b="0" i="0" u="none" strike="noStrike" cap="none" dirty="0" err="1">
                 <a:solidFill>
-                  <a:schemeClr val="bg1">
-                    <a:lumMod val="85000"/>
+                  <a:schemeClr val="bg2">
+                    <a:lumMod val="20000"/>
+                    <a:lumOff val="80000"/>
                   </a:schemeClr>
                 </a:solidFill>
                 <a:latin typeface="Inter"/>
@@ -24402,8 +24462,9 @@
             <a:r>
               <a:rPr lang="en-US" sz="1500" b="0" i="0" u="none" strike="noStrike" cap="none" dirty="0">
                 <a:solidFill>
-                  <a:schemeClr val="bg1">
-                    <a:lumMod val="85000"/>
+                  <a:schemeClr val="bg2">
+                    <a:lumMod val="20000"/>
+                    <a:lumOff val="80000"/>
                   </a:schemeClr>
                 </a:solidFill>
                 <a:latin typeface="Inter"/>
@@ -24416,8 +24477,9 @@
             <a:r>
               <a:rPr lang="en-US" sz="1500" b="0" i="0" u="none" strike="noStrike" cap="none" dirty="0" err="1">
                 <a:solidFill>
-                  <a:schemeClr val="bg1">
-                    <a:lumMod val="85000"/>
+                  <a:schemeClr val="bg2">
+                    <a:lumMod val="20000"/>
+                    <a:lumOff val="80000"/>
                   </a:schemeClr>
                 </a:solidFill>
                 <a:latin typeface="Inter"/>
@@ -24430,8 +24492,9 @@
             <a:r>
               <a:rPr lang="en-US" sz="1500" b="0" i="0" u="none" strike="noStrike" cap="none" dirty="0">
                 <a:solidFill>
-                  <a:schemeClr val="bg1">
-                    <a:lumMod val="85000"/>
+                  <a:schemeClr val="bg2">
+                    <a:lumMod val="20000"/>
+                    <a:lumOff val="80000"/>
                   </a:schemeClr>
                 </a:solidFill>
                 <a:latin typeface="Inter"/>
@@ -24444,8 +24507,9 @@
             <a:r>
               <a:rPr lang="en-US" sz="1500" b="0" i="0" u="none" strike="noStrike" cap="none" dirty="0" err="1">
                 <a:solidFill>
-                  <a:schemeClr val="bg1">
-                    <a:lumMod val="85000"/>
+                  <a:schemeClr val="bg2">
+                    <a:lumMod val="20000"/>
+                    <a:lumOff val="80000"/>
                   </a:schemeClr>
                 </a:solidFill>
                 <a:latin typeface="Inter"/>
@@ -24458,8 +24522,9 @@
             <a:r>
               <a:rPr lang="en-US" sz="1500" b="0" i="0" u="none" strike="noStrike" cap="none" dirty="0">
                 <a:solidFill>
-                  <a:schemeClr val="bg1">
-                    <a:lumMod val="85000"/>
+                  <a:schemeClr val="bg2">
+                    <a:lumMod val="20000"/>
+                    <a:lumOff val="80000"/>
                   </a:schemeClr>
                 </a:solidFill>
                 <a:latin typeface="Inter"/>
@@ -24472,8 +24537,9 @@
             <a:r>
               <a:rPr lang="en-US" sz="1500" b="0" i="0" u="none" strike="noStrike" cap="none" dirty="0" err="1">
                 <a:solidFill>
-                  <a:schemeClr val="bg1">
-                    <a:lumMod val="85000"/>
+                  <a:schemeClr val="bg2">
+                    <a:lumMod val="20000"/>
+                    <a:lumOff val="80000"/>
                   </a:schemeClr>
                 </a:solidFill>
                 <a:latin typeface="Inter"/>
@@ -24486,8 +24552,9 @@
             <a:r>
               <a:rPr lang="en-US" sz="1500" b="0" i="0" u="none" strike="noStrike" cap="none" dirty="0">
                 <a:solidFill>
-                  <a:schemeClr val="bg1">
-                    <a:lumMod val="85000"/>
+                  <a:schemeClr val="bg2">
+                    <a:lumMod val="20000"/>
+                    <a:lumOff val="80000"/>
                   </a:schemeClr>
                 </a:solidFill>
                 <a:latin typeface="Inter"/>
@@ -24500,8 +24567,9 @@
             <a:r>
               <a:rPr lang="en-US" sz="1500" b="0" i="0" u="none" strike="noStrike" cap="none" dirty="0" err="1">
                 <a:solidFill>
-                  <a:schemeClr val="bg1">
-                    <a:lumMod val="85000"/>
+                  <a:schemeClr val="bg2">
+                    <a:lumMod val="20000"/>
+                    <a:lumOff val="80000"/>
                   </a:schemeClr>
                 </a:solidFill>
                 <a:latin typeface="Inter"/>
@@ -24514,8 +24582,9 @@
             <a:r>
               <a:rPr lang="en-US" sz="1500" b="0" i="0" u="none" strike="noStrike" cap="none" dirty="0">
                 <a:solidFill>
-                  <a:schemeClr val="bg1">
-                    <a:lumMod val="85000"/>
+                  <a:schemeClr val="bg2">
+                    <a:lumMod val="20000"/>
+                    <a:lumOff val="80000"/>
                   </a:schemeClr>
                 </a:solidFill>
                 <a:latin typeface="Inter"/>
@@ -24527,8 +24596,9 @@
             </a:r>
             <a:endParaRPr dirty="0">
               <a:solidFill>
-                <a:schemeClr val="bg1">
-                  <a:lumMod val="85000"/>
+                <a:schemeClr val="bg2">
+                  <a:lumMod val="20000"/>
+                  <a:lumOff val="80000"/>
                 </a:schemeClr>
               </a:solidFill>
             </a:endParaRPr>
@@ -24635,8 +24705,9 @@
             <a:r>
               <a:rPr lang="en-US" sz="1500" b="0" i="0" u="none" strike="noStrike" cap="none" dirty="0" err="1">
                 <a:solidFill>
-                  <a:schemeClr val="bg1">
-                    <a:lumMod val="85000"/>
+                  <a:schemeClr val="bg2">
+                    <a:lumMod val="20000"/>
+                    <a:lumOff val="80000"/>
                   </a:schemeClr>
                 </a:solidFill>
                 <a:latin typeface="Inter"/>
@@ -24649,8 +24720,9 @@
             <a:r>
               <a:rPr lang="en-US" sz="1500" b="0" i="0" u="none" strike="noStrike" cap="none" dirty="0">
                 <a:solidFill>
-                  <a:schemeClr val="bg1">
-                    <a:lumMod val="85000"/>
+                  <a:schemeClr val="bg2">
+                    <a:lumMod val="20000"/>
+                    <a:lumOff val="80000"/>
                   </a:schemeClr>
                 </a:solidFill>
                 <a:latin typeface="Inter"/>
@@ -24663,8 +24735,9 @@
             <a:r>
               <a:rPr lang="en-US" sz="1500" b="0" i="0" u="none" strike="noStrike" cap="none" dirty="0" err="1">
                 <a:solidFill>
-                  <a:schemeClr val="bg1">
-                    <a:lumMod val="85000"/>
+                  <a:schemeClr val="bg2">
+                    <a:lumMod val="20000"/>
+                    <a:lumOff val="80000"/>
                   </a:schemeClr>
                 </a:solidFill>
                 <a:latin typeface="Inter"/>
@@ -24677,8 +24750,9 @@
             <a:r>
               <a:rPr lang="en-US" sz="1500" b="0" i="0" u="none" strike="noStrike" cap="none" dirty="0">
                 <a:solidFill>
-                  <a:schemeClr val="bg1">
-                    <a:lumMod val="85000"/>
+                  <a:schemeClr val="bg2">
+                    <a:lumMod val="20000"/>
+                    <a:lumOff val="80000"/>
                   </a:schemeClr>
                 </a:solidFill>
                 <a:latin typeface="Inter"/>
@@ -24691,8 +24765,9 @@
             <a:r>
               <a:rPr lang="en-US" sz="1500" b="0" i="0" u="none" strike="noStrike" cap="none" dirty="0" err="1">
                 <a:solidFill>
-                  <a:schemeClr val="bg1">
-                    <a:lumMod val="85000"/>
+                  <a:schemeClr val="bg2">
+                    <a:lumMod val="20000"/>
+                    <a:lumOff val="80000"/>
                   </a:schemeClr>
                 </a:solidFill>
                 <a:latin typeface="Inter"/>
@@ -24705,8 +24780,9 @@
             <a:r>
               <a:rPr lang="en-US" sz="1500" b="0" i="0" u="none" strike="noStrike" cap="none" dirty="0">
                 <a:solidFill>
-                  <a:schemeClr val="bg1">
-                    <a:lumMod val="85000"/>
+                  <a:schemeClr val="bg2">
+                    <a:lumMod val="20000"/>
+                    <a:lumOff val="80000"/>
                   </a:schemeClr>
                 </a:solidFill>
                 <a:latin typeface="Inter"/>
@@ -24719,8 +24795,9 @@
             <a:r>
               <a:rPr lang="en-US" sz="1500" b="0" i="0" u="none" strike="noStrike" cap="none" dirty="0" err="1">
                 <a:solidFill>
-                  <a:schemeClr val="bg1">
-                    <a:lumMod val="85000"/>
+                  <a:schemeClr val="bg2">
+                    <a:lumMod val="20000"/>
+                    <a:lumOff val="80000"/>
                   </a:schemeClr>
                 </a:solidFill>
                 <a:latin typeface="Inter"/>
@@ -24733,8 +24810,9 @@
             <a:r>
               <a:rPr lang="en-US" sz="1500" b="0" i="0" u="none" strike="noStrike" cap="none" dirty="0">
                 <a:solidFill>
-                  <a:schemeClr val="bg1">
-                    <a:lumMod val="85000"/>
+                  <a:schemeClr val="bg2">
+                    <a:lumMod val="20000"/>
+                    <a:lumOff val="80000"/>
                   </a:schemeClr>
                 </a:solidFill>
                 <a:latin typeface="Inter"/>
@@ -24747,8 +24825,9 @@
             <a:r>
               <a:rPr lang="en-US" sz="1500" b="0" i="0" u="none" strike="noStrike" cap="none" dirty="0" err="1">
                 <a:solidFill>
-                  <a:schemeClr val="bg1">
-                    <a:lumMod val="85000"/>
+                  <a:schemeClr val="bg2">
+                    <a:lumMod val="20000"/>
+                    <a:lumOff val="80000"/>
                   </a:schemeClr>
                 </a:solidFill>
                 <a:latin typeface="Inter"/>
@@ -24761,8 +24840,9 @@
             <a:r>
               <a:rPr lang="en-US" sz="1500" b="0" i="0" u="none" strike="noStrike" cap="none" dirty="0">
                 <a:solidFill>
-                  <a:schemeClr val="bg1">
-                    <a:lumMod val="85000"/>
+                  <a:schemeClr val="bg2">
+                    <a:lumMod val="20000"/>
+                    <a:lumOff val="80000"/>
                   </a:schemeClr>
                 </a:solidFill>
                 <a:latin typeface="Inter"/>
@@ -24775,8 +24855,9 @@
             <a:r>
               <a:rPr lang="en-US" sz="1500" b="0" i="0" u="none" strike="noStrike" cap="none" dirty="0" err="1">
                 <a:solidFill>
-                  <a:schemeClr val="bg1">
-                    <a:lumMod val="85000"/>
+                  <a:schemeClr val="bg2">
+                    <a:lumMod val="20000"/>
+                    <a:lumOff val="80000"/>
                   </a:schemeClr>
                 </a:solidFill>
                 <a:latin typeface="Inter"/>
@@ -24789,8 +24870,9 @@
             <a:r>
               <a:rPr lang="en-US" sz="1500" b="0" i="0" u="none" strike="noStrike" cap="none" dirty="0">
                 <a:solidFill>
-                  <a:schemeClr val="bg1">
-                    <a:lumMod val="85000"/>
+                  <a:schemeClr val="bg2">
+                    <a:lumMod val="20000"/>
+                    <a:lumOff val="80000"/>
                   </a:schemeClr>
                 </a:solidFill>
                 <a:latin typeface="Inter"/>
@@ -24803,8 +24885,9 @@
             <a:r>
               <a:rPr lang="en-US" sz="1500" b="0" i="0" u="none" strike="noStrike" cap="none" dirty="0" err="1">
                 <a:solidFill>
-                  <a:schemeClr val="bg1">
-                    <a:lumMod val="85000"/>
+                  <a:schemeClr val="bg2">
+                    <a:lumMod val="20000"/>
+                    <a:lumOff val="80000"/>
                   </a:schemeClr>
                 </a:solidFill>
                 <a:latin typeface="Inter"/>
@@ -24817,8 +24900,9 @@
             <a:r>
               <a:rPr lang="en-US" sz="1500" b="0" i="0" u="none" strike="noStrike" cap="none" dirty="0">
                 <a:solidFill>
-                  <a:schemeClr val="bg1">
-                    <a:lumMod val="85000"/>
+                  <a:schemeClr val="bg2">
+                    <a:lumMod val="20000"/>
+                    <a:lumOff val="80000"/>
                   </a:schemeClr>
                 </a:solidFill>
                 <a:latin typeface="Inter"/>
@@ -24831,8 +24915,9 @@
             <a:r>
               <a:rPr lang="en-US" sz="1500" b="0" i="0" u="none" strike="noStrike" cap="none" dirty="0" err="1">
                 <a:solidFill>
-                  <a:schemeClr val="bg1">
-                    <a:lumMod val="85000"/>
+                  <a:schemeClr val="bg2">
+                    <a:lumMod val="20000"/>
+                    <a:lumOff val="80000"/>
                   </a:schemeClr>
                 </a:solidFill>
                 <a:latin typeface="Inter"/>
@@ -24845,8 +24930,9 @@
             <a:r>
               <a:rPr lang="en-US" sz="1500" b="0" i="0" u="none" strike="noStrike" cap="none" dirty="0">
                 <a:solidFill>
-                  <a:schemeClr val="bg1">
-                    <a:lumMod val="85000"/>
+                  <a:schemeClr val="bg2">
+                    <a:lumMod val="20000"/>
+                    <a:lumOff val="80000"/>
                   </a:schemeClr>
                 </a:solidFill>
                 <a:latin typeface="Inter"/>
@@ -24859,8 +24945,9 @@
             <a:r>
               <a:rPr lang="en-US" sz="1500" b="0" i="0" u="none" strike="noStrike" cap="none" dirty="0" err="1">
                 <a:solidFill>
-                  <a:schemeClr val="bg1">
-                    <a:lumMod val="85000"/>
+                  <a:schemeClr val="bg2">
+                    <a:lumMod val="20000"/>
+                    <a:lumOff val="80000"/>
                   </a:schemeClr>
                 </a:solidFill>
                 <a:latin typeface="Inter"/>
@@ -24873,8 +24960,9 @@
             <a:r>
               <a:rPr lang="en-US" sz="1500" dirty="0">
                 <a:solidFill>
-                  <a:schemeClr val="bg1">
-                    <a:lumMod val="85000"/>
+                  <a:schemeClr val="bg2">
+                    <a:lumMod val="20000"/>
+                    <a:lumOff val="80000"/>
                   </a:schemeClr>
                 </a:solidFill>
                 <a:latin typeface="Inter"/>
@@ -24887,8 +24975,9 @@
             <a:r>
               <a:rPr lang="en-US" sz="1500" dirty="0" err="1">
                 <a:solidFill>
-                  <a:schemeClr val="bg1">
-                    <a:lumMod val="85000"/>
+                  <a:schemeClr val="bg2">
+                    <a:lumMod val="20000"/>
+                    <a:lumOff val="80000"/>
                   </a:schemeClr>
                 </a:solidFill>
                 <a:latin typeface="Inter"/>
@@ -24901,8 +24990,9 @@
             <a:r>
               <a:rPr lang="en-US" sz="1500" dirty="0">
                 <a:solidFill>
-                  <a:schemeClr val="bg1">
-                    <a:lumMod val="85000"/>
+                  <a:schemeClr val="bg2">
+                    <a:lumMod val="20000"/>
+                    <a:lumOff val="80000"/>
                   </a:schemeClr>
                 </a:solidFill>
                 <a:latin typeface="Inter"/>
@@ -24915,8 +25005,9 @@
             <a:r>
               <a:rPr lang="en-US" sz="1500" dirty="0" err="1">
                 <a:solidFill>
-                  <a:schemeClr val="bg1">
-                    <a:lumMod val="85000"/>
+                  <a:schemeClr val="bg2">
+                    <a:lumMod val="20000"/>
+                    <a:lumOff val="80000"/>
                   </a:schemeClr>
                 </a:solidFill>
                 <a:latin typeface="Inter"/>
@@ -24929,8 +25020,9 @@
             <a:r>
               <a:rPr lang="en-US" sz="1500" dirty="0">
                 <a:solidFill>
-                  <a:schemeClr val="bg1">
-                    <a:lumMod val="85000"/>
+                  <a:schemeClr val="bg2">
+                    <a:lumMod val="20000"/>
+                    <a:lumOff val="80000"/>
                   </a:schemeClr>
                 </a:solidFill>
                 <a:latin typeface="Inter"/>
@@ -24943,8 +25035,9 @@
             <a:r>
               <a:rPr lang="en-US" sz="1500" dirty="0" err="1">
                 <a:solidFill>
-                  <a:schemeClr val="bg1">
-                    <a:lumMod val="85000"/>
+                  <a:schemeClr val="bg2">
+                    <a:lumMod val="20000"/>
+                    <a:lumOff val="80000"/>
                   </a:schemeClr>
                 </a:solidFill>
                 <a:latin typeface="Inter"/>
@@ -24957,8 +25050,9 @@
             <a:r>
               <a:rPr lang="en-US" sz="1500" dirty="0">
                 <a:solidFill>
-                  <a:schemeClr val="bg1">
-                    <a:lumMod val="85000"/>
+                  <a:schemeClr val="bg2">
+                    <a:lumMod val="20000"/>
+                    <a:lumOff val="80000"/>
                   </a:schemeClr>
                 </a:solidFill>
                 <a:latin typeface="Inter"/>
@@ -24971,8 +25065,9 @@
             <a:r>
               <a:rPr lang="en-US" sz="1500" dirty="0" err="1">
                 <a:solidFill>
-                  <a:schemeClr val="bg1">
-                    <a:lumMod val="85000"/>
+                  <a:schemeClr val="bg2">
+                    <a:lumMod val="20000"/>
+                    <a:lumOff val="80000"/>
                   </a:schemeClr>
                 </a:solidFill>
                 <a:latin typeface="Inter"/>
@@ -24985,8 +25080,9 @@
             <a:r>
               <a:rPr lang="en-US" sz="1500" dirty="0">
                 <a:solidFill>
-                  <a:schemeClr val="bg1">
-                    <a:lumMod val="85000"/>
+                  <a:schemeClr val="bg2">
+                    <a:lumMod val="20000"/>
+                    <a:lumOff val="80000"/>
                   </a:schemeClr>
                 </a:solidFill>
                 <a:latin typeface="Inter"/>
@@ -24999,8 +25095,9 @@
             <a:r>
               <a:rPr lang="en-US" sz="1500" dirty="0" err="1">
                 <a:solidFill>
-                  <a:schemeClr val="bg1">
-                    <a:lumMod val="85000"/>
+                  <a:schemeClr val="bg2">
+                    <a:lumMod val="20000"/>
+                    <a:lumOff val="80000"/>
                   </a:schemeClr>
                 </a:solidFill>
                 <a:latin typeface="Inter"/>
@@ -25013,8 +25110,9 @@
             <a:r>
               <a:rPr lang="en-US" sz="1500" dirty="0">
                 <a:solidFill>
-                  <a:schemeClr val="bg1">
-                    <a:lumMod val="85000"/>
+                  <a:schemeClr val="bg2">
+                    <a:lumMod val="20000"/>
+                    <a:lumOff val="80000"/>
                   </a:schemeClr>
                 </a:solidFill>
                 <a:latin typeface="Inter"/>
@@ -25027,8 +25125,9 @@
             <a:r>
               <a:rPr lang="en-US" sz="1500" dirty="0" err="1">
                 <a:solidFill>
-                  <a:schemeClr val="bg1">
-                    <a:lumMod val="85000"/>
+                  <a:schemeClr val="bg2">
+                    <a:lumMod val="20000"/>
+                    <a:lumOff val="80000"/>
                   </a:schemeClr>
                 </a:solidFill>
                 <a:latin typeface="Inter"/>
@@ -25041,8 +25140,9 @@
             <a:r>
               <a:rPr lang="en-US" sz="1500" dirty="0">
                 <a:solidFill>
-                  <a:schemeClr val="bg1">
-                    <a:lumMod val="85000"/>
+                  <a:schemeClr val="bg2">
+                    <a:lumMod val="20000"/>
+                    <a:lumOff val="80000"/>
                   </a:schemeClr>
                 </a:solidFill>
                 <a:latin typeface="Inter"/>
@@ -25055,8 +25155,9 @@
             <a:r>
               <a:rPr lang="en-US" sz="1500" dirty="0" err="1">
                 <a:solidFill>
-                  <a:schemeClr val="bg1">
-                    <a:lumMod val="85000"/>
+                  <a:schemeClr val="bg2">
+                    <a:lumMod val="20000"/>
+                    <a:lumOff val="80000"/>
                   </a:schemeClr>
                 </a:solidFill>
                 <a:latin typeface="Inter"/>
@@ -25069,8 +25170,9 @@
             <a:r>
               <a:rPr lang="en-US" sz="1500" dirty="0">
                 <a:solidFill>
-                  <a:schemeClr val="bg1">
-                    <a:lumMod val="85000"/>
+                  <a:schemeClr val="bg2">
+                    <a:lumMod val="20000"/>
+                    <a:lumOff val="80000"/>
                   </a:schemeClr>
                 </a:solidFill>
                 <a:latin typeface="Inter"/>
@@ -25083,8 +25185,9 @@
             <a:r>
               <a:rPr lang="en-US" sz="1500" dirty="0" err="1">
                 <a:solidFill>
-                  <a:schemeClr val="bg1">
-                    <a:lumMod val="85000"/>
+                  <a:schemeClr val="bg2">
+                    <a:lumMod val="20000"/>
+                    <a:lumOff val="80000"/>
                   </a:schemeClr>
                 </a:solidFill>
                 <a:latin typeface="Inter"/>
@@ -25097,8 +25200,9 @@
             <a:r>
               <a:rPr lang="en-US" sz="1500" dirty="0">
                 <a:solidFill>
-                  <a:schemeClr val="bg1">
-                    <a:lumMod val="85000"/>
+                  <a:schemeClr val="bg2">
+                    <a:lumMod val="20000"/>
+                    <a:lumOff val="80000"/>
                   </a:schemeClr>
                 </a:solidFill>
                 <a:latin typeface="Inter"/>
@@ -25111,8 +25215,9 @@
             <a:r>
               <a:rPr lang="en-US" sz="1500" dirty="0" err="1">
                 <a:solidFill>
-                  <a:schemeClr val="bg1">
-                    <a:lumMod val="85000"/>
+                  <a:schemeClr val="bg2">
+                    <a:lumMod val="20000"/>
+                    <a:lumOff val="80000"/>
                   </a:schemeClr>
                 </a:solidFill>
                 <a:latin typeface="Inter"/>
@@ -25125,8 +25230,9 @@
             <a:r>
               <a:rPr lang="en-US" sz="1500" dirty="0">
                 <a:solidFill>
-                  <a:schemeClr val="bg1">
-                    <a:lumMod val="85000"/>
+                  <a:schemeClr val="bg2">
+                    <a:lumMod val="20000"/>
+                    <a:lumOff val="80000"/>
                   </a:schemeClr>
                 </a:solidFill>
                 <a:latin typeface="Inter"/>
@@ -25139,8 +25245,9 @@
             <a:r>
               <a:rPr lang="en-US" sz="1500" dirty="0" err="1">
                 <a:solidFill>
-                  <a:schemeClr val="bg1">
-                    <a:lumMod val="85000"/>
+                  <a:schemeClr val="bg2">
+                    <a:lumMod val="20000"/>
+                    <a:lumOff val="80000"/>
                   </a:schemeClr>
                 </a:solidFill>
                 <a:latin typeface="Inter"/>
@@ -25153,8 +25260,9 @@
             <a:r>
               <a:rPr lang="en-US" sz="1500" dirty="0">
                 <a:solidFill>
-                  <a:schemeClr val="bg1">
-                    <a:lumMod val="85000"/>
+                  <a:schemeClr val="bg2">
+                    <a:lumMod val="20000"/>
+                    <a:lumOff val="80000"/>
                   </a:schemeClr>
                 </a:solidFill>
                 <a:latin typeface="Inter"/>
@@ -25167,8 +25275,9 @@
             <a:r>
               <a:rPr lang="en-US" sz="1500" dirty="0" err="1">
                 <a:solidFill>
-                  <a:schemeClr val="bg1">
-                    <a:lumMod val="85000"/>
+                  <a:schemeClr val="bg2">
+                    <a:lumMod val="20000"/>
+                    <a:lumOff val="80000"/>
                   </a:schemeClr>
                 </a:solidFill>
                 <a:latin typeface="Inter"/>
@@ -25181,8 +25290,9 @@
             <a:r>
               <a:rPr lang="en-US" sz="1500" dirty="0">
                 <a:solidFill>
-                  <a:schemeClr val="bg1">
-                    <a:lumMod val="85000"/>
+                  <a:schemeClr val="bg2">
+                    <a:lumMod val="20000"/>
+                    <a:lumOff val="80000"/>
                   </a:schemeClr>
                 </a:solidFill>
                 <a:latin typeface="Inter"/>
@@ -25195,8 +25305,9 @@
             <a:r>
               <a:rPr lang="en-US" sz="1500" dirty="0" err="1">
                 <a:solidFill>
-                  <a:schemeClr val="bg1">
-                    <a:lumMod val="85000"/>
+                  <a:schemeClr val="bg2">
+                    <a:lumMod val="20000"/>
+                    <a:lumOff val="80000"/>
                   </a:schemeClr>
                 </a:solidFill>
                 <a:latin typeface="Inter"/>
@@ -25209,8 +25320,9 @@
             <a:r>
               <a:rPr lang="en-US" sz="1500" dirty="0">
                 <a:solidFill>
-                  <a:schemeClr val="bg1">
-                    <a:lumMod val="85000"/>
+                  <a:schemeClr val="bg2">
+                    <a:lumMod val="20000"/>
+                    <a:lumOff val="80000"/>
                   </a:schemeClr>
                 </a:solidFill>
                 <a:latin typeface="Inter"/>
@@ -25223,8 +25335,9 @@
             <a:r>
               <a:rPr lang="en-US" sz="1500" dirty="0" err="1">
                 <a:solidFill>
-                  <a:schemeClr val="bg1">
-                    <a:lumMod val="85000"/>
+                  <a:schemeClr val="bg2">
+                    <a:lumMod val="20000"/>
+                    <a:lumOff val="80000"/>
                   </a:schemeClr>
                 </a:solidFill>
                 <a:latin typeface="Inter"/>
@@ -25237,8 +25350,9 @@
             <a:r>
               <a:rPr lang="en-US" sz="1500" dirty="0">
                 <a:solidFill>
-                  <a:schemeClr val="bg1">
-                    <a:lumMod val="85000"/>
+                  <a:schemeClr val="bg2">
+                    <a:lumMod val="20000"/>
+                    <a:lumOff val="80000"/>
                   </a:schemeClr>
                 </a:solidFill>
                 <a:latin typeface="Inter"/>
@@ -25251,8 +25365,9 @@
             <a:r>
               <a:rPr lang="en-US" sz="1500" dirty="0" err="1">
                 <a:solidFill>
-                  <a:schemeClr val="bg1">
-                    <a:lumMod val="85000"/>
+                  <a:schemeClr val="bg2">
+                    <a:lumMod val="20000"/>
+                    <a:lumOff val="80000"/>
                   </a:schemeClr>
                 </a:solidFill>
                 <a:latin typeface="Inter"/>
@@ -25265,8 +25380,9 @@
             <a:r>
               <a:rPr lang="en-US" sz="1500" dirty="0">
                 <a:solidFill>
-                  <a:schemeClr val="bg1">
-                    <a:lumMod val="85000"/>
+                  <a:schemeClr val="bg2">
+                    <a:lumMod val="20000"/>
+                    <a:lumOff val="80000"/>
                   </a:schemeClr>
                 </a:solidFill>
                 <a:latin typeface="Inter"/>
@@ -25279,8 +25395,9 @@
             <a:r>
               <a:rPr lang="en-US" sz="1500" dirty="0" err="1">
                 <a:solidFill>
-                  <a:schemeClr val="bg1">
-                    <a:lumMod val="85000"/>
+                  <a:schemeClr val="bg2">
+                    <a:lumMod val="20000"/>
+                    <a:lumOff val="80000"/>
                   </a:schemeClr>
                 </a:solidFill>
                 <a:latin typeface="Inter"/>
@@ -25293,8 +25410,9 @@
             <a:r>
               <a:rPr lang="en-US" sz="1500" dirty="0">
                 <a:solidFill>
-                  <a:schemeClr val="bg1">
-                    <a:lumMod val="85000"/>
+                  <a:schemeClr val="bg2">
+                    <a:lumMod val="20000"/>
+                    <a:lumOff val="80000"/>
                   </a:schemeClr>
                 </a:solidFill>
                 <a:latin typeface="Inter"/>
@@ -25307,8 +25425,9 @@
             <a:r>
               <a:rPr lang="en-US" sz="1500" dirty="0" err="1">
                 <a:solidFill>
-                  <a:schemeClr val="bg1">
-                    <a:lumMod val="85000"/>
+                  <a:schemeClr val="bg2">
+                    <a:lumMod val="20000"/>
+                    <a:lumOff val="80000"/>
                   </a:schemeClr>
                 </a:solidFill>
                 <a:latin typeface="Inter"/>
@@ -25321,8 +25440,9 @@
             <a:r>
               <a:rPr lang="en-US" sz="1500" dirty="0">
                 <a:solidFill>
-                  <a:schemeClr val="bg1">
-                    <a:lumMod val="85000"/>
+                  <a:schemeClr val="bg2">
+                    <a:lumMod val="20000"/>
+                    <a:lumOff val="80000"/>
                   </a:schemeClr>
                 </a:solidFill>
                 <a:latin typeface="Inter"/>
@@ -25335,8 +25455,9 @@
             <a:r>
               <a:rPr lang="en-US" sz="1500" b="0" i="0" u="none" strike="noStrike" cap="none" dirty="0">
                 <a:solidFill>
-                  <a:schemeClr val="bg1">
-                    <a:lumMod val="85000"/>
+                  <a:schemeClr val="bg2">
+                    <a:lumMod val="20000"/>
+                    <a:lumOff val="80000"/>
                   </a:schemeClr>
                 </a:solidFill>
                 <a:latin typeface="Inter"/>
@@ -25348,8 +25469,9 @@
             </a:r>
             <a:endParaRPr dirty="0">
               <a:solidFill>
-                <a:schemeClr val="bg1">
-                  <a:lumMod val="85000"/>
+                <a:schemeClr val="bg2">
+                  <a:lumMod val="20000"/>
+                  <a:lumOff val="80000"/>
                 </a:schemeClr>
               </a:solidFill>
             </a:endParaRPr>
@@ -25468,8 +25590,9 @@
             <a:r>
               <a:rPr lang="en-US" sz="1500" b="0" i="0" u="none" strike="noStrike" cap="none" dirty="0" err="1">
                 <a:solidFill>
-                  <a:schemeClr val="bg1">
-                    <a:lumMod val="85000"/>
+                  <a:schemeClr val="bg2">
+                    <a:lumMod val="20000"/>
+                    <a:lumOff val="80000"/>
                   </a:schemeClr>
                 </a:solidFill>
                 <a:latin typeface="Inter"/>
@@ -25482,8 +25605,9 @@
             <a:r>
               <a:rPr lang="en-US" sz="1500" b="0" i="0" u="none" strike="noStrike" cap="none" dirty="0">
                 <a:solidFill>
-                  <a:schemeClr val="bg1">
-                    <a:lumMod val="85000"/>
+                  <a:schemeClr val="bg2">
+                    <a:lumMod val="20000"/>
+                    <a:lumOff val="80000"/>
                   </a:schemeClr>
                 </a:solidFill>
                 <a:latin typeface="Inter"/>
@@ -25496,8 +25620,9 @@
             <a:r>
               <a:rPr lang="en-US" sz="1500" b="0" i="0" u="none" strike="noStrike" cap="none" dirty="0" err="1">
                 <a:solidFill>
-                  <a:schemeClr val="bg1">
-                    <a:lumMod val="85000"/>
+                  <a:schemeClr val="bg2">
+                    <a:lumMod val="20000"/>
+                    <a:lumOff val="80000"/>
                   </a:schemeClr>
                 </a:solidFill>
                 <a:latin typeface="Inter"/>
@@ -25510,8 +25635,9 @@
             <a:r>
               <a:rPr lang="en-US" sz="1500" b="0" i="0" u="none" strike="noStrike" cap="none" dirty="0">
                 <a:solidFill>
-                  <a:schemeClr val="bg1">
-                    <a:lumMod val="85000"/>
+                  <a:schemeClr val="bg2">
+                    <a:lumMod val="20000"/>
+                    <a:lumOff val="80000"/>
                   </a:schemeClr>
                 </a:solidFill>
                 <a:latin typeface="Inter"/>
@@ -25524,8 +25650,9 @@
             <a:r>
               <a:rPr lang="en-US" sz="1500" b="0" i="0" u="none" strike="noStrike" cap="none" dirty="0" err="1">
                 <a:solidFill>
-                  <a:schemeClr val="bg1">
-                    <a:lumMod val="85000"/>
+                  <a:schemeClr val="bg2">
+                    <a:lumMod val="20000"/>
+                    <a:lumOff val="80000"/>
                   </a:schemeClr>
                 </a:solidFill>
                 <a:latin typeface="Inter"/>
@@ -25538,8 +25665,9 @@
             <a:r>
               <a:rPr lang="en-US" sz="1500" b="0" i="0" u="none" strike="noStrike" cap="none" dirty="0">
                 <a:solidFill>
-                  <a:schemeClr val="bg1">
-                    <a:lumMod val="85000"/>
+                  <a:schemeClr val="bg2">
+                    <a:lumMod val="20000"/>
+                    <a:lumOff val="80000"/>
                   </a:schemeClr>
                 </a:solidFill>
                 <a:latin typeface="Inter"/>
@@ -25552,8 +25680,9 @@
             <a:r>
               <a:rPr lang="en-US" sz="1500" b="0" i="0" u="none" strike="noStrike" cap="none" dirty="0" err="1">
                 <a:solidFill>
-                  <a:schemeClr val="bg1">
-                    <a:lumMod val="85000"/>
+                  <a:schemeClr val="bg2">
+                    <a:lumMod val="20000"/>
+                    <a:lumOff val="80000"/>
                   </a:schemeClr>
                 </a:solidFill>
                 <a:latin typeface="Inter"/>
@@ -25566,8 +25695,9 @@
             <a:r>
               <a:rPr lang="en-US" sz="1500" b="0" i="0" u="none" strike="noStrike" cap="none" dirty="0">
                 <a:solidFill>
-                  <a:schemeClr val="bg1">
-                    <a:lumMod val="85000"/>
+                  <a:schemeClr val="bg2">
+                    <a:lumMod val="20000"/>
+                    <a:lumOff val="80000"/>
                   </a:schemeClr>
                 </a:solidFill>
                 <a:latin typeface="Inter"/>
@@ -25580,8 +25710,9 @@
             <a:r>
               <a:rPr lang="en-US" sz="1500" b="0" i="0" u="none" strike="noStrike" cap="none" dirty="0" err="1">
                 <a:solidFill>
-                  <a:schemeClr val="bg1">
-                    <a:lumMod val="85000"/>
+                  <a:schemeClr val="bg2">
+                    <a:lumMod val="20000"/>
+                    <a:lumOff val="80000"/>
                   </a:schemeClr>
                 </a:solidFill>
                 <a:latin typeface="Inter"/>
@@ -25594,8 +25725,9 @@
             <a:r>
               <a:rPr lang="en-US" sz="1500" b="0" i="0" u="none" strike="noStrike" cap="none" dirty="0">
                 <a:solidFill>
-                  <a:schemeClr val="bg1">
-                    <a:lumMod val="85000"/>
+                  <a:schemeClr val="bg2">
+                    <a:lumMod val="20000"/>
+                    <a:lumOff val="80000"/>
                   </a:schemeClr>
                 </a:solidFill>
                 <a:latin typeface="Inter"/>
@@ -25608,8 +25740,9 @@
             <a:r>
               <a:rPr lang="en-US" sz="1500" b="0" i="0" u="none" strike="noStrike" cap="none" dirty="0" err="1">
                 <a:solidFill>
-                  <a:schemeClr val="bg1">
-                    <a:lumMod val="85000"/>
+                  <a:schemeClr val="bg2">
+                    <a:lumMod val="20000"/>
+                    <a:lumOff val="80000"/>
                   </a:schemeClr>
                 </a:solidFill>
                 <a:latin typeface="Inter"/>
@@ -25622,8 +25755,9 @@
             <a:r>
               <a:rPr lang="en-US" sz="1500" b="0" i="0" u="none" strike="noStrike" cap="none" dirty="0">
                 <a:solidFill>
-                  <a:schemeClr val="bg1">
-                    <a:lumMod val="85000"/>
+                  <a:schemeClr val="bg2">
+                    <a:lumMod val="20000"/>
+                    <a:lumOff val="80000"/>
                   </a:schemeClr>
                 </a:solidFill>
                 <a:latin typeface="Inter"/>
@@ -25636,8 +25770,9 @@
             <a:r>
               <a:rPr lang="en-US" sz="1500" b="0" i="0" u="none" strike="noStrike" cap="none" dirty="0" err="1">
                 <a:solidFill>
-                  <a:schemeClr val="bg1">
-                    <a:lumMod val="85000"/>
+                  <a:schemeClr val="bg2">
+                    <a:lumMod val="20000"/>
+                    <a:lumOff val="80000"/>
                   </a:schemeClr>
                 </a:solidFill>
                 <a:latin typeface="Inter"/>
@@ -25650,8 +25785,9 @@
             <a:r>
               <a:rPr lang="en-US" sz="1500" b="0" i="0" u="none" strike="noStrike" cap="none" dirty="0">
                 <a:solidFill>
-                  <a:schemeClr val="bg1">
-                    <a:lumMod val="85000"/>
+                  <a:schemeClr val="bg2">
+                    <a:lumMod val="20000"/>
+                    <a:lumOff val="80000"/>
                   </a:schemeClr>
                 </a:solidFill>
                 <a:latin typeface="Inter"/>
@@ -25664,8 +25800,9 @@
             <a:r>
               <a:rPr lang="en-US" sz="1500" b="0" i="0" u="none" strike="noStrike" cap="none" dirty="0" err="1">
                 <a:solidFill>
-                  <a:schemeClr val="bg1">
-                    <a:lumMod val="85000"/>
+                  <a:schemeClr val="bg2">
+                    <a:lumMod val="20000"/>
+                    <a:lumOff val="80000"/>
                   </a:schemeClr>
                 </a:solidFill>
                 <a:latin typeface="Inter"/>
@@ -25678,8 +25815,9 @@
             <a:r>
               <a:rPr lang="en-US" sz="1500" b="0" i="0" u="none" strike="noStrike" cap="none" dirty="0">
                 <a:solidFill>
-                  <a:schemeClr val="bg1">
-                    <a:lumMod val="85000"/>
+                  <a:schemeClr val="bg2">
+                    <a:lumMod val="20000"/>
+                    <a:lumOff val="80000"/>
                   </a:schemeClr>
                 </a:solidFill>
                 <a:latin typeface="Inter"/>
@@ -25692,8 +25830,9 @@
             <a:r>
               <a:rPr lang="en-US" sz="1500" b="0" i="0" u="none" strike="noStrike" cap="none" dirty="0" err="1">
                 <a:solidFill>
-                  <a:schemeClr val="bg1">
-                    <a:lumMod val="85000"/>
+                  <a:schemeClr val="bg2">
+                    <a:lumMod val="20000"/>
+                    <a:lumOff val="80000"/>
                   </a:schemeClr>
                 </a:solidFill>
                 <a:latin typeface="Inter"/>
@@ -25706,8 +25845,9 @@
             <a:r>
               <a:rPr lang="en-US" sz="1500" b="0" i="0" u="none" strike="noStrike" cap="none" dirty="0">
                 <a:solidFill>
-                  <a:schemeClr val="bg1">
-                    <a:lumMod val="85000"/>
+                  <a:schemeClr val="bg2">
+                    <a:lumMod val="20000"/>
+                    <a:lumOff val="80000"/>
                   </a:schemeClr>
                 </a:solidFill>
                 <a:latin typeface="Inter"/>
@@ -25719,8 +25859,9 @@
             </a:r>
             <a:endParaRPr dirty="0">
               <a:solidFill>
-                <a:schemeClr val="bg1">
-                  <a:lumMod val="85000"/>
+                <a:schemeClr val="bg2">
+                  <a:lumMod val="20000"/>
+                  <a:lumOff val="80000"/>
                 </a:schemeClr>
               </a:solidFill>
             </a:endParaRPr>
@@ -25791,8 +25932,9 @@
             <a:r>
               <a:rPr lang="en-US" sz="1500" dirty="0" err="1">
                 <a:solidFill>
-                  <a:schemeClr val="bg1">
-                    <a:lumMod val="85000"/>
+                  <a:schemeClr val="bg2">
+                    <a:lumMod val="20000"/>
+                    <a:lumOff val="80000"/>
                   </a:schemeClr>
                 </a:solidFill>
                 <a:latin typeface="Inter"/>
@@ -25805,8 +25947,9 @@
             <a:r>
               <a:rPr lang="en-US" sz="1500" dirty="0">
                 <a:solidFill>
-                  <a:schemeClr val="bg1">
-                    <a:lumMod val="85000"/>
+                  <a:schemeClr val="bg2">
+                    <a:lumMod val="20000"/>
+                    <a:lumOff val="80000"/>
                   </a:schemeClr>
                 </a:solidFill>
                 <a:latin typeface="Inter"/>
@@ -25819,8 +25962,9 @@
             <a:r>
               <a:rPr lang="en-US" sz="1500" dirty="0" err="1">
                 <a:solidFill>
-                  <a:schemeClr val="bg1">
-                    <a:lumMod val="85000"/>
+                  <a:schemeClr val="bg2">
+                    <a:lumMod val="20000"/>
+                    <a:lumOff val="80000"/>
                   </a:schemeClr>
                 </a:solidFill>
                 <a:latin typeface="Inter"/>
@@ -25833,8 +25977,9 @@
             <a:r>
               <a:rPr lang="en-US" sz="1500" dirty="0">
                 <a:solidFill>
-                  <a:schemeClr val="bg1">
-                    <a:lumMod val="85000"/>
+                  <a:schemeClr val="bg2">
+                    <a:lumMod val="20000"/>
+                    <a:lumOff val="80000"/>
                   </a:schemeClr>
                 </a:solidFill>
                 <a:latin typeface="Inter"/>
@@ -25847,8 +25992,9 @@
             <a:r>
               <a:rPr lang="en-US" sz="1500" dirty="0" err="1">
                 <a:solidFill>
-                  <a:schemeClr val="bg1">
-                    <a:lumMod val="85000"/>
+                  <a:schemeClr val="bg2">
+                    <a:lumMod val="20000"/>
+                    <a:lumOff val="80000"/>
                   </a:schemeClr>
                 </a:solidFill>
                 <a:latin typeface="Inter"/>
@@ -25861,8 +26007,9 @@
             <a:r>
               <a:rPr lang="en-US" sz="1500" dirty="0">
                 <a:solidFill>
-                  <a:schemeClr val="bg1">
-                    <a:lumMod val="85000"/>
+                  <a:schemeClr val="bg2">
+                    <a:lumMod val="20000"/>
+                    <a:lumOff val="80000"/>
                   </a:schemeClr>
                 </a:solidFill>
                 <a:latin typeface="Inter"/>
@@ -25875,8 +26022,9 @@
             <a:r>
               <a:rPr lang="en-US" sz="1500" b="0" i="0" u="none" strike="noStrike" cap="none" dirty="0">
                 <a:solidFill>
-                  <a:schemeClr val="bg1">
-                    <a:lumMod val="85000"/>
+                  <a:schemeClr val="bg2">
+                    <a:lumMod val="20000"/>
+                    <a:lumOff val="80000"/>
                   </a:schemeClr>
                 </a:solidFill>
                 <a:latin typeface="Inter"/>
@@ -25889,8 +26037,9 @@
             <a:r>
               <a:rPr lang="en-US" sz="1500" b="0" i="0" u="none" strike="noStrike" cap="none" dirty="0" err="1">
                 <a:solidFill>
-                  <a:schemeClr val="bg1">
-                    <a:lumMod val="85000"/>
+                  <a:schemeClr val="bg2">
+                    <a:lumMod val="20000"/>
+                    <a:lumOff val="80000"/>
                   </a:schemeClr>
                 </a:solidFill>
                 <a:latin typeface="Inter"/>
@@ -25903,8 +26052,9 @@
             <a:r>
               <a:rPr lang="en-US" sz="1500" b="0" i="0" u="none" strike="noStrike" cap="none" dirty="0">
                 <a:solidFill>
-                  <a:schemeClr val="bg1">
-                    <a:lumMod val="85000"/>
+                  <a:schemeClr val="bg2">
+                    <a:lumMod val="20000"/>
+                    <a:lumOff val="80000"/>
                   </a:schemeClr>
                 </a:solidFill>
                 <a:latin typeface="Inter"/>
@@ -25917,8 +26067,9 @@
             <a:r>
               <a:rPr lang="en-US" sz="1500" b="0" i="0" u="none" strike="noStrike" cap="none" dirty="0" err="1">
                 <a:solidFill>
-                  <a:schemeClr val="bg1">
-                    <a:lumMod val="85000"/>
+                  <a:schemeClr val="bg2">
+                    <a:lumMod val="20000"/>
+                    <a:lumOff val="80000"/>
                   </a:schemeClr>
                 </a:solidFill>
                 <a:latin typeface="Inter"/>
@@ -25931,8 +26082,9 @@
             <a:r>
               <a:rPr lang="en-US" sz="1500" b="0" i="0" u="none" strike="noStrike" cap="none" dirty="0">
                 <a:solidFill>
-                  <a:schemeClr val="bg1">
-                    <a:lumMod val="85000"/>
+                  <a:schemeClr val="bg2">
+                    <a:lumMod val="20000"/>
+                    <a:lumOff val="80000"/>
                   </a:schemeClr>
                 </a:solidFill>
                 <a:latin typeface="Inter"/>
@@ -25944,8 +26096,9 @@
             </a:r>
             <a:endParaRPr dirty="0">
               <a:solidFill>
-                <a:schemeClr val="bg1">
-                  <a:lumMod val="85000"/>
+                <a:schemeClr val="bg2">
+                  <a:lumMod val="20000"/>
+                  <a:lumOff val="80000"/>
                 </a:schemeClr>
               </a:solidFill>
             </a:endParaRPr>
@@ -25967,7 +26120,7 @@
         </p:blipFill>
         <p:spPr>
           <a:xfrm>
-            <a:off x="1333500" y="2395537"/>
+            <a:off x="1333350" y="2455307"/>
             <a:ext cx="266700" cy="276225"/>
           </a:xfrm>
           <a:prstGeom prst="rect">
@@ -25994,7 +26147,7 @@
         </p:blipFill>
         <p:spPr>
           <a:xfrm>
-            <a:off x="1333500" y="2938462"/>
+            <a:off x="1333350" y="3017043"/>
             <a:ext cx="266700" cy="276225"/>
           </a:xfrm>
           <a:prstGeom prst="rect">
@@ -26021,7 +26174,7 @@
         </p:blipFill>
         <p:spPr>
           <a:xfrm>
-            <a:off x="1333350" y="4491037"/>
+            <a:off x="1329902" y="4550807"/>
             <a:ext cx="304800" cy="276225"/>
           </a:xfrm>
           <a:prstGeom prst="rect">
@@ -26048,7 +26201,7 @@
         </p:blipFill>
         <p:spPr>
           <a:xfrm>
-            <a:off x="1333350" y="5338762"/>
+            <a:off x="1329902" y="5398532"/>
             <a:ext cx="333375" cy="276225"/>
           </a:xfrm>
           <a:prstGeom prst="rect">

</xml_diff>

<commit_message>
Changelogs: - Aggiornate le slides. - Aggiornate le immagini, - Altre modifiche generali.
</commit_message>
<xml_diff>
--- a/Progetto Interfacce Uomo-Macchina.pptx
+++ b/Progetto Interfacce Uomo-Macchina.pptx
@@ -5,7 +5,7 @@
     <p:sldMasterId id="2147483659" r:id="rId1"/>
   </p:sldMasterIdLst>
   <p:notesMasterIdLst>
-    <p:notesMasterId r:id="rId14"/>
+    <p:notesMasterId r:id="rId15"/>
   </p:notesMasterIdLst>
   <p:sldIdLst>
     <p:sldId id="256" r:id="rId2"/>
@@ -18,46 +18,47 @@
     <p:sldId id="264" r:id="rId9"/>
     <p:sldId id="270" r:id="rId10"/>
     <p:sldId id="271" r:id="rId11"/>
-    <p:sldId id="266" r:id="rId12"/>
-    <p:sldId id="269" r:id="rId13"/>
+    <p:sldId id="272" r:id="rId12"/>
+    <p:sldId id="266" r:id="rId13"/>
+    <p:sldId id="269" r:id="rId14"/>
   </p:sldIdLst>
   <p:sldSz cx="12192000" cy="6858000"/>
   <p:notesSz cx="6858000" cy="9144000"/>
   <p:embeddedFontLst>
     <p:embeddedFont>
       <p:font typeface="Inter" panose="020B0604020202020204" charset="0"/>
-      <p:regular r:id="rId15"/>
-      <p:bold r:id="rId16"/>
-      <p:italic r:id="rId17"/>
-      <p:boldItalic r:id="rId18"/>
+      <p:regular r:id="rId16"/>
+      <p:bold r:id="rId17"/>
+      <p:italic r:id="rId18"/>
+      <p:boldItalic r:id="rId19"/>
     </p:embeddedFont>
     <p:embeddedFont>
       <p:font typeface="Inter SemiBold" panose="020B0604020202020204" charset="0"/>
-      <p:regular r:id="rId19"/>
-      <p:bold r:id="rId20"/>
-      <p:italic r:id="rId21"/>
-      <p:boldItalic r:id="rId22"/>
+      <p:regular r:id="rId20"/>
+      <p:bold r:id="rId21"/>
+      <p:italic r:id="rId22"/>
+      <p:boldItalic r:id="rId23"/>
     </p:embeddedFont>
     <p:embeddedFont>
       <p:font typeface="Poppins" panose="00000500000000000000" pitchFamily="2" charset="0"/>
-      <p:regular r:id="rId23"/>
-      <p:bold r:id="rId24"/>
-      <p:italic r:id="rId25"/>
-      <p:boldItalic r:id="rId26"/>
+      <p:regular r:id="rId24"/>
+      <p:bold r:id="rId25"/>
+      <p:italic r:id="rId26"/>
+      <p:boldItalic r:id="rId27"/>
     </p:embeddedFont>
     <p:embeddedFont>
       <p:font typeface="Poppins Medium" panose="00000600000000000000" pitchFamily="2" charset="0"/>
-      <p:regular r:id="rId27"/>
-      <p:bold r:id="rId28"/>
-      <p:italic r:id="rId29"/>
-      <p:boldItalic r:id="rId30"/>
+      <p:regular r:id="rId28"/>
+      <p:bold r:id="rId29"/>
+      <p:italic r:id="rId30"/>
+      <p:boldItalic r:id="rId31"/>
     </p:embeddedFont>
     <p:embeddedFont>
       <p:font typeface="Poppins SemiBold" panose="00000700000000000000" pitchFamily="2" charset="0"/>
-      <p:regular r:id="rId31"/>
-      <p:bold r:id="rId32"/>
-      <p:italic r:id="rId33"/>
-      <p:boldItalic r:id="rId34"/>
+      <p:regular r:id="rId32"/>
+      <p:bold r:id="rId33"/>
+      <p:italic r:id="rId34"/>
+      <p:boldItalic r:id="rId35"/>
     </p:embeddedFont>
   </p:embeddedFontLst>
   <p:defaultTextStyle>
@@ -985,6 +986,133 @@
   <p:cSld>
     <p:spTree>
       <p:nvGrpSpPr>
+        <p:cNvPr id="1" name="Shape 235">
+          <a:extLst>
+            <a:ext uri="{FF2B5EF4-FFF2-40B4-BE49-F238E27FC236}">
+              <a16:creationId xmlns:a16="http://schemas.microsoft.com/office/drawing/2014/main" id="{FC2C6982-D461-6595-D0D3-FBB3DD0350EC}"/>
+            </a:ext>
+          </a:extLst>
+        </p:cNvPr>
+        <p:cNvGrpSpPr/>
+        <p:nvPr/>
+      </p:nvGrpSpPr>
+      <p:grpSpPr>
+        <a:xfrm>
+          <a:off x="0" y="0"/>
+          <a:ext cx="0" cy="0"/>
+          <a:chOff x="0" y="0"/>
+          <a:chExt cx="0" cy="0"/>
+        </a:xfrm>
+      </p:grpSpPr>
+      <p:sp>
+        <p:nvSpPr>
+          <p:cNvPr id="236" name="Google Shape;236;p11:notes">
+            <a:extLst>
+              <a:ext uri="{FF2B5EF4-FFF2-40B4-BE49-F238E27FC236}">
+                <a16:creationId xmlns:a16="http://schemas.microsoft.com/office/drawing/2014/main" id="{F79BB721-46C0-BA2B-F3CA-1DEC1C3D7AE5}"/>
+              </a:ext>
+            </a:extLst>
+          </p:cNvPr>
+          <p:cNvSpPr txBox="1">
+            <a:spLocks noGrp="1"/>
+          </p:cNvSpPr>
+          <p:nvPr>
+            <p:ph type="body" idx="1"/>
+          </p:nvPr>
+        </p:nvSpPr>
+        <p:spPr>
+          <a:xfrm>
+            <a:off x="685800" y="4343400"/>
+            <a:ext cx="5486400" cy="4114800"/>
+          </a:xfrm>
+          <a:prstGeom prst="rect">
+            <a:avLst/>
+          </a:prstGeom>
+        </p:spPr>
+        <p:txBody>
+          <a:bodyPr spcFirstLastPara="1" wrap="square" lIns="91425" tIns="91425" rIns="91425" bIns="91425" anchor="t" anchorCtr="0">
+            <a:noAutofit/>
+          </a:bodyPr>
+          <a:lstStyle/>
+          <a:p>
+            <a:pPr marL="0" lvl="0" indent="0" algn="l" rtl="0">
+              <a:spcBef>
+                <a:spcPts val="0"/>
+              </a:spcBef>
+              <a:spcAft>
+                <a:spcPts val="0"/>
+              </a:spcAft>
+              <a:buNone/>
+            </a:pPr>
+            <a:endParaRPr/>
+          </a:p>
+        </p:txBody>
+      </p:sp>
+      <p:sp>
+        <p:nvSpPr>
+          <p:cNvPr id="237" name="Google Shape;237;p11:notes">
+            <a:extLst>
+              <a:ext uri="{FF2B5EF4-FFF2-40B4-BE49-F238E27FC236}">
+                <a16:creationId xmlns:a16="http://schemas.microsoft.com/office/drawing/2014/main" id="{6947C15C-7BF0-644E-69E0-6D194FF6F542}"/>
+              </a:ext>
+            </a:extLst>
+          </p:cNvPr>
+          <p:cNvSpPr>
+            <a:spLocks noGrp="1" noRot="1" noChangeAspect="1"/>
+          </p:cNvSpPr>
+          <p:nvPr>
+            <p:ph type="sldImg" idx="2"/>
+          </p:nvPr>
+        </p:nvSpPr>
+        <p:spPr>
+          <a:xfrm>
+            <a:off x="381000" y="685800"/>
+            <a:ext cx="6096000" cy="3429000"/>
+          </a:xfrm>
+          <a:custGeom>
+            <a:avLst/>
+            <a:gdLst/>
+            <a:ahLst/>
+            <a:cxnLst/>
+            <a:rect l="l" t="t" r="r" b="b"/>
+            <a:pathLst>
+              <a:path w="120000" h="120000" extrusionOk="0">
+                <a:moveTo>
+                  <a:pt x="0" y="0"/>
+                </a:moveTo>
+                <a:lnTo>
+                  <a:pt x="120000" y="0"/>
+                </a:lnTo>
+                <a:lnTo>
+                  <a:pt x="120000" y="120000"/>
+                </a:lnTo>
+                <a:lnTo>
+                  <a:pt x="0" y="120000"/>
+                </a:lnTo>
+                <a:close/>
+              </a:path>
+            </a:pathLst>
+          </a:custGeom>
+        </p:spPr>
+      </p:sp>
+    </p:spTree>
+    <p:extLst>
+      <p:ext uri="{BB962C8B-B14F-4D97-AF65-F5344CB8AC3E}">
+        <p14:creationId xmlns:p14="http://schemas.microsoft.com/office/powerpoint/2010/main" val="8982370"/>
+      </p:ext>
+    </p:extLst>
+  </p:cSld>
+  <p:clrMapOvr>
+    <a:masterClrMapping/>
+  </p:clrMapOvr>
+</p:notes>
+</file>
+
+<file path=ppt/notesSlides/notesSlide12.xml><?xml version="1.0" encoding="utf-8"?>
+<p:notes xmlns:a="http://schemas.openxmlformats.org/drawingml/2006/main" xmlns:r="http://schemas.openxmlformats.org/officeDocument/2006/relationships" xmlns:p="http://schemas.openxmlformats.org/presentationml/2006/main" showMasterSp="0" showMasterPhAnim="0">
+  <p:cSld>
+    <p:spTree>
+      <p:nvGrpSpPr>
         <p:cNvPr id="1" name="Shape 235"/>
         <p:cNvGrpSpPr/>
         <p:nvPr/>
@@ -1084,7 +1212,7 @@
 </p:notes>
 </file>
 
-<file path=ppt/notesSlides/notesSlide12.xml><?xml version="1.0" encoding="utf-8"?>
+<file path=ppt/notesSlides/notesSlide13.xml><?xml version="1.0" encoding="utf-8"?>
 <p:notes xmlns:a="http://schemas.openxmlformats.org/drawingml/2006/main" xmlns:r="http://schemas.openxmlformats.org/officeDocument/2006/relationships" xmlns:p="http://schemas.openxmlformats.org/presentationml/2006/main" showMasterSp="0" showMasterPhAnim="0">
   <p:cSld>
     <p:spTree>
@@ -11649,7 +11777,7 @@
                 <a:cs typeface="Inter"/>
                 <a:sym typeface="Inter"/>
               </a:rPr>
-              <a:t>Rispettivamente: RF (50 </a:t>
+              <a:t>Baseline: RF (50 </a:t>
             </a:r>
             <a:r>
               <a:rPr lang="it-IT" sz="1350" b="0" i="0" u="none" strike="noStrike" cap="none" dirty="0" err="1">
@@ -11753,7 +11881,7 @@
         </p:nvSpPr>
         <p:spPr>
           <a:xfrm>
-            <a:off x="688846" y="3377571"/>
+            <a:off x="571499" y="1921053"/>
             <a:ext cx="2290257" cy="323165"/>
           </a:xfrm>
           <a:prstGeom prst="rect">
@@ -11809,8 +11937,8 @@
         </p:nvSpPr>
         <p:spPr>
           <a:xfrm>
-            <a:off x="688846" y="3887119"/>
-            <a:ext cx="2918329" cy="1246495"/>
+            <a:off x="571499" y="2318478"/>
+            <a:ext cx="2918329" cy="997196"/>
           </a:xfrm>
           <a:prstGeom prst="rect">
             <a:avLst/>
@@ -11834,9 +11962,9 @@
             <a:r>
               <a:rPr lang="en-US" sz="1350" b="1" dirty="0" err="1">
                 <a:solidFill>
-                  <a:schemeClr val="bg2">
-                    <a:lumMod val="20000"/>
-                    <a:lumOff val="80000"/>
+                  <a:schemeClr val="accent3">
+                    <a:lumMod val="40000"/>
+                    <a:lumOff val="60000"/>
                   </a:schemeClr>
                 </a:solidFill>
                 <a:latin typeface="Inter"/>
@@ -11849,9 +11977,9 @@
             <a:r>
               <a:rPr lang="en-US" sz="1350" b="1" dirty="0">
                 <a:solidFill>
-                  <a:schemeClr val="bg2">
-                    <a:lumMod val="20000"/>
-                    <a:lumOff val="80000"/>
+                  <a:schemeClr val="accent3">
+                    <a:lumMod val="40000"/>
+                    <a:lumOff val="60000"/>
                   </a:schemeClr>
                 </a:solidFill>
                 <a:latin typeface="Inter"/>
@@ -11860,6 +11988,21 @@
                 <a:sym typeface="Inter"/>
               </a:rPr>
               <a:t>:</a:t>
+            </a:r>
+            <a:r>
+              <a:rPr lang="en-US" sz="1350" dirty="0">
+                <a:solidFill>
+                  <a:schemeClr val="accent3">
+                    <a:lumMod val="40000"/>
+                    <a:lumOff val="60000"/>
+                  </a:schemeClr>
+                </a:solidFill>
+                <a:latin typeface="Inter"/>
+                <a:ea typeface="Inter"/>
+                <a:cs typeface="Inter"/>
+                <a:sym typeface="Inter"/>
+              </a:rPr>
+              <a:t> </a:t>
             </a:r>
             <a:r>
               <a:rPr lang="en-US" sz="1350" dirty="0">
@@ -11873,34 +12016,8 @@
                 <a:cs typeface="Inter"/>
                 <a:sym typeface="Inter"/>
               </a:rPr>
-              <a:t> 72.77%</a:t>
-            </a:r>
-            <a:endParaRPr lang="en-US" sz="1350" b="1" i="0" u="none" strike="noStrike" cap="none" dirty="0">
-              <a:solidFill>
-                <a:schemeClr val="bg2">
-                  <a:lumMod val="20000"/>
-                  <a:lumOff val="80000"/>
-                </a:schemeClr>
-              </a:solidFill>
-              <a:latin typeface="Inter"/>
-              <a:ea typeface="Inter"/>
-              <a:cs typeface="Inter"/>
-              <a:sym typeface="Inter"/>
-            </a:endParaRPr>
-          </a:p>
-          <a:p>
-            <a:pPr marL="0" marR="0" lvl="0" indent="0" algn="l" rtl="0">
-              <a:lnSpc>
-                <a:spcPct val="120000"/>
-              </a:lnSpc>
-              <a:spcBef>
-                <a:spcPts val="0"/>
-              </a:spcBef>
-              <a:spcAft>
-                <a:spcPts val="0"/>
-              </a:spcAft>
-              <a:buNone/>
-            </a:pPr>
+              <a:t>72.77%</a:t>
+            </a:r>
             <a:endParaRPr lang="en-US" sz="1350" b="1" dirty="0">
               <a:solidFill>
                 <a:schemeClr val="bg2">
@@ -12127,7 +12244,7 @@
         </p:nvSpPr>
         <p:spPr>
           <a:xfrm>
-            <a:off x="688846" y="2961214"/>
+            <a:off x="571499" y="1611931"/>
             <a:ext cx="2290257" cy="323165"/>
           </a:xfrm>
           <a:prstGeom prst="rect">
@@ -12183,7 +12300,7 @@
         </p:nvSpPr>
         <p:spPr>
           <a:xfrm>
-            <a:off x="4464202" y="3370305"/>
+            <a:off x="4346854" y="1926712"/>
             <a:ext cx="2290257" cy="323165"/>
           </a:xfrm>
           <a:prstGeom prst="rect">
@@ -12239,8 +12356,8 @@
         </p:nvSpPr>
         <p:spPr>
           <a:xfrm>
-            <a:off x="4464202" y="3879853"/>
-            <a:ext cx="2918329" cy="1246495"/>
+            <a:off x="4346854" y="2318478"/>
+            <a:ext cx="2918329" cy="997196"/>
           </a:xfrm>
           <a:prstGeom prst="rect">
             <a:avLst/>
@@ -12264,9 +12381,9 @@
             <a:r>
               <a:rPr lang="en-US" sz="1350" b="1" dirty="0" err="1">
                 <a:solidFill>
-                  <a:schemeClr val="bg2">
-                    <a:lumMod val="20000"/>
-                    <a:lumOff val="80000"/>
+                  <a:schemeClr val="accent3">
+                    <a:lumMod val="40000"/>
+                    <a:lumOff val="60000"/>
                   </a:schemeClr>
                 </a:solidFill>
                 <a:latin typeface="Inter"/>
@@ -12279,9 +12396,9 @@
             <a:r>
               <a:rPr lang="en-US" sz="1350" b="1" dirty="0">
                 <a:solidFill>
-                  <a:schemeClr val="bg2">
-                    <a:lumMod val="20000"/>
-                    <a:lumOff val="80000"/>
+                  <a:schemeClr val="accent3">
+                    <a:lumMod val="40000"/>
+                    <a:lumOff val="60000"/>
                   </a:schemeClr>
                 </a:solidFill>
                 <a:latin typeface="Inter"/>
@@ -12290,6 +12407,21 @@
                 <a:sym typeface="Inter"/>
               </a:rPr>
               <a:t>:</a:t>
+            </a:r>
+            <a:r>
+              <a:rPr lang="en-US" sz="1350" dirty="0">
+                <a:solidFill>
+                  <a:schemeClr val="accent3">
+                    <a:lumMod val="40000"/>
+                    <a:lumOff val="60000"/>
+                  </a:schemeClr>
+                </a:solidFill>
+                <a:latin typeface="Inter"/>
+                <a:ea typeface="Inter"/>
+                <a:cs typeface="Inter"/>
+                <a:sym typeface="Inter"/>
+              </a:rPr>
+              <a:t> </a:t>
             </a:r>
             <a:r>
               <a:rPr lang="en-US" sz="1350" dirty="0">
@@ -12303,34 +12435,8 @@
                 <a:cs typeface="Inter"/>
                 <a:sym typeface="Inter"/>
               </a:rPr>
-              <a:t> 72.10%</a:t>
-            </a:r>
-            <a:endParaRPr lang="en-US" sz="1350" b="1" i="0" u="none" strike="noStrike" cap="none" dirty="0">
-              <a:solidFill>
-                <a:schemeClr val="bg2">
-                  <a:lumMod val="20000"/>
-                  <a:lumOff val="80000"/>
-                </a:schemeClr>
-              </a:solidFill>
-              <a:latin typeface="Inter"/>
-              <a:ea typeface="Inter"/>
-              <a:cs typeface="Inter"/>
-              <a:sym typeface="Inter"/>
-            </a:endParaRPr>
-          </a:p>
-          <a:p>
-            <a:pPr marL="0" marR="0" lvl="0" indent="0" algn="l" rtl="0">
-              <a:lnSpc>
-                <a:spcPct val="120000"/>
-              </a:lnSpc>
-              <a:spcBef>
-                <a:spcPts val="0"/>
-              </a:spcBef>
-              <a:spcAft>
-                <a:spcPts val="0"/>
-              </a:spcAft>
-              <a:buNone/>
-            </a:pPr>
+              <a:t>72.10%</a:t>
+            </a:r>
             <a:endParaRPr lang="en-US" sz="1350" b="1" dirty="0">
               <a:solidFill>
                 <a:schemeClr val="bg2">
@@ -12557,7 +12663,7 @@
         </p:nvSpPr>
         <p:spPr>
           <a:xfrm>
-            <a:off x="4464202" y="2953948"/>
+            <a:off x="4346855" y="1604665"/>
             <a:ext cx="2290257" cy="323165"/>
           </a:xfrm>
           <a:prstGeom prst="rect">
@@ -12637,7 +12743,7 @@
         </p:nvSpPr>
         <p:spPr>
           <a:xfrm>
-            <a:off x="8328101" y="3370305"/>
+            <a:off x="8210754" y="1952302"/>
             <a:ext cx="2290257" cy="323165"/>
           </a:xfrm>
           <a:prstGeom prst="rect">
@@ -12693,8 +12799,8 @@
         </p:nvSpPr>
         <p:spPr>
           <a:xfrm>
-            <a:off x="8328101" y="3879853"/>
-            <a:ext cx="2918329" cy="1246495"/>
+            <a:off x="8243020" y="2318478"/>
+            <a:ext cx="2918329" cy="997196"/>
           </a:xfrm>
           <a:prstGeom prst="rect">
             <a:avLst/>
@@ -12718,6 +12824,91 @@
             <a:r>
               <a:rPr lang="en-US" sz="1350" b="1" dirty="0" err="1">
                 <a:solidFill>
+                  <a:schemeClr val="accent3">
+                    <a:lumMod val="40000"/>
+                    <a:lumOff val="60000"/>
+                  </a:schemeClr>
+                </a:solidFill>
+                <a:latin typeface="Inter"/>
+                <a:ea typeface="Inter"/>
+                <a:cs typeface="Inter"/>
+                <a:sym typeface="Inter"/>
+              </a:rPr>
+              <a:t>Accuratezza</a:t>
+            </a:r>
+            <a:r>
+              <a:rPr lang="en-US" sz="1350" b="1" dirty="0">
+                <a:solidFill>
+                  <a:schemeClr val="accent3">
+                    <a:lumMod val="40000"/>
+                    <a:lumOff val="60000"/>
+                  </a:schemeClr>
+                </a:solidFill>
+                <a:latin typeface="Inter"/>
+                <a:ea typeface="Inter"/>
+                <a:cs typeface="Inter"/>
+                <a:sym typeface="Inter"/>
+              </a:rPr>
+              <a:t>:</a:t>
+            </a:r>
+            <a:r>
+              <a:rPr lang="en-US" sz="1350" dirty="0">
+                <a:solidFill>
+                  <a:schemeClr val="accent3">
+                    <a:lumMod val="40000"/>
+                    <a:lumOff val="60000"/>
+                  </a:schemeClr>
+                </a:solidFill>
+                <a:latin typeface="Inter"/>
+                <a:ea typeface="Inter"/>
+                <a:cs typeface="Inter"/>
+                <a:sym typeface="Inter"/>
+              </a:rPr>
+              <a:t> </a:t>
+            </a:r>
+            <a:r>
+              <a:rPr lang="en-US" sz="1350" dirty="0">
+                <a:solidFill>
+                  <a:schemeClr val="bg1">
+                    <a:lumMod val="85000"/>
+                  </a:schemeClr>
+                </a:solidFill>
+                <a:latin typeface="Inter"/>
+                <a:ea typeface="Inter"/>
+                <a:cs typeface="Inter"/>
+                <a:sym typeface="Inter"/>
+              </a:rPr>
+              <a:t>70.42%</a:t>
+            </a:r>
+            <a:endParaRPr lang="en-US" sz="1350" b="1" i="0" u="none" strike="noStrike" cap="none" dirty="0">
+              <a:solidFill>
+                <a:schemeClr val="bg2">
+                  <a:lumMod val="20000"/>
+                  <a:lumOff val="80000"/>
+                </a:schemeClr>
+              </a:solidFill>
+              <a:latin typeface="Inter"/>
+              <a:ea typeface="Inter"/>
+              <a:cs typeface="Inter"/>
+              <a:sym typeface="Inter"/>
+            </a:endParaRPr>
+          </a:p>
+          <a:p>
+            <a:pPr marL="0" marR="0" lvl="0" indent="0" algn="l" rtl="0">
+              <a:lnSpc>
+                <a:spcPct val="120000"/>
+              </a:lnSpc>
+              <a:spcBef>
+                <a:spcPts val="0"/>
+              </a:spcBef>
+              <a:spcAft>
+                <a:spcPts val="0"/>
+              </a:spcAft>
+              <a:buNone/>
+            </a:pPr>
+            <a:r>
+              <a:rPr lang="en-US" sz="1350" b="1" i="0" u="none" strike="noStrike" cap="none" dirty="0" err="1">
+                <a:solidFill>
                   <a:schemeClr val="bg2">
                     <a:lumMod val="20000"/>
                     <a:lumOff val="80000"/>
@@ -12728,10 +12919,10 @@
                 <a:cs typeface="Inter"/>
                 <a:sym typeface="Inter"/>
               </a:rPr>
-              <a:t>Accuratezza</a:t>
-            </a:r>
-            <a:r>
-              <a:rPr lang="en-US" sz="1350" b="1" dirty="0">
+              <a:t>Precisione</a:t>
+            </a:r>
+            <a:r>
+              <a:rPr lang="en-US" sz="1350" b="1" i="0" u="none" strike="noStrike" cap="none" dirty="0">
                 <a:solidFill>
                   <a:schemeClr val="bg2">
                     <a:lumMod val="20000"/>
@@ -12746,6 +12937,21 @@
               <a:t>:</a:t>
             </a:r>
             <a:r>
+              <a:rPr lang="en-US" sz="1350" b="0" i="0" u="none" strike="noStrike" cap="none" dirty="0">
+                <a:solidFill>
+                  <a:schemeClr val="bg2">
+                    <a:lumMod val="20000"/>
+                    <a:lumOff val="80000"/>
+                  </a:schemeClr>
+                </a:solidFill>
+                <a:latin typeface="Inter"/>
+                <a:ea typeface="Inter"/>
+                <a:cs typeface="Inter"/>
+                <a:sym typeface="Inter"/>
+              </a:rPr>
+              <a:t> </a:t>
+            </a:r>
+            <a:r>
               <a:rPr lang="en-US" sz="1350" dirty="0">
                 <a:solidFill>
                   <a:schemeClr val="bg1">
@@ -12757,7 +12963,556 @@
                 <a:cs typeface="Inter"/>
                 <a:sym typeface="Inter"/>
               </a:rPr>
-              <a:t> 70.42%</a:t>
+              <a:t>73</a:t>
+            </a:r>
+            <a:r>
+              <a:rPr lang="en-US" sz="1350" b="0" i="0" u="none" strike="noStrike" cap="none" dirty="0">
+                <a:solidFill>
+                  <a:schemeClr val="bg1">
+                    <a:lumMod val="85000"/>
+                  </a:schemeClr>
+                </a:solidFill>
+                <a:latin typeface="Inter"/>
+                <a:ea typeface="Inter"/>
+                <a:cs typeface="Inter"/>
+                <a:sym typeface="Inter"/>
+              </a:rPr>
+              <a:t>%</a:t>
+            </a:r>
+            <a:br>
+              <a:rPr lang="en-US" sz="1800" b="0" i="0" u="none" strike="noStrike" cap="none" dirty="0">
+                <a:solidFill>
+                  <a:schemeClr val="dk1"/>
+                </a:solidFill>
+                <a:latin typeface="Calibri"/>
+                <a:ea typeface="Calibri"/>
+                <a:cs typeface="Calibri"/>
+                <a:sym typeface="Calibri"/>
+              </a:rPr>
+            </a:br>
+            <a:r>
+              <a:rPr lang="en-US" sz="1350" b="1" i="0" u="none" strike="noStrike" cap="none" dirty="0">
+                <a:solidFill>
+                  <a:schemeClr val="bg2">
+                    <a:lumMod val="20000"/>
+                    <a:lumOff val="80000"/>
+                  </a:schemeClr>
+                </a:solidFill>
+                <a:latin typeface="Inter"/>
+                <a:ea typeface="Inter"/>
+                <a:cs typeface="Inter"/>
+                <a:sym typeface="Inter"/>
+              </a:rPr>
+              <a:t>Recall:</a:t>
+            </a:r>
+            <a:r>
+              <a:rPr lang="en-US" sz="1350" b="0" i="0" u="none" strike="noStrike" cap="none" dirty="0">
+                <a:solidFill>
+                  <a:schemeClr val="bg2">
+                    <a:lumMod val="20000"/>
+                    <a:lumOff val="80000"/>
+                  </a:schemeClr>
+                </a:solidFill>
+                <a:latin typeface="Inter"/>
+                <a:ea typeface="Inter"/>
+                <a:cs typeface="Inter"/>
+                <a:sym typeface="Inter"/>
+              </a:rPr>
+              <a:t> </a:t>
+            </a:r>
+            <a:r>
+              <a:rPr lang="en-US" sz="1350" b="0" i="0" u="none" strike="noStrike" cap="none" dirty="0">
+                <a:solidFill>
+                  <a:schemeClr val="bg1">
+                    <a:lumMod val="85000"/>
+                  </a:schemeClr>
+                </a:solidFill>
+                <a:latin typeface="Inter"/>
+                <a:ea typeface="Inter"/>
+                <a:cs typeface="Inter"/>
+                <a:sym typeface="Inter"/>
+              </a:rPr>
+              <a:t>74%</a:t>
+            </a:r>
+            <a:br>
+              <a:rPr lang="en-US" sz="1800" b="0" i="0" u="none" strike="noStrike" cap="none" dirty="0">
+                <a:solidFill>
+                  <a:schemeClr val="dk1"/>
+                </a:solidFill>
+                <a:latin typeface="Calibri"/>
+                <a:ea typeface="Calibri"/>
+                <a:cs typeface="Calibri"/>
+                <a:sym typeface="Calibri"/>
+              </a:rPr>
+            </a:br>
+            <a:r>
+              <a:rPr lang="en-US" sz="1350" b="1" i="0" u="none" strike="noStrike" cap="none" dirty="0">
+                <a:solidFill>
+                  <a:schemeClr val="bg2">
+                    <a:lumMod val="20000"/>
+                    <a:lumOff val="80000"/>
+                  </a:schemeClr>
+                </a:solidFill>
+                <a:latin typeface="Inter"/>
+                <a:ea typeface="Inter"/>
+                <a:cs typeface="Inter"/>
+                <a:sym typeface="Inter"/>
+              </a:rPr>
+              <a:t>F1-Score:</a:t>
+            </a:r>
+            <a:r>
+              <a:rPr lang="en-US" sz="1350" b="0" i="0" u="none" strike="noStrike" cap="none" dirty="0">
+                <a:solidFill>
+                  <a:schemeClr val="bg2">
+                    <a:lumMod val="20000"/>
+                    <a:lumOff val="80000"/>
+                  </a:schemeClr>
+                </a:solidFill>
+                <a:latin typeface="Inter"/>
+                <a:ea typeface="Inter"/>
+                <a:cs typeface="Inter"/>
+                <a:sym typeface="Inter"/>
+              </a:rPr>
+              <a:t> </a:t>
+            </a:r>
+            <a:r>
+              <a:rPr lang="en-US" sz="1350" b="0" i="0" u="none" strike="noStrike" cap="none" dirty="0">
+                <a:solidFill>
+                  <a:schemeClr val="bg1">
+                    <a:lumMod val="85000"/>
+                  </a:schemeClr>
+                </a:solidFill>
+                <a:latin typeface="Inter"/>
+                <a:ea typeface="Inter"/>
+                <a:cs typeface="Inter"/>
+                <a:sym typeface="Inter"/>
+              </a:rPr>
+              <a:t>73%</a:t>
+            </a:r>
+          </a:p>
+        </p:txBody>
+      </p:sp>
+      <p:sp>
+        <p:nvSpPr>
+          <p:cNvPr id="14" name="Google Shape;242;p23">
+            <a:extLst>
+              <a:ext uri="{FF2B5EF4-FFF2-40B4-BE49-F238E27FC236}">
+                <a16:creationId xmlns:a16="http://schemas.microsoft.com/office/drawing/2014/main" id="{19386B87-908C-40F6-EFF0-AD1CB92DECAA}"/>
+              </a:ext>
+            </a:extLst>
+          </p:cNvPr>
+          <p:cNvSpPr txBox="1"/>
+          <p:nvPr/>
+        </p:nvSpPr>
+        <p:spPr>
+          <a:xfrm>
+            <a:off x="8210754" y="1604665"/>
+            <a:ext cx="2598517" cy="323165"/>
+          </a:xfrm>
+          <a:prstGeom prst="rect">
+            <a:avLst/>
+          </a:prstGeom>
+          <a:noFill/>
+          <a:ln>
+            <a:noFill/>
+          </a:ln>
+        </p:spPr>
+        <p:txBody>
+          <a:bodyPr spcFirstLastPara="1" wrap="square" lIns="0" tIns="0" rIns="0" bIns="0" anchor="t" anchorCtr="0">
+            <a:spAutoFit/>
+          </a:bodyPr>
+          <a:lstStyle/>
+          <a:p>
+            <a:pPr marL="0" marR="0" lvl="0" indent="0" algn="l" rtl="0">
+              <a:spcBef>
+                <a:spcPts val="0"/>
+              </a:spcBef>
+              <a:spcAft>
+                <a:spcPts val="0"/>
+              </a:spcAft>
+              <a:buNone/>
+            </a:pPr>
+            <a:r>
+              <a:rPr lang="en-US" sz="2100" b="1" i="0" u="none" strike="noStrike" cap="none" dirty="0">
+                <a:solidFill>
+                  <a:srgbClr val="38BDF8"/>
+                </a:solidFill>
+                <a:latin typeface="Poppins Medium"/>
+                <a:ea typeface="Poppins Medium"/>
+                <a:cs typeface="Poppins Medium"/>
+                <a:sym typeface="Poppins Medium"/>
+              </a:rPr>
+              <a:t>Logistic Regression</a:t>
+            </a:r>
+            <a:endParaRPr b="1" dirty="0"/>
+          </a:p>
+        </p:txBody>
+      </p:sp>
+      <p:sp>
+        <p:nvSpPr>
+          <p:cNvPr id="4" name="Google Shape;94;p14">
+            <a:extLst>
+              <a:ext uri="{FF2B5EF4-FFF2-40B4-BE49-F238E27FC236}">
+                <a16:creationId xmlns:a16="http://schemas.microsoft.com/office/drawing/2014/main" id="{C4ADCDF9-C5F5-321F-20CD-452BFBD96E72}"/>
+              </a:ext>
+            </a:extLst>
+          </p:cNvPr>
+          <p:cNvSpPr txBox="1"/>
+          <p:nvPr/>
+        </p:nvSpPr>
+        <p:spPr>
+          <a:xfrm>
+            <a:off x="486507" y="3540059"/>
+            <a:ext cx="11180885" cy="332399"/>
+          </a:xfrm>
+          <a:prstGeom prst="rect">
+            <a:avLst/>
+          </a:prstGeom>
+          <a:noFill/>
+          <a:ln>
+            <a:noFill/>
+          </a:ln>
+        </p:spPr>
+        <p:txBody>
+          <a:bodyPr spcFirstLastPara="1" wrap="square" lIns="0" tIns="0" rIns="0" bIns="0" anchor="t" anchorCtr="0">
+            <a:spAutoFit/>
+          </a:bodyPr>
+          <a:lstStyle/>
+          <a:p>
+            <a:pPr marL="0" marR="0" lvl="0" indent="0" algn="l" rtl="0">
+              <a:lnSpc>
+                <a:spcPct val="160000"/>
+              </a:lnSpc>
+              <a:spcBef>
+                <a:spcPts val="0"/>
+              </a:spcBef>
+              <a:spcAft>
+                <a:spcPts val="0"/>
+              </a:spcAft>
+              <a:buNone/>
+            </a:pPr>
+            <a:r>
+              <a:rPr lang="it-IT" sz="1350" dirty="0">
+                <a:solidFill>
+                  <a:srgbClr val="CBD5E1"/>
+                </a:solidFill>
+                <a:latin typeface="Inter"/>
+                <a:ea typeface="Inter"/>
+                <a:cs typeface="Inter"/>
+                <a:sym typeface="Inter"/>
+              </a:rPr>
+              <a:t>Soglia PPI 0.60 vs 0.85: </a:t>
+            </a:r>
+            <a:r>
+              <a:rPr lang="it-IT" sz="1350" b="0" i="0" u="none" strike="noStrike" cap="none" dirty="0">
+                <a:solidFill>
+                  <a:srgbClr val="CBD5E1"/>
+                </a:solidFill>
+                <a:latin typeface="Inter"/>
+                <a:ea typeface="Inter"/>
+                <a:cs typeface="Inter"/>
+                <a:sym typeface="Inter"/>
+              </a:rPr>
+              <a:t>RF (75 </a:t>
+            </a:r>
+            <a:r>
+              <a:rPr lang="it-IT" sz="1350" b="0" i="0" u="none" strike="noStrike" cap="none" dirty="0" err="1">
+                <a:solidFill>
+                  <a:srgbClr val="CBD5E1"/>
+                </a:solidFill>
+                <a:latin typeface="Inter"/>
+                <a:ea typeface="Inter"/>
+                <a:cs typeface="Inter"/>
+                <a:sym typeface="Inter"/>
+              </a:rPr>
+              <a:t>Learners</a:t>
+            </a:r>
+            <a:r>
+              <a:rPr lang="it-IT" sz="1350" b="0" i="0" u="none" strike="noStrike" cap="none" dirty="0">
+                <a:solidFill>
+                  <a:srgbClr val="CBD5E1"/>
+                </a:solidFill>
+                <a:latin typeface="Inter"/>
+                <a:ea typeface="Inter"/>
+                <a:cs typeface="Inter"/>
+                <a:sym typeface="Inter"/>
+              </a:rPr>
+              <a:t>, 750 </a:t>
+            </a:r>
+            <a:r>
+              <a:rPr lang="it-IT" sz="1350" b="0" i="0" u="none" strike="noStrike" cap="none" dirty="0" err="1">
+                <a:solidFill>
+                  <a:srgbClr val="CBD5E1"/>
+                </a:solidFill>
+                <a:latin typeface="Inter"/>
+                <a:ea typeface="Inter"/>
+                <a:cs typeface="Inter"/>
+                <a:sym typeface="Inter"/>
+              </a:rPr>
+              <a:t>Splits</a:t>
+            </a:r>
+            <a:r>
+              <a:rPr lang="it-IT" sz="1350" b="0" i="0" u="none" strike="noStrike" cap="none" dirty="0">
+                <a:solidFill>
+                  <a:srgbClr val="CBD5E1"/>
+                </a:solidFill>
+                <a:latin typeface="Inter"/>
+                <a:ea typeface="Inter"/>
+                <a:cs typeface="Inter"/>
+                <a:sym typeface="Inter"/>
+              </a:rPr>
+              <a:t>), SVM (Kernel Cubico), </a:t>
+            </a:r>
+            <a:r>
+              <a:rPr lang="it-IT" sz="1350" b="0" i="0" u="none" strike="noStrike" cap="none" dirty="0" err="1">
+                <a:solidFill>
+                  <a:srgbClr val="CBD5E1"/>
+                </a:solidFill>
+                <a:latin typeface="Inter"/>
+                <a:ea typeface="Inter"/>
+                <a:cs typeface="Inter"/>
+                <a:sym typeface="Inter"/>
+              </a:rPr>
+              <a:t>Logistic</a:t>
+            </a:r>
+            <a:r>
+              <a:rPr lang="it-IT" sz="1350" b="0" i="0" u="none" strike="noStrike" cap="none" dirty="0">
+                <a:solidFill>
+                  <a:srgbClr val="CBD5E1"/>
+                </a:solidFill>
+                <a:latin typeface="Inter"/>
+                <a:ea typeface="Inter"/>
+                <a:cs typeface="Inter"/>
+                <a:sym typeface="Inter"/>
+              </a:rPr>
+              <a:t> </a:t>
+            </a:r>
+            <a:r>
+              <a:rPr lang="it-IT" sz="1350" b="0" i="0" u="none" strike="noStrike" cap="none" dirty="0" err="1">
+                <a:solidFill>
+                  <a:srgbClr val="CBD5E1"/>
+                </a:solidFill>
+                <a:latin typeface="Inter"/>
+                <a:ea typeface="Inter"/>
+                <a:cs typeface="Inter"/>
+                <a:sym typeface="Inter"/>
+              </a:rPr>
+              <a:t>Regression</a:t>
+            </a:r>
+            <a:r>
+              <a:rPr lang="it-IT" sz="1350" b="0" i="0" u="none" strike="noStrike" cap="none" dirty="0">
+                <a:solidFill>
+                  <a:srgbClr val="CBD5E1"/>
+                </a:solidFill>
+                <a:latin typeface="Inter"/>
+                <a:ea typeface="Inter"/>
+                <a:cs typeface="Inter"/>
+                <a:sym typeface="Inter"/>
+              </a:rPr>
+              <a:t>, </a:t>
+            </a:r>
+            <a:r>
+              <a:rPr lang="it-IT" sz="1350" b="0" i="0" u="none" strike="noStrike" cap="none" dirty="0" err="1">
+                <a:solidFill>
+                  <a:srgbClr val="CBD5E1"/>
+                </a:solidFill>
+                <a:latin typeface="Inter"/>
+                <a:ea typeface="Inter"/>
+                <a:cs typeface="Inter"/>
+                <a:sym typeface="Inter"/>
+              </a:rPr>
+              <a:t>RUSBoost</a:t>
+            </a:r>
+            <a:r>
+              <a:rPr lang="it-IT" sz="1350" b="0" i="0" u="none" strike="noStrike" cap="none" dirty="0">
+                <a:solidFill>
+                  <a:srgbClr val="CBD5E1"/>
+                </a:solidFill>
+                <a:latin typeface="Inter"/>
+                <a:ea typeface="Inter"/>
+                <a:cs typeface="Inter"/>
+                <a:sym typeface="Inter"/>
+              </a:rPr>
+              <a:t> (150 cicli, 15 </a:t>
+            </a:r>
+            <a:r>
+              <a:rPr lang="it-IT" sz="1350" b="0" i="0" u="none" strike="noStrike" cap="none" dirty="0" err="1">
+                <a:solidFill>
+                  <a:srgbClr val="CBD5E1"/>
+                </a:solidFill>
+                <a:latin typeface="Inter"/>
+                <a:ea typeface="Inter"/>
+                <a:cs typeface="Inter"/>
+                <a:sym typeface="Inter"/>
+              </a:rPr>
+              <a:t>Splits</a:t>
+            </a:r>
+            <a:r>
+              <a:rPr lang="it-IT" sz="1350" b="0" i="0" u="none" strike="noStrike" cap="none" dirty="0">
+                <a:solidFill>
+                  <a:srgbClr val="CBD5E1"/>
+                </a:solidFill>
+                <a:latin typeface="Inter"/>
+                <a:ea typeface="Inter"/>
+                <a:cs typeface="Inter"/>
+                <a:sym typeface="Inter"/>
+              </a:rPr>
+              <a:t>)</a:t>
+            </a:r>
+            <a:endParaRPr lang="it-IT" dirty="0"/>
+          </a:p>
+        </p:txBody>
+      </p:sp>
+      <p:sp>
+        <p:nvSpPr>
+          <p:cNvPr id="6" name="Google Shape;242;p23">
+            <a:extLst>
+              <a:ext uri="{FF2B5EF4-FFF2-40B4-BE49-F238E27FC236}">
+                <a16:creationId xmlns:a16="http://schemas.microsoft.com/office/drawing/2014/main" id="{68542087-848E-15F3-1DDB-6384011945E2}"/>
+              </a:ext>
+            </a:extLst>
+          </p:cNvPr>
+          <p:cNvSpPr txBox="1"/>
+          <p:nvPr/>
+        </p:nvSpPr>
+        <p:spPr>
+          <a:xfrm>
+            <a:off x="486507" y="4502947"/>
+            <a:ext cx="2290257" cy="323165"/>
+          </a:xfrm>
+          <a:prstGeom prst="rect">
+            <a:avLst/>
+          </a:prstGeom>
+          <a:noFill/>
+          <a:ln>
+            <a:noFill/>
+          </a:ln>
+        </p:spPr>
+        <p:txBody>
+          <a:bodyPr spcFirstLastPara="1" wrap="square" lIns="0" tIns="0" rIns="0" bIns="0" anchor="t" anchorCtr="0">
+            <a:spAutoFit/>
+          </a:bodyPr>
+          <a:lstStyle/>
+          <a:p>
+            <a:pPr marL="0" marR="0" lvl="0" indent="0" algn="l" rtl="0">
+              <a:spcBef>
+                <a:spcPts val="0"/>
+              </a:spcBef>
+              <a:spcAft>
+                <a:spcPts val="0"/>
+              </a:spcAft>
+              <a:buNone/>
+            </a:pPr>
+            <a:r>
+              <a:rPr lang="en-US" sz="2100" b="0" i="0" u="none" strike="noStrike" cap="none" dirty="0">
+                <a:solidFill>
+                  <a:srgbClr val="38BDF8"/>
+                </a:solidFill>
+                <a:latin typeface="Poppins Medium"/>
+                <a:ea typeface="Poppins Medium"/>
+                <a:cs typeface="Poppins Medium"/>
+                <a:sym typeface="Poppins Medium"/>
+              </a:rPr>
+              <a:t>Stress</a:t>
+            </a:r>
+            <a:endParaRPr dirty="0"/>
+          </a:p>
+        </p:txBody>
+      </p:sp>
+      <p:sp>
+        <p:nvSpPr>
+          <p:cNvPr id="7" name="Google Shape;244;p23">
+            <a:extLst>
+              <a:ext uri="{FF2B5EF4-FFF2-40B4-BE49-F238E27FC236}">
+                <a16:creationId xmlns:a16="http://schemas.microsoft.com/office/drawing/2014/main" id="{C993AE8B-39B2-2D3F-9457-8A6819195AC5}"/>
+              </a:ext>
+            </a:extLst>
+          </p:cNvPr>
+          <p:cNvSpPr txBox="1"/>
+          <p:nvPr/>
+        </p:nvSpPr>
+        <p:spPr>
+          <a:xfrm>
+            <a:off x="486507" y="4900372"/>
+            <a:ext cx="2918329" cy="997196"/>
+          </a:xfrm>
+          <a:prstGeom prst="rect">
+            <a:avLst/>
+          </a:prstGeom>
+          <a:noFill/>
+          <a:ln>
+            <a:noFill/>
+          </a:ln>
+        </p:spPr>
+        <p:txBody>
+          <a:bodyPr spcFirstLastPara="1" wrap="square" lIns="0" tIns="0" rIns="0" bIns="0" anchor="t" anchorCtr="0">
+            <a:spAutoFit/>
+          </a:bodyPr>
+          <a:lstStyle/>
+          <a:p>
+            <a:pPr lvl="0">
+              <a:lnSpc>
+                <a:spcPct val="120000"/>
+              </a:lnSpc>
+            </a:pPr>
+            <a:r>
+              <a:rPr lang="en-US" sz="1350" b="1" dirty="0" err="1">
+                <a:solidFill>
+                  <a:schemeClr val="accent3">
+                    <a:lumMod val="40000"/>
+                    <a:lumOff val="60000"/>
+                  </a:schemeClr>
+                </a:solidFill>
+                <a:latin typeface="Inter"/>
+                <a:ea typeface="Inter"/>
+                <a:cs typeface="Inter"/>
+                <a:sym typeface="Inter"/>
+              </a:rPr>
+              <a:t>Accuratezza</a:t>
+            </a:r>
+            <a:r>
+              <a:rPr lang="en-US" sz="1350" b="1" dirty="0">
+                <a:solidFill>
+                  <a:schemeClr val="accent3">
+                    <a:lumMod val="40000"/>
+                    <a:lumOff val="60000"/>
+                  </a:schemeClr>
+                </a:solidFill>
+                <a:latin typeface="Inter"/>
+                <a:ea typeface="Inter"/>
+                <a:cs typeface="Inter"/>
+                <a:sym typeface="Inter"/>
+              </a:rPr>
+              <a:t>:</a:t>
+            </a:r>
+            <a:r>
+              <a:rPr lang="en-US" sz="1350" dirty="0">
+                <a:solidFill>
+                  <a:schemeClr val="accent3">
+                    <a:lumMod val="40000"/>
+                    <a:lumOff val="60000"/>
+                  </a:schemeClr>
+                </a:solidFill>
+                <a:latin typeface="Inter"/>
+                <a:ea typeface="Inter"/>
+                <a:cs typeface="Inter"/>
+                <a:sym typeface="Inter"/>
+              </a:rPr>
+              <a:t> </a:t>
+            </a:r>
+            <a:r>
+              <a:rPr lang="en-US" sz="1350" dirty="0">
+                <a:solidFill>
+                  <a:schemeClr val="bg1">
+                    <a:lumMod val="85000"/>
+                  </a:schemeClr>
+                </a:solidFill>
+                <a:latin typeface="Inter"/>
+                <a:ea typeface="Inter"/>
+                <a:cs typeface="Inter"/>
+                <a:sym typeface="Inter"/>
+              </a:rPr>
+              <a:t>74.91%</a:t>
             </a:r>
             <a:endParaRPr lang="en-US" sz="1350" b="1" dirty="0">
               <a:solidFill>
@@ -12785,6 +13540,884 @@
               </a:spcAft>
               <a:buNone/>
             </a:pPr>
+            <a:r>
+              <a:rPr lang="en-US" sz="1350" b="1" i="0" u="none" strike="noStrike" cap="none" dirty="0" err="1">
+                <a:solidFill>
+                  <a:schemeClr val="bg2">
+                    <a:lumMod val="20000"/>
+                    <a:lumOff val="80000"/>
+                  </a:schemeClr>
+                </a:solidFill>
+                <a:latin typeface="Inter"/>
+                <a:ea typeface="Inter"/>
+                <a:cs typeface="Inter"/>
+                <a:sym typeface="Inter"/>
+              </a:rPr>
+              <a:t>Precisione</a:t>
+            </a:r>
+            <a:r>
+              <a:rPr lang="en-US" sz="1350" b="1" i="0" u="none" strike="noStrike" cap="none" dirty="0">
+                <a:solidFill>
+                  <a:schemeClr val="bg2">
+                    <a:lumMod val="20000"/>
+                    <a:lumOff val="80000"/>
+                  </a:schemeClr>
+                </a:solidFill>
+                <a:latin typeface="Inter"/>
+                <a:ea typeface="Inter"/>
+                <a:cs typeface="Inter"/>
+                <a:sym typeface="Inter"/>
+              </a:rPr>
+              <a:t>:</a:t>
+            </a:r>
+            <a:r>
+              <a:rPr lang="en-US" sz="1350" b="0" i="0" u="none" strike="noStrike" cap="none" dirty="0">
+                <a:solidFill>
+                  <a:schemeClr val="bg2">
+                    <a:lumMod val="20000"/>
+                    <a:lumOff val="80000"/>
+                  </a:schemeClr>
+                </a:solidFill>
+                <a:latin typeface="Inter"/>
+                <a:ea typeface="Inter"/>
+                <a:cs typeface="Inter"/>
+                <a:sym typeface="Inter"/>
+              </a:rPr>
+              <a:t> </a:t>
+            </a:r>
+            <a:r>
+              <a:rPr lang="en-US" sz="1350" dirty="0">
+                <a:solidFill>
+                  <a:schemeClr val="bg1">
+                    <a:lumMod val="85000"/>
+                  </a:schemeClr>
+                </a:solidFill>
+                <a:latin typeface="Inter"/>
+                <a:ea typeface="Inter"/>
+                <a:cs typeface="Inter"/>
+                <a:sym typeface="Inter"/>
+              </a:rPr>
+              <a:t>77</a:t>
+            </a:r>
+            <a:r>
+              <a:rPr lang="en-US" sz="1350" b="0" i="0" u="none" strike="noStrike" cap="none" dirty="0">
+                <a:solidFill>
+                  <a:schemeClr val="bg1">
+                    <a:lumMod val="85000"/>
+                  </a:schemeClr>
+                </a:solidFill>
+                <a:latin typeface="Inter"/>
+                <a:ea typeface="Inter"/>
+                <a:cs typeface="Inter"/>
+                <a:sym typeface="Inter"/>
+              </a:rPr>
+              <a:t>%</a:t>
+            </a:r>
+            <a:br>
+              <a:rPr lang="en-US" sz="1800" b="0" i="0" u="none" strike="noStrike" cap="none" dirty="0">
+                <a:solidFill>
+                  <a:schemeClr val="dk1"/>
+                </a:solidFill>
+                <a:latin typeface="Calibri"/>
+                <a:ea typeface="Calibri"/>
+                <a:cs typeface="Calibri"/>
+                <a:sym typeface="Calibri"/>
+              </a:rPr>
+            </a:br>
+            <a:r>
+              <a:rPr lang="en-US" sz="1350" b="1" i="0" u="none" strike="noStrike" cap="none" dirty="0">
+                <a:solidFill>
+                  <a:schemeClr val="bg2">
+                    <a:lumMod val="20000"/>
+                    <a:lumOff val="80000"/>
+                  </a:schemeClr>
+                </a:solidFill>
+                <a:latin typeface="Inter"/>
+                <a:ea typeface="Inter"/>
+                <a:cs typeface="Inter"/>
+                <a:sym typeface="Inter"/>
+              </a:rPr>
+              <a:t>Recall:</a:t>
+            </a:r>
+            <a:r>
+              <a:rPr lang="en-US" sz="1350" b="0" i="0" u="none" strike="noStrike" cap="none" dirty="0">
+                <a:solidFill>
+                  <a:schemeClr val="bg2">
+                    <a:lumMod val="20000"/>
+                    <a:lumOff val="80000"/>
+                  </a:schemeClr>
+                </a:solidFill>
+                <a:latin typeface="Inter"/>
+                <a:ea typeface="Inter"/>
+                <a:cs typeface="Inter"/>
+                <a:sym typeface="Inter"/>
+              </a:rPr>
+              <a:t> </a:t>
+            </a:r>
+            <a:r>
+              <a:rPr lang="en-US" sz="1350" b="0" i="0" u="none" strike="noStrike" cap="none" dirty="0">
+                <a:solidFill>
+                  <a:schemeClr val="bg1">
+                    <a:lumMod val="85000"/>
+                  </a:schemeClr>
+                </a:solidFill>
+                <a:latin typeface="Inter"/>
+                <a:ea typeface="Inter"/>
+                <a:cs typeface="Inter"/>
+                <a:sym typeface="Inter"/>
+              </a:rPr>
+              <a:t>88%</a:t>
+            </a:r>
+            <a:br>
+              <a:rPr lang="en-US" sz="1800" b="0" i="0" u="none" strike="noStrike" cap="none" dirty="0">
+                <a:solidFill>
+                  <a:schemeClr val="dk1"/>
+                </a:solidFill>
+                <a:latin typeface="Calibri"/>
+                <a:ea typeface="Calibri"/>
+                <a:cs typeface="Calibri"/>
+                <a:sym typeface="Calibri"/>
+              </a:rPr>
+            </a:br>
+            <a:r>
+              <a:rPr lang="en-US" sz="1350" b="1" i="0" u="none" strike="noStrike" cap="none" dirty="0">
+                <a:solidFill>
+                  <a:schemeClr val="bg2">
+                    <a:lumMod val="20000"/>
+                    <a:lumOff val="80000"/>
+                  </a:schemeClr>
+                </a:solidFill>
+                <a:latin typeface="Inter"/>
+                <a:ea typeface="Inter"/>
+                <a:cs typeface="Inter"/>
+                <a:sym typeface="Inter"/>
+              </a:rPr>
+              <a:t>F1-Score:</a:t>
+            </a:r>
+            <a:r>
+              <a:rPr lang="en-US" sz="1350" b="0" i="0" u="none" strike="noStrike" cap="none" dirty="0">
+                <a:solidFill>
+                  <a:schemeClr val="bg2">
+                    <a:lumMod val="20000"/>
+                    <a:lumOff val="80000"/>
+                  </a:schemeClr>
+                </a:solidFill>
+                <a:latin typeface="Inter"/>
+                <a:ea typeface="Inter"/>
+                <a:cs typeface="Inter"/>
+                <a:sym typeface="Inter"/>
+              </a:rPr>
+              <a:t> </a:t>
+            </a:r>
+            <a:r>
+              <a:rPr lang="en-US" sz="1350" dirty="0">
+                <a:solidFill>
+                  <a:schemeClr val="bg1">
+                    <a:lumMod val="85000"/>
+                  </a:schemeClr>
+                </a:solidFill>
+                <a:latin typeface="Inter"/>
+                <a:ea typeface="Inter"/>
+                <a:cs typeface="Inter"/>
+                <a:sym typeface="Inter"/>
+              </a:rPr>
+              <a:t>82</a:t>
+            </a:r>
+            <a:r>
+              <a:rPr lang="en-US" sz="1350" b="0" i="0" u="none" strike="noStrike" cap="none" dirty="0">
+                <a:solidFill>
+                  <a:schemeClr val="bg1">
+                    <a:lumMod val="85000"/>
+                  </a:schemeClr>
+                </a:solidFill>
+                <a:latin typeface="Inter"/>
+                <a:ea typeface="Inter"/>
+                <a:cs typeface="Inter"/>
+                <a:sym typeface="Inter"/>
+              </a:rPr>
+              <a:t>%</a:t>
+            </a:r>
+          </a:p>
+        </p:txBody>
+      </p:sp>
+      <p:sp>
+        <p:nvSpPr>
+          <p:cNvPr id="15" name="Google Shape;242;p23">
+            <a:extLst>
+              <a:ext uri="{FF2B5EF4-FFF2-40B4-BE49-F238E27FC236}">
+                <a16:creationId xmlns:a16="http://schemas.microsoft.com/office/drawing/2014/main" id="{19CF970C-83E2-28D5-60F6-A997C0F054E4}"/>
+              </a:ext>
+            </a:extLst>
+          </p:cNvPr>
+          <p:cNvSpPr txBox="1"/>
+          <p:nvPr/>
+        </p:nvSpPr>
+        <p:spPr>
+          <a:xfrm>
+            <a:off x="486507" y="4193825"/>
+            <a:ext cx="2290257" cy="323165"/>
+          </a:xfrm>
+          <a:prstGeom prst="rect">
+            <a:avLst/>
+          </a:prstGeom>
+          <a:noFill/>
+          <a:ln>
+            <a:noFill/>
+          </a:ln>
+        </p:spPr>
+        <p:txBody>
+          <a:bodyPr spcFirstLastPara="1" wrap="square" lIns="0" tIns="0" rIns="0" bIns="0" anchor="t" anchorCtr="0">
+            <a:spAutoFit/>
+          </a:bodyPr>
+          <a:lstStyle/>
+          <a:p>
+            <a:pPr marL="0" marR="0" lvl="0" indent="0" algn="l" rtl="0">
+              <a:spcBef>
+                <a:spcPts val="0"/>
+              </a:spcBef>
+              <a:spcAft>
+                <a:spcPts val="0"/>
+              </a:spcAft>
+              <a:buNone/>
+            </a:pPr>
+            <a:r>
+              <a:rPr lang="en-US" sz="2100" b="1" i="0" u="none" strike="noStrike" cap="none" dirty="0">
+                <a:solidFill>
+                  <a:srgbClr val="38BDF8"/>
+                </a:solidFill>
+                <a:latin typeface="Poppins Medium"/>
+                <a:ea typeface="Poppins Medium"/>
+                <a:cs typeface="Poppins Medium"/>
+                <a:sym typeface="Poppins Medium"/>
+              </a:rPr>
+              <a:t>Random Forest</a:t>
+            </a:r>
+            <a:endParaRPr b="1" dirty="0"/>
+          </a:p>
+        </p:txBody>
+      </p:sp>
+      <p:sp>
+        <p:nvSpPr>
+          <p:cNvPr id="16" name="Google Shape;242;p23">
+            <a:extLst>
+              <a:ext uri="{FF2B5EF4-FFF2-40B4-BE49-F238E27FC236}">
+                <a16:creationId xmlns:a16="http://schemas.microsoft.com/office/drawing/2014/main" id="{64845E2F-7DCC-0985-E059-DAD73C3159EF}"/>
+              </a:ext>
+            </a:extLst>
+          </p:cNvPr>
+          <p:cNvSpPr txBox="1"/>
+          <p:nvPr/>
+        </p:nvSpPr>
+        <p:spPr>
+          <a:xfrm>
+            <a:off x="3315589" y="4515872"/>
+            <a:ext cx="2290257" cy="323165"/>
+          </a:xfrm>
+          <a:prstGeom prst="rect">
+            <a:avLst/>
+          </a:prstGeom>
+          <a:noFill/>
+          <a:ln>
+            <a:noFill/>
+          </a:ln>
+        </p:spPr>
+        <p:txBody>
+          <a:bodyPr spcFirstLastPara="1" wrap="square" lIns="0" tIns="0" rIns="0" bIns="0" anchor="t" anchorCtr="0">
+            <a:spAutoFit/>
+          </a:bodyPr>
+          <a:lstStyle/>
+          <a:p>
+            <a:pPr marL="0" marR="0" lvl="0" indent="0" algn="l" rtl="0">
+              <a:spcBef>
+                <a:spcPts val="0"/>
+              </a:spcBef>
+              <a:spcAft>
+                <a:spcPts val="0"/>
+              </a:spcAft>
+              <a:buNone/>
+            </a:pPr>
+            <a:r>
+              <a:rPr lang="en-US" sz="2100" b="0" i="0" u="none" strike="noStrike" cap="none" dirty="0">
+                <a:solidFill>
+                  <a:srgbClr val="38BDF8"/>
+                </a:solidFill>
+                <a:latin typeface="Poppins Medium"/>
+                <a:ea typeface="Poppins Medium"/>
+                <a:cs typeface="Poppins Medium"/>
+                <a:sym typeface="Poppins Medium"/>
+              </a:rPr>
+              <a:t>Stress</a:t>
+            </a:r>
+            <a:endParaRPr dirty="0"/>
+          </a:p>
+        </p:txBody>
+      </p:sp>
+      <p:sp>
+        <p:nvSpPr>
+          <p:cNvPr id="17" name="Google Shape;244;p23">
+            <a:extLst>
+              <a:ext uri="{FF2B5EF4-FFF2-40B4-BE49-F238E27FC236}">
+                <a16:creationId xmlns:a16="http://schemas.microsoft.com/office/drawing/2014/main" id="{9C5FA7D9-9000-3A53-4C50-0075A48D0216}"/>
+              </a:ext>
+            </a:extLst>
+          </p:cNvPr>
+          <p:cNvSpPr txBox="1"/>
+          <p:nvPr/>
+        </p:nvSpPr>
+        <p:spPr>
+          <a:xfrm>
+            <a:off x="3315589" y="4907638"/>
+            <a:ext cx="2918329" cy="997196"/>
+          </a:xfrm>
+          <a:prstGeom prst="rect">
+            <a:avLst/>
+          </a:prstGeom>
+          <a:noFill/>
+          <a:ln>
+            <a:noFill/>
+          </a:ln>
+        </p:spPr>
+        <p:txBody>
+          <a:bodyPr spcFirstLastPara="1" wrap="square" lIns="0" tIns="0" rIns="0" bIns="0" anchor="t" anchorCtr="0">
+            <a:spAutoFit/>
+          </a:bodyPr>
+          <a:lstStyle/>
+          <a:p>
+            <a:pPr>
+              <a:lnSpc>
+                <a:spcPct val="120000"/>
+              </a:lnSpc>
+            </a:pPr>
+            <a:r>
+              <a:rPr lang="en-US" sz="1350" b="1" dirty="0" err="1">
+                <a:solidFill>
+                  <a:schemeClr val="accent3">
+                    <a:lumMod val="40000"/>
+                    <a:lumOff val="60000"/>
+                  </a:schemeClr>
+                </a:solidFill>
+                <a:latin typeface="Inter"/>
+                <a:ea typeface="Inter"/>
+                <a:cs typeface="Inter"/>
+                <a:sym typeface="Inter"/>
+              </a:rPr>
+              <a:t>Accuratezza</a:t>
+            </a:r>
+            <a:r>
+              <a:rPr lang="en-US" sz="1350" b="1" dirty="0">
+                <a:solidFill>
+                  <a:schemeClr val="accent3">
+                    <a:lumMod val="40000"/>
+                    <a:lumOff val="60000"/>
+                  </a:schemeClr>
+                </a:solidFill>
+                <a:latin typeface="Inter"/>
+                <a:ea typeface="Inter"/>
+                <a:cs typeface="Inter"/>
+                <a:sym typeface="Inter"/>
+              </a:rPr>
+              <a:t>:</a:t>
+            </a:r>
+            <a:r>
+              <a:rPr lang="en-US" sz="1350" dirty="0">
+                <a:solidFill>
+                  <a:schemeClr val="accent3">
+                    <a:lumMod val="40000"/>
+                    <a:lumOff val="60000"/>
+                  </a:schemeClr>
+                </a:solidFill>
+                <a:latin typeface="Inter"/>
+                <a:ea typeface="Inter"/>
+                <a:cs typeface="Inter"/>
+                <a:sym typeface="Inter"/>
+              </a:rPr>
+              <a:t> </a:t>
+            </a:r>
+            <a:r>
+              <a:rPr lang="en-US" sz="1350" dirty="0">
+                <a:solidFill>
+                  <a:schemeClr val="bg1">
+                    <a:lumMod val="85000"/>
+                  </a:schemeClr>
+                </a:solidFill>
+                <a:latin typeface="Inter"/>
+                <a:ea typeface="Inter"/>
+                <a:cs typeface="Inter"/>
+                <a:sym typeface="Inter"/>
+              </a:rPr>
+              <a:t>74.16%</a:t>
+            </a:r>
+            <a:endParaRPr lang="en-US" sz="1350" b="1" dirty="0">
+              <a:solidFill>
+                <a:schemeClr val="bg2">
+                  <a:lumMod val="20000"/>
+                  <a:lumOff val="80000"/>
+                </a:schemeClr>
+              </a:solidFill>
+              <a:latin typeface="Inter"/>
+              <a:ea typeface="Inter"/>
+              <a:cs typeface="Inter"/>
+              <a:sym typeface="Inter"/>
+            </a:endParaRPr>
+          </a:p>
+          <a:p>
+            <a:pPr marL="0" marR="0" lvl="0" indent="0" algn="l" rtl="0">
+              <a:lnSpc>
+                <a:spcPct val="120000"/>
+              </a:lnSpc>
+              <a:spcBef>
+                <a:spcPts val="0"/>
+              </a:spcBef>
+              <a:spcAft>
+                <a:spcPts val="0"/>
+              </a:spcAft>
+              <a:buNone/>
+            </a:pPr>
+            <a:r>
+              <a:rPr lang="en-US" sz="1350" b="1" i="0" u="none" strike="noStrike" cap="none" dirty="0" err="1">
+                <a:solidFill>
+                  <a:schemeClr val="bg2">
+                    <a:lumMod val="20000"/>
+                    <a:lumOff val="80000"/>
+                  </a:schemeClr>
+                </a:solidFill>
+                <a:latin typeface="Inter"/>
+                <a:ea typeface="Inter"/>
+                <a:cs typeface="Inter"/>
+                <a:sym typeface="Inter"/>
+              </a:rPr>
+              <a:t>Precisione</a:t>
+            </a:r>
+            <a:r>
+              <a:rPr lang="en-US" sz="1350" b="1" i="0" u="none" strike="noStrike" cap="none" dirty="0">
+                <a:solidFill>
+                  <a:schemeClr val="bg2">
+                    <a:lumMod val="20000"/>
+                    <a:lumOff val="80000"/>
+                  </a:schemeClr>
+                </a:solidFill>
+                <a:latin typeface="Inter"/>
+                <a:ea typeface="Inter"/>
+                <a:cs typeface="Inter"/>
+                <a:sym typeface="Inter"/>
+              </a:rPr>
+              <a:t>:</a:t>
+            </a:r>
+            <a:r>
+              <a:rPr lang="en-US" sz="1350" b="0" i="0" u="none" strike="noStrike" cap="none" dirty="0">
+                <a:solidFill>
+                  <a:schemeClr val="bg2">
+                    <a:lumMod val="20000"/>
+                    <a:lumOff val="80000"/>
+                  </a:schemeClr>
+                </a:solidFill>
+                <a:latin typeface="Inter"/>
+                <a:ea typeface="Inter"/>
+                <a:cs typeface="Inter"/>
+                <a:sym typeface="Inter"/>
+              </a:rPr>
+              <a:t> </a:t>
+            </a:r>
+            <a:r>
+              <a:rPr lang="en-US" sz="1350" dirty="0">
+                <a:solidFill>
+                  <a:schemeClr val="bg1">
+                    <a:lumMod val="85000"/>
+                  </a:schemeClr>
+                </a:solidFill>
+                <a:latin typeface="Inter"/>
+                <a:ea typeface="Inter"/>
+                <a:cs typeface="Inter"/>
+                <a:sym typeface="Inter"/>
+              </a:rPr>
+              <a:t>75</a:t>
+            </a:r>
+            <a:r>
+              <a:rPr lang="en-US" sz="1350" b="0" i="0" u="none" strike="noStrike" cap="none" dirty="0">
+                <a:solidFill>
+                  <a:schemeClr val="bg1">
+                    <a:lumMod val="85000"/>
+                  </a:schemeClr>
+                </a:solidFill>
+                <a:latin typeface="Inter"/>
+                <a:ea typeface="Inter"/>
+                <a:cs typeface="Inter"/>
+                <a:sym typeface="Inter"/>
+              </a:rPr>
+              <a:t>%</a:t>
+            </a:r>
+            <a:br>
+              <a:rPr lang="en-US" sz="1800" b="0" i="0" u="none" strike="noStrike" cap="none" dirty="0">
+                <a:solidFill>
+                  <a:schemeClr val="dk1"/>
+                </a:solidFill>
+                <a:latin typeface="Calibri"/>
+                <a:ea typeface="Calibri"/>
+                <a:cs typeface="Calibri"/>
+                <a:sym typeface="Calibri"/>
+              </a:rPr>
+            </a:br>
+            <a:r>
+              <a:rPr lang="en-US" sz="1350" b="1" i="0" u="none" strike="noStrike" cap="none" dirty="0">
+                <a:solidFill>
+                  <a:schemeClr val="bg2">
+                    <a:lumMod val="20000"/>
+                    <a:lumOff val="80000"/>
+                  </a:schemeClr>
+                </a:solidFill>
+                <a:latin typeface="Inter"/>
+                <a:ea typeface="Inter"/>
+                <a:cs typeface="Inter"/>
+                <a:sym typeface="Inter"/>
+              </a:rPr>
+              <a:t>Recall:</a:t>
+            </a:r>
+            <a:r>
+              <a:rPr lang="en-US" sz="1350" b="0" i="0" u="none" strike="noStrike" cap="none" dirty="0">
+                <a:solidFill>
+                  <a:schemeClr val="bg2">
+                    <a:lumMod val="20000"/>
+                    <a:lumOff val="80000"/>
+                  </a:schemeClr>
+                </a:solidFill>
+                <a:latin typeface="Inter"/>
+                <a:ea typeface="Inter"/>
+                <a:cs typeface="Inter"/>
+                <a:sym typeface="Inter"/>
+              </a:rPr>
+              <a:t> </a:t>
+            </a:r>
+            <a:r>
+              <a:rPr lang="en-US" sz="1350" dirty="0">
+                <a:solidFill>
+                  <a:schemeClr val="bg1">
+                    <a:lumMod val="85000"/>
+                  </a:schemeClr>
+                </a:solidFill>
+                <a:latin typeface="Inter"/>
+                <a:ea typeface="Inter"/>
+                <a:cs typeface="Inter"/>
+                <a:sym typeface="Inter"/>
+              </a:rPr>
+              <a:t>90</a:t>
+            </a:r>
+            <a:r>
+              <a:rPr lang="en-US" sz="1350" b="0" i="0" u="none" strike="noStrike" cap="none" dirty="0">
+                <a:solidFill>
+                  <a:schemeClr val="bg1">
+                    <a:lumMod val="85000"/>
+                  </a:schemeClr>
+                </a:solidFill>
+                <a:latin typeface="Inter"/>
+                <a:ea typeface="Inter"/>
+                <a:cs typeface="Inter"/>
+                <a:sym typeface="Inter"/>
+              </a:rPr>
+              <a:t>%</a:t>
+            </a:r>
+            <a:br>
+              <a:rPr lang="en-US" sz="1800" b="0" i="0" u="none" strike="noStrike" cap="none" dirty="0">
+                <a:solidFill>
+                  <a:schemeClr val="dk1"/>
+                </a:solidFill>
+                <a:latin typeface="Calibri"/>
+                <a:ea typeface="Calibri"/>
+                <a:cs typeface="Calibri"/>
+                <a:sym typeface="Calibri"/>
+              </a:rPr>
+            </a:br>
+            <a:r>
+              <a:rPr lang="en-US" sz="1350" b="1" i="0" u="none" strike="noStrike" cap="none" dirty="0">
+                <a:solidFill>
+                  <a:schemeClr val="bg2">
+                    <a:lumMod val="20000"/>
+                    <a:lumOff val="80000"/>
+                  </a:schemeClr>
+                </a:solidFill>
+                <a:latin typeface="Inter"/>
+                <a:ea typeface="Inter"/>
+                <a:cs typeface="Inter"/>
+                <a:sym typeface="Inter"/>
+              </a:rPr>
+              <a:t>F1-Score:</a:t>
+            </a:r>
+            <a:r>
+              <a:rPr lang="en-US" sz="1350" b="0" i="0" u="none" strike="noStrike" cap="none" dirty="0">
+                <a:solidFill>
+                  <a:schemeClr val="bg2">
+                    <a:lumMod val="20000"/>
+                    <a:lumOff val="80000"/>
+                  </a:schemeClr>
+                </a:solidFill>
+                <a:latin typeface="Inter"/>
+                <a:ea typeface="Inter"/>
+                <a:cs typeface="Inter"/>
+                <a:sym typeface="Inter"/>
+              </a:rPr>
+              <a:t> </a:t>
+            </a:r>
+            <a:r>
+              <a:rPr lang="en-US" sz="1350" dirty="0">
+                <a:solidFill>
+                  <a:schemeClr val="bg1">
+                    <a:lumMod val="85000"/>
+                  </a:schemeClr>
+                </a:solidFill>
+                <a:latin typeface="Inter"/>
+                <a:ea typeface="Inter"/>
+                <a:cs typeface="Inter"/>
+                <a:sym typeface="Inter"/>
+              </a:rPr>
+              <a:t>82</a:t>
+            </a:r>
+            <a:r>
+              <a:rPr lang="en-US" sz="1350" b="0" i="0" u="none" strike="noStrike" cap="none" dirty="0">
+                <a:solidFill>
+                  <a:schemeClr val="bg1">
+                    <a:lumMod val="85000"/>
+                  </a:schemeClr>
+                </a:solidFill>
+                <a:latin typeface="Inter"/>
+                <a:ea typeface="Inter"/>
+                <a:cs typeface="Inter"/>
+                <a:sym typeface="Inter"/>
+              </a:rPr>
+              <a:t>%</a:t>
+            </a:r>
+          </a:p>
+        </p:txBody>
+      </p:sp>
+      <p:sp>
+        <p:nvSpPr>
+          <p:cNvPr id="18" name="Google Shape;242;p23">
+            <a:extLst>
+              <a:ext uri="{FF2B5EF4-FFF2-40B4-BE49-F238E27FC236}">
+                <a16:creationId xmlns:a16="http://schemas.microsoft.com/office/drawing/2014/main" id="{9978A342-2A96-7717-809E-C1FE390BF954}"/>
+              </a:ext>
+            </a:extLst>
+          </p:cNvPr>
+          <p:cNvSpPr txBox="1"/>
+          <p:nvPr/>
+        </p:nvSpPr>
+        <p:spPr>
+          <a:xfrm>
+            <a:off x="3315590" y="4193825"/>
+            <a:ext cx="2290257" cy="323165"/>
+          </a:xfrm>
+          <a:prstGeom prst="rect">
+            <a:avLst/>
+          </a:prstGeom>
+          <a:noFill/>
+          <a:ln>
+            <a:noFill/>
+          </a:ln>
+        </p:spPr>
+        <p:txBody>
+          <a:bodyPr spcFirstLastPara="1" wrap="square" lIns="0" tIns="0" rIns="0" bIns="0" anchor="t" anchorCtr="0">
+            <a:spAutoFit/>
+          </a:bodyPr>
+          <a:lstStyle/>
+          <a:p>
+            <a:pPr marL="0" marR="0" lvl="0" indent="0" algn="l" rtl="0">
+              <a:spcBef>
+                <a:spcPts val="0"/>
+              </a:spcBef>
+              <a:spcAft>
+                <a:spcPts val="0"/>
+              </a:spcAft>
+              <a:buNone/>
+            </a:pPr>
+            <a:r>
+              <a:rPr lang="en-US" sz="2100" b="1" i="0" u="none" strike="noStrike" cap="none" dirty="0">
+                <a:solidFill>
+                  <a:srgbClr val="38BDF8"/>
+                </a:solidFill>
+                <a:latin typeface="Poppins Medium"/>
+                <a:ea typeface="Poppins Medium"/>
+                <a:cs typeface="Poppins Medium"/>
+                <a:sym typeface="Poppins Medium"/>
+              </a:rPr>
+              <a:t>SVM (</a:t>
+            </a:r>
+            <a:r>
+              <a:rPr lang="en-US" sz="2100" b="1" i="0" u="none" strike="noStrike" cap="none" dirty="0" err="1">
+                <a:solidFill>
+                  <a:srgbClr val="38BDF8"/>
+                </a:solidFill>
+                <a:latin typeface="Poppins Medium"/>
+                <a:ea typeface="Poppins Medium"/>
+                <a:cs typeface="Poppins Medium"/>
+                <a:sym typeface="Poppins Medium"/>
+              </a:rPr>
+              <a:t>Cubica</a:t>
+            </a:r>
+            <a:r>
+              <a:rPr lang="en-US" sz="2100" b="1" i="0" u="none" strike="noStrike" cap="none" dirty="0">
+                <a:solidFill>
+                  <a:srgbClr val="38BDF8"/>
+                </a:solidFill>
+                <a:latin typeface="Poppins Medium"/>
+                <a:ea typeface="Poppins Medium"/>
+                <a:cs typeface="Poppins Medium"/>
+                <a:sym typeface="Poppins Medium"/>
+              </a:rPr>
+              <a:t>)</a:t>
+            </a:r>
+            <a:endParaRPr b="1" dirty="0"/>
+          </a:p>
+        </p:txBody>
+      </p:sp>
+      <p:sp>
+        <p:nvSpPr>
+          <p:cNvPr id="19" name="Google Shape;242;p23">
+            <a:extLst>
+              <a:ext uri="{FF2B5EF4-FFF2-40B4-BE49-F238E27FC236}">
+                <a16:creationId xmlns:a16="http://schemas.microsoft.com/office/drawing/2014/main" id="{EB065E2A-212A-B233-748D-4B3A28366D58}"/>
+              </a:ext>
+            </a:extLst>
+          </p:cNvPr>
+          <p:cNvSpPr txBox="1"/>
+          <p:nvPr/>
+        </p:nvSpPr>
+        <p:spPr>
+          <a:xfrm>
+            <a:off x="5886498" y="4525298"/>
+            <a:ext cx="2290257" cy="323165"/>
+          </a:xfrm>
+          <a:prstGeom prst="rect">
+            <a:avLst/>
+          </a:prstGeom>
+          <a:noFill/>
+          <a:ln>
+            <a:noFill/>
+          </a:ln>
+        </p:spPr>
+        <p:txBody>
+          <a:bodyPr spcFirstLastPara="1" wrap="square" lIns="0" tIns="0" rIns="0" bIns="0" anchor="t" anchorCtr="0">
+            <a:spAutoFit/>
+          </a:bodyPr>
+          <a:lstStyle/>
+          <a:p>
+            <a:pPr marL="0" marR="0" lvl="0" indent="0" algn="l" rtl="0">
+              <a:spcBef>
+                <a:spcPts val="0"/>
+              </a:spcBef>
+              <a:spcAft>
+                <a:spcPts val="0"/>
+              </a:spcAft>
+              <a:buNone/>
+            </a:pPr>
+            <a:r>
+              <a:rPr lang="en-US" sz="2100" b="0" i="0" u="none" strike="noStrike" cap="none" dirty="0">
+                <a:solidFill>
+                  <a:srgbClr val="38BDF8"/>
+                </a:solidFill>
+                <a:latin typeface="Poppins Medium"/>
+                <a:ea typeface="Poppins Medium"/>
+                <a:cs typeface="Poppins Medium"/>
+                <a:sym typeface="Poppins Medium"/>
+              </a:rPr>
+              <a:t>Stress</a:t>
+            </a:r>
+            <a:endParaRPr dirty="0"/>
+          </a:p>
+        </p:txBody>
+      </p:sp>
+      <p:sp>
+        <p:nvSpPr>
+          <p:cNvPr id="20" name="Google Shape;244;p23">
+            <a:extLst>
+              <a:ext uri="{FF2B5EF4-FFF2-40B4-BE49-F238E27FC236}">
+                <a16:creationId xmlns:a16="http://schemas.microsoft.com/office/drawing/2014/main" id="{AEA4055E-A3DC-15E1-679A-981D1D4B12E4}"/>
+              </a:ext>
+            </a:extLst>
+          </p:cNvPr>
+          <p:cNvSpPr txBox="1"/>
+          <p:nvPr/>
+        </p:nvSpPr>
+        <p:spPr>
+          <a:xfrm>
+            <a:off x="5886498" y="4891474"/>
+            <a:ext cx="2918329" cy="997196"/>
+          </a:xfrm>
+          <a:prstGeom prst="rect">
+            <a:avLst/>
+          </a:prstGeom>
+          <a:noFill/>
+          <a:ln>
+            <a:noFill/>
+          </a:ln>
+        </p:spPr>
+        <p:txBody>
+          <a:bodyPr spcFirstLastPara="1" wrap="square" lIns="0" tIns="0" rIns="0" bIns="0" anchor="t" anchorCtr="0">
+            <a:spAutoFit/>
+          </a:bodyPr>
+          <a:lstStyle/>
+          <a:p>
+            <a:pPr>
+              <a:lnSpc>
+                <a:spcPct val="120000"/>
+              </a:lnSpc>
+            </a:pPr>
+            <a:r>
+              <a:rPr lang="en-US" sz="1350" b="1" dirty="0" err="1">
+                <a:solidFill>
+                  <a:schemeClr val="accent3">
+                    <a:lumMod val="40000"/>
+                    <a:lumOff val="60000"/>
+                  </a:schemeClr>
+                </a:solidFill>
+                <a:latin typeface="Inter"/>
+                <a:ea typeface="Inter"/>
+                <a:cs typeface="Inter"/>
+                <a:sym typeface="Inter"/>
+              </a:rPr>
+              <a:t>Accuratezza</a:t>
+            </a:r>
+            <a:r>
+              <a:rPr lang="en-US" sz="1350" b="1" dirty="0">
+                <a:solidFill>
+                  <a:schemeClr val="accent3">
+                    <a:lumMod val="40000"/>
+                    <a:lumOff val="60000"/>
+                  </a:schemeClr>
+                </a:solidFill>
+                <a:latin typeface="Inter"/>
+                <a:ea typeface="Inter"/>
+                <a:cs typeface="Inter"/>
+                <a:sym typeface="Inter"/>
+              </a:rPr>
+              <a:t>:</a:t>
+            </a:r>
+            <a:r>
+              <a:rPr lang="en-US" sz="1350" dirty="0">
+                <a:solidFill>
+                  <a:schemeClr val="accent3">
+                    <a:lumMod val="40000"/>
+                    <a:lumOff val="60000"/>
+                  </a:schemeClr>
+                </a:solidFill>
+                <a:latin typeface="Inter"/>
+                <a:ea typeface="Inter"/>
+                <a:cs typeface="Inter"/>
+                <a:sym typeface="Inter"/>
+              </a:rPr>
+              <a:t> </a:t>
+            </a:r>
+            <a:r>
+              <a:rPr lang="en-US" sz="1350" dirty="0">
+                <a:solidFill>
+                  <a:schemeClr val="bg1">
+                    <a:lumMod val="85000"/>
+                  </a:schemeClr>
+                </a:solidFill>
+                <a:latin typeface="Inter"/>
+                <a:ea typeface="Inter"/>
+                <a:cs typeface="Inter"/>
+                <a:sym typeface="Inter"/>
+              </a:rPr>
+              <a:t>71.07%</a:t>
+            </a:r>
             <a:endParaRPr lang="en-US" sz="1350" b="1" i="0" u="none" strike="noStrike" cap="none" dirty="0">
               <a:solidFill>
                 <a:schemeClr val="bg2">
@@ -12926,7 +14559,7 @@
               <a:t> </a:t>
             </a:r>
             <a:r>
-              <a:rPr lang="en-US" sz="1350" b="0" i="0" u="none" strike="noStrike" cap="none" dirty="0">
+              <a:rPr lang="en-US" sz="1350" dirty="0">
                 <a:solidFill>
                   <a:schemeClr val="bg1">
                     <a:lumMod val="85000"/>
@@ -12937,7 +14570,21 @@
                 <a:cs typeface="Inter"/>
                 <a:sym typeface="Inter"/>
               </a:rPr>
-              <a:t>74%</a:t>
+              <a:t>87</a:t>
+            </a:r>
+            <a:r>
+              <a:rPr lang="en-US" sz="1350" b="0" i="0" u="none" strike="noStrike" cap="none" dirty="0">
+                <a:solidFill>
+                  <a:schemeClr val="bg1">
+                    <a:lumMod val="85000"/>
+                  </a:schemeClr>
+                </a:solidFill>
+                <a:latin typeface="Inter"/>
+                <a:ea typeface="Inter"/>
+                <a:cs typeface="Inter"/>
+                <a:sym typeface="Inter"/>
+              </a:rPr>
+              <a:t>%</a:t>
             </a:r>
             <a:br>
               <a:rPr lang="en-US" sz="1800" b="0" i="0" u="none" strike="noStrike" cap="none" dirty="0">
@@ -12981,7 +14628,7 @@
               <a:t> </a:t>
             </a:r>
             <a:r>
-              <a:rPr lang="en-US" sz="1350" b="0" i="0" u="none" strike="noStrike" cap="none" dirty="0">
+              <a:rPr lang="en-US" sz="1350" dirty="0">
                 <a:solidFill>
                   <a:schemeClr val="bg1">
                     <a:lumMod val="85000"/>
@@ -12992,17 +14639,31 @@
                 <a:cs typeface="Inter"/>
                 <a:sym typeface="Inter"/>
               </a:rPr>
-              <a:t>73%</a:t>
+              <a:t>79</a:t>
+            </a:r>
+            <a:r>
+              <a:rPr lang="en-US" sz="1350" b="0" i="0" u="none" strike="noStrike" cap="none" dirty="0">
+                <a:solidFill>
+                  <a:schemeClr val="bg1">
+                    <a:lumMod val="85000"/>
+                  </a:schemeClr>
+                </a:solidFill>
+                <a:latin typeface="Inter"/>
+                <a:ea typeface="Inter"/>
+                <a:cs typeface="Inter"/>
+                <a:sym typeface="Inter"/>
+              </a:rPr>
+              <a:t>%</a:t>
             </a:r>
           </a:p>
         </p:txBody>
       </p:sp>
       <p:sp>
         <p:nvSpPr>
-          <p:cNvPr id="14" name="Google Shape;242;p23">
+          <p:cNvPr id="21" name="Google Shape;242;p23">
             <a:extLst>
               <a:ext uri="{FF2B5EF4-FFF2-40B4-BE49-F238E27FC236}">
-                <a16:creationId xmlns:a16="http://schemas.microsoft.com/office/drawing/2014/main" id="{19386B87-908C-40F6-EFF0-AD1CB92DECAA}"/>
+                <a16:creationId xmlns:a16="http://schemas.microsoft.com/office/drawing/2014/main" id="{53869A8C-7686-D029-DFD2-DEB163F49FC2}"/>
               </a:ext>
             </a:extLst>
           </p:cNvPr>
@@ -13011,7 +14672,7 @@
         </p:nvSpPr>
         <p:spPr>
           <a:xfrm>
-            <a:off x="8328101" y="2953948"/>
+            <a:off x="5886498" y="4177661"/>
             <a:ext cx="2598517" cy="323165"/>
           </a:xfrm>
           <a:prstGeom prst="rect">
@@ -13048,6 +14709,439 @@
                 <a:sym typeface="Poppins Medium"/>
               </a:rPr>
               <a:t>Logistic Regression</a:t>
+            </a:r>
+            <a:endParaRPr b="1" dirty="0"/>
+          </a:p>
+        </p:txBody>
+      </p:sp>
+      <p:sp>
+        <p:nvSpPr>
+          <p:cNvPr id="22" name="Google Shape;242;p23">
+            <a:extLst>
+              <a:ext uri="{FF2B5EF4-FFF2-40B4-BE49-F238E27FC236}">
+                <a16:creationId xmlns:a16="http://schemas.microsoft.com/office/drawing/2014/main" id="{97ACBC11-6E93-2047-9FB2-37AA1F318B43}"/>
+              </a:ext>
+            </a:extLst>
+          </p:cNvPr>
+          <p:cNvSpPr txBox="1"/>
+          <p:nvPr/>
+        </p:nvSpPr>
+        <p:spPr>
+          <a:xfrm>
+            <a:off x="9023841" y="4534196"/>
+            <a:ext cx="2290257" cy="323165"/>
+          </a:xfrm>
+          <a:prstGeom prst="rect">
+            <a:avLst/>
+          </a:prstGeom>
+          <a:noFill/>
+          <a:ln>
+            <a:noFill/>
+          </a:ln>
+        </p:spPr>
+        <p:txBody>
+          <a:bodyPr spcFirstLastPara="1" wrap="square" lIns="0" tIns="0" rIns="0" bIns="0" anchor="t" anchorCtr="0">
+            <a:spAutoFit/>
+          </a:bodyPr>
+          <a:lstStyle/>
+          <a:p>
+            <a:pPr marL="0" marR="0" lvl="0" indent="0" algn="l" rtl="0">
+              <a:spcBef>
+                <a:spcPts val="0"/>
+              </a:spcBef>
+              <a:spcAft>
+                <a:spcPts val="0"/>
+              </a:spcAft>
+              <a:buNone/>
+            </a:pPr>
+            <a:r>
+              <a:rPr lang="en-US" sz="2100" b="0" i="0" u="none" strike="noStrike" cap="none" dirty="0">
+                <a:solidFill>
+                  <a:srgbClr val="38BDF8"/>
+                </a:solidFill>
+                <a:latin typeface="Poppins Medium"/>
+                <a:ea typeface="Poppins Medium"/>
+                <a:cs typeface="Poppins Medium"/>
+                <a:sym typeface="Poppins Medium"/>
+              </a:rPr>
+              <a:t>Stress</a:t>
+            </a:r>
+            <a:endParaRPr dirty="0"/>
+          </a:p>
+        </p:txBody>
+      </p:sp>
+      <p:sp>
+        <p:nvSpPr>
+          <p:cNvPr id="23" name="Google Shape;244;p23">
+            <a:extLst>
+              <a:ext uri="{FF2B5EF4-FFF2-40B4-BE49-F238E27FC236}">
+                <a16:creationId xmlns:a16="http://schemas.microsoft.com/office/drawing/2014/main" id="{DDE83B2C-7292-EE31-5BCC-5B8DC47BEAB3}"/>
+              </a:ext>
+            </a:extLst>
+          </p:cNvPr>
+          <p:cNvSpPr txBox="1"/>
+          <p:nvPr/>
+        </p:nvSpPr>
+        <p:spPr>
+          <a:xfrm>
+            <a:off x="9023841" y="4900372"/>
+            <a:ext cx="2442173" cy="997196"/>
+          </a:xfrm>
+          <a:prstGeom prst="rect">
+            <a:avLst/>
+          </a:prstGeom>
+          <a:noFill/>
+          <a:ln>
+            <a:noFill/>
+          </a:ln>
+        </p:spPr>
+        <p:txBody>
+          <a:bodyPr spcFirstLastPara="1" wrap="square" lIns="0" tIns="0" rIns="0" bIns="0" anchor="t" anchorCtr="0">
+            <a:spAutoFit/>
+          </a:bodyPr>
+          <a:lstStyle/>
+          <a:p>
+            <a:pPr>
+              <a:lnSpc>
+                <a:spcPct val="120000"/>
+              </a:lnSpc>
+            </a:pPr>
+            <a:r>
+              <a:rPr lang="en-US" sz="1350" b="1" dirty="0" err="1">
+                <a:solidFill>
+                  <a:schemeClr val="accent3">
+                    <a:lumMod val="40000"/>
+                    <a:lumOff val="60000"/>
+                  </a:schemeClr>
+                </a:solidFill>
+                <a:latin typeface="Inter"/>
+                <a:ea typeface="Inter"/>
+                <a:cs typeface="Inter"/>
+                <a:sym typeface="Inter"/>
+              </a:rPr>
+              <a:t>Accuratezza</a:t>
+            </a:r>
+            <a:r>
+              <a:rPr lang="en-US" sz="1350" b="1" dirty="0">
+                <a:solidFill>
+                  <a:schemeClr val="accent3">
+                    <a:lumMod val="40000"/>
+                    <a:lumOff val="60000"/>
+                  </a:schemeClr>
+                </a:solidFill>
+                <a:latin typeface="Inter"/>
+                <a:ea typeface="Inter"/>
+                <a:cs typeface="Inter"/>
+                <a:sym typeface="Inter"/>
+              </a:rPr>
+              <a:t>:</a:t>
+            </a:r>
+            <a:r>
+              <a:rPr lang="en-US" sz="1350" dirty="0">
+                <a:solidFill>
+                  <a:schemeClr val="accent3">
+                    <a:lumMod val="40000"/>
+                    <a:lumOff val="60000"/>
+                  </a:schemeClr>
+                </a:solidFill>
+                <a:latin typeface="Inter"/>
+                <a:ea typeface="Inter"/>
+                <a:cs typeface="Inter"/>
+                <a:sym typeface="Inter"/>
+              </a:rPr>
+              <a:t> </a:t>
+            </a:r>
+            <a:r>
+              <a:rPr lang="en-US" sz="1350" dirty="0">
+                <a:solidFill>
+                  <a:schemeClr val="bg1">
+                    <a:lumMod val="85000"/>
+                  </a:schemeClr>
+                </a:solidFill>
+                <a:latin typeface="Inter"/>
+                <a:ea typeface="Inter"/>
+                <a:cs typeface="Inter"/>
+                <a:sym typeface="Inter"/>
+              </a:rPr>
+              <a:t>73.78%</a:t>
+            </a:r>
+            <a:endParaRPr lang="en-US" sz="1350" b="1" i="0" u="none" strike="noStrike" cap="none" dirty="0">
+              <a:solidFill>
+                <a:schemeClr val="bg2">
+                  <a:lumMod val="20000"/>
+                  <a:lumOff val="80000"/>
+                </a:schemeClr>
+              </a:solidFill>
+              <a:latin typeface="Inter"/>
+              <a:ea typeface="Inter"/>
+              <a:cs typeface="Inter"/>
+              <a:sym typeface="Inter"/>
+            </a:endParaRPr>
+          </a:p>
+          <a:p>
+            <a:pPr marL="0" marR="0" lvl="0" indent="0" algn="l" rtl="0">
+              <a:lnSpc>
+                <a:spcPct val="120000"/>
+              </a:lnSpc>
+              <a:spcBef>
+                <a:spcPts val="0"/>
+              </a:spcBef>
+              <a:spcAft>
+                <a:spcPts val="0"/>
+              </a:spcAft>
+              <a:buNone/>
+            </a:pPr>
+            <a:r>
+              <a:rPr lang="en-US" sz="1350" b="1" i="0" u="none" strike="noStrike" cap="none" dirty="0" err="1">
+                <a:solidFill>
+                  <a:schemeClr val="bg2">
+                    <a:lumMod val="20000"/>
+                    <a:lumOff val="80000"/>
+                  </a:schemeClr>
+                </a:solidFill>
+                <a:latin typeface="Inter"/>
+                <a:ea typeface="Inter"/>
+                <a:cs typeface="Inter"/>
+                <a:sym typeface="Inter"/>
+              </a:rPr>
+              <a:t>Precisione</a:t>
+            </a:r>
+            <a:r>
+              <a:rPr lang="en-US" sz="1350" b="1" i="0" u="none" strike="noStrike" cap="none" dirty="0">
+                <a:solidFill>
+                  <a:schemeClr val="bg2">
+                    <a:lumMod val="20000"/>
+                    <a:lumOff val="80000"/>
+                  </a:schemeClr>
+                </a:solidFill>
+                <a:latin typeface="Inter"/>
+                <a:ea typeface="Inter"/>
+                <a:cs typeface="Inter"/>
+                <a:sym typeface="Inter"/>
+              </a:rPr>
+              <a:t>:</a:t>
+            </a:r>
+            <a:r>
+              <a:rPr lang="en-US" sz="1350" b="0" i="0" u="none" strike="noStrike" cap="none" dirty="0">
+                <a:solidFill>
+                  <a:schemeClr val="bg2">
+                    <a:lumMod val="20000"/>
+                    <a:lumOff val="80000"/>
+                  </a:schemeClr>
+                </a:solidFill>
+                <a:latin typeface="Inter"/>
+                <a:ea typeface="Inter"/>
+                <a:cs typeface="Inter"/>
+                <a:sym typeface="Inter"/>
+              </a:rPr>
+              <a:t> </a:t>
+            </a:r>
+            <a:r>
+              <a:rPr lang="en-US" sz="1350" dirty="0">
+                <a:solidFill>
+                  <a:schemeClr val="bg1">
+                    <a:lumMod val="85000"/>
+                  </a:schemeClr>
+                </a:solidFill>
+                <a:latin typeface="Inter"/>
+                <a:ea typeface="Inter"/>
+                <a:cs typeface="Inter"/>
+                <a:sym typeface="Inter"/>
+              </a:rPr>
+              <a:t>78</a:t>
+            </a:r>
+            <a:r>
+              <a:rPr lang="en-US" sz="1350" b="0" i="0" u="none" strike="noStrike" cap="none" dirty="0">
+                <a:solidFill>
+                  <a:schemeClr val="bg1">
+                    <a:lumMod val="85000"/>
+                  </a:schemeClr>
+                </a:solidFill>
+                <a:latin typeface="Inter"/>
+                <a:ea typeface="Inter"/>
+                <a:cs typeface="Inter"/>
+                <a:sym typeface="Inter"/>
+              </a:rPr>
+              <a:t>%</a:t>
+            </a:r>
+            <a:br>
+              <a:rPr lang="en-US" sz="1800" b="0" i="0" u="none" strike="noStrike" cap="none" dirty="0">
+                <a:solidFill>
+                  <a:schemeClr val="dk1"/>
+                </a:solidFill>
+                <a:latin typeface="Calibri"/>
+                <a:ea typeface="Calibri"/>
+                <a:cs typeface="Calibri"/>
+                <a:sym typeface="Calibri"/>
+              </a:rPr>
+            </a:br>
+            <a:r>
+              <a:rPr lang="en-US" sz="1350" b="1" i="0" u="none" strike="noStrike" cap="none" dirty="0">
+                <a:solidFill>
+                  <a:schemeClr val="bg2">
+                    <a:lumMod val="20000"/>
+                    <a:lumOff val="80000"/>
+                  </a:schemeClr>
+                </a:solidFill>
+                <a:latin typeface="Inter"/>
+                <a:ea typeface="Inter"/>
+                <a:cs typeface="Inter"/>
+                <a:sym typeface="Inter"/>
+              </a:rPr>
+              <a:t>Recall:</a:t>
+            </a:r>
+            <a:r>
+              <a:rPr lang="en-US" sz="1350" b="0" i="0" u="none" strike="noStrike" cap="none" dirty="0">
+                <a:solidFill>
+                  <a:schemeClr val="bg2">
+                    <a:lumMod val="20000"/>
+                    <a:lumOff val="80000"/>
+                  </a:schemeClr>
+                </a:solidFill>
+                <a:latin typeface="Inter"/>
+                <a:ea typeface="Inter"/>
+                <a:cs typeface="Inter"/>
+                <a:sym typeface="Inter"/>
+              </a:rPr>
+              <a:t> </a:t>
+            </a:r>
+            <a:r>
+              <a:rPr lang="en-US" sz="1350" dirty="0">
+                <a:solidFill>
+                  <a:schemeClr val="bg1">
+                    <a:lumMod val="85000"/>
+                  </a:schemeClr>
+                </a:solidFill>
+                <a:latin typeface="Inter"/>
+                <a:ea typeface="Inter"/>
+                <a:cs typeface="Inter"/>
+                <a:sym typeface="Inter"/>
+              </a:rPr>
+              <a:t>83</a:t>
+            </a:r>
+            <a:r>
+              <a:rPr lang="en-US" sz="1350" b="0" i="0" u="none" strike="noStrike" cap="none" dirty="0">
+                <a:solidFill>
+                  <a:schemeClr val="bg1">
+                    <a:lumMod val="85000"/>
+                  </a:schemeClr>
+                </a:solidFill>
+                <a:latin typeface="Inter"/>
+                <a:ea typeface="Inter"/>
+                <a:cs typeface="Inter"/>
+                <a:sym typeface="Inter"/>
+              </a:rPr>
+              <a:t>%</a:t>
+            </a:r>
+            <a:br>
+              <a:rPr lang="en-US" sz="1800" b="0" i="0" u="none" strike="noStrike" cap="none" dirty="0">
+                <a:solidFill>
+                  <a:schemeClr val="dk1"/>
+                </a:solidFill>
+                <a:latin typeface="Calibri"/>
+                <a:ea typeface="Calibri"/>
+                <a:cs typeface="Calibri"/>
+                <a:sym typeface="Calibri"/>
+              </a:rPr>
+            </a:br>
+            <a:r>
+              <a:rPr lang="en-US" sz="1350" b="1" i="0" u="none" strike="noStrike" cap="none" dirty="0">
+                <a:solidFill>
+                  <a:schemeClr val="bg2">
+                    <a:lumMod val="20000"/>
+                    <a:lumOff val="80000"/>
+                  </a:schemeClr>
+                </a:solidFill>
+                <a:latin typeface="Inter"/>
+                <a:ea typeface="Inter"/>
+                <a:cs typeface="Inter"/>
+                <a:sym typeface="Inter"/>
+              </a:rPr>
+              <a:t>F1-Score:</a:t>
+            </a:r>
+            <a:r>
+              <a:rPr lang="en-US" sz="1350" b="0" i="0" u="none" strike="noStrike" cap="none" dirty="0">
+                <a:solidFill>
+                  <a:schemeClr val="bg2">
+                    <a:lumMod val="20000"/>
+                    <a:lumOff val="80000"/>
+                  </a:schemeClr>
+                </a:solidFill>
+                <a:latin typeface="Inter"/>
+                <a:ea typeface="Inter"/>
+                <a:cs typeface="Inter"/>
+                <a:sym typeface="Inter"/>
+              </a:rPr>
+              <a:t> </a:t>
+            </a:r>
+            <a:r>
+              <a:rPr lang="en-US" sz="1350" b="0" i="0" u="none" strike="noStrike" cap="none" dirty="0">
+                <a:solidFill>
+                  <a:schemeClr val="bg1">
+                    <a:lumMod val="85000"/>
+                  </a:schemeClr>
+                </a:solidFill>
+                <a:latin typeface="Inter"/>
+                <a:ea typeface="Inter"/>
+                <a:cs typeface="Inter"/>
+                <a:sym typeface="Inter"/>
+              </a:rPr>
+              <a:t>80%</a:t>
+            </a:r>
+          </a:p>
+        </p:txBody>
+      </p:sp>
+      <p:sp>
+        <p:nvSpPr>
+          <p:cNvPr id="24" name="Google Shape;242;p23">
+            <a:extLst>
+              <a:ext uri="{FF2B5EF4-FFF2-40B4-BE49-F238E27FC236}">
+                <a16:creationId xmlns:a16="http://schemas.microsoft.com/office/drawing/2014/main" id="{3BB401BA-7DF0-1634-47FF-96BAF1073E89}"/>
+              </a:ext>
+            </a:extLst>
+          </p:cNvPr>
+          <p:cNvSpPr txBox="1"/>
+          <p:nvPr/>
+        </p:nvSpPr>
+        <p:spPr>
+          <a:xfrm>
+            <a:off x="9023841" y="4186559"/>
+            <a:ext cx="2598517" cy="323165"/>
+          </a:xfrm>
+          <a:prstGeom prst="rect">
+            <a:avLst/>
+          </a:prstGeom>
+          <a:noFill/>
+          <a:ln>
+            <a:noFill/>
+          </a:ln>
+        </p:spPr>
+        <p:txBody>
+          <a:bodyPr spcFirstLastPara="1" wrap="square" lIns="0" tIns="0" rIns="0" bIns="0" anchor="t" anchorCtr="0">
+            <a:spAutoFit/>
+          </a:bodyPr>
+          <a:lstStyle/>
+          <a:p>
+            <a:pPr marL="0" marR="0" lvl="0" indent="0" algn="l" rtl="0">
+              <a:spcBef>
+                <a:spcPts val="0"/>
+              </a:spcBef>
+              <a:spcAft>
+                <a:spcPts val="0"/>
+              </a:spcAft>
+              <a:buNone/>
+            </a:pPr>
+            <a:r>
+              <a:rPr lang="en-US" sz="2100" b="1" i="0" u="none" strike="noStrike" cap="none" dirty="0" err="1">
+                <a:solidFill>
+                  <a:srgbClr val="38BDF8"/>
+                </a:solidFill>
+                <a:latin typeface="Poppins Medium"/>
+                <a:ea typeface="Poppins Medium"/>
+                <a:cs typeface="Poppins Medium"/>
+                <a:sym typeface="Poppins Medium"/>
+              </a:rPr>
+              <a:t>RUSBoost</a:t>
             </a:r>
             <a:endParaRPr b="1" dirty="0"/>
           </a:p>
@@ -13067,6 +15161,412 @@
 </file>
 
 <file path=ppt/slides/slide11.xml><?xml version="1.0" encoding="utf-8"?>
+<p:sld xmlns:a="http://schemas.openxmlformats.org/drawingml/2006/main" xmlns:r="http://schemas.openxmlformats.org/officeDocument/2006/relationships" xmlns:p="http://schemas.openxmlformats.org/presentationml/2006/main">
+  <p:cSld>
+    <p:bg>
+      <p:bgPr>
+        <a:solidFill>
+          <a:srgbClr val="111827"/>
+        </a:solidFill>
+        <a:effectLst/>
+      </p:bgPr>
+    </p:bg>
+    <p:spTree>
+      <p:nvGrpSpPr>
+        <p:cNvPr id="1" name="Shape 238">
+          <a:extLst>
+            <a:ext uri="{FF2B5EF4-FFF2-40B4-BE49-F238E27FC236}">
+              <a16:creationId xmlns:a16="http://schemas.microsoft.com/office/drawing/2014/main" id="{B962F93B-3165-2B10-50E5-ECB0A527F90A}"/>
+            </a:ext>
+          </a:extLst>
+        </p:cNvPr>
+        <p:cNvGrpSpPr/>
+        <p:nvPr/>
+      </p:nvGrpSpPr>
+      <p:grpSpPr>
+        <a:xfrm>
+          <a:off x="0" y="0"/>
+          <a:ext cx="0" cy="0"/>
+          <a:chOff x="0" y="0"/>
+          <a:chExt cx="0" cy="0"/>
+        </a:xfrm>
+      </p:grpSpPr>
+      <p:pic>
+        <p:nvPicPr>
+          <p:cNvPr id="239" name="Google Shape;239;p23" descr="image.png">
+            <a:extLst>
+              <a:ext uri="{FF2B5EF4-FFF2-40B4-BE49-F238E27FC236}">
+                <a16:creationId xmlns:a16="http://schemas.microsoft.com/office/drawing/2014/main" id="{C0EAC803-6B45-4FEC-8942-FCEAC0A5E41E}"/>
+              </a:ext>
+            </a:extLst>
+          </p:cNvPr>
+          <p:cNvPicPr preferRelativeResize="0"/>
+          <p:nvPr/>
+        </p:nvPicPr>
+        <p:blipFill rotWithShape="1">
+          <a:blip r:embed="rId3">
+            <a:alphaModFix/>
+          </a:blip>
+          <a:srcRect/>
+          <a:stretch/>
+        </p:blipFill>
+        <p:spPr>
+          <a:xfrm>
+            <a:off x="0" y="0"/>
+            <a:ext cx="12192000" cy="6858000"/>
+          </a:xfrm>
+          <a:prstGeom prst="rect">
+            <a:avLst/>
+          </a:prstGeom>
+          <a:noFill/>
+          <a:ln>
+            <a:noFill/>
+          </a:ln>
+        </p:spPr>
+      </p:pic>
+      <p:sp>
+        <p:nvSpPr>
+          <p:cNvPr id="246" name="Google Shape;246;p23">
+            <a:extLst>
+              <a:ext uri="{FF2B5EF4-FFF2-40B4-BE49-F238E27FC236}">
+                <a16:creationId xmlns:a16="http://schemas.microsoft.com/office/drawing/2014/main" id="{7E08B28F-80D9-593E-F8C8-F568FC642319}"/>
+              </a:ext>
+            </a:extLst>
+          </p:cNvPr>
+          <p:cNvSpPr txBox="1"/>
+          <p:nvPr/>
+        </p:nvSpPr>
+        <p:spPr>
+          <a:xfrm>
+            <a:off x="571500" y="571500"/>
+            <a:ext cx="10355118" cy="461665"/>
+          </a:xfrm>
+          <a:prstGeom prst="rect">
+            <a:avLst/>
+          </a:prstGeom>
+          <a:noFill/>
+          <a:ln>
+            <a:noFill/>
+          </a:ln>
+        </p:spPr>
+        <p:txBody>
+          <a:bodyPr spcFirstLastPara="1" wrap="square" lIns="0" tIns="0" rIns="0" bIns="0" anchor="t" anchorCtr="0">
+            <a:spAutoFit/>
+          </a:bodyPr>
+          <a:lstStyle/>
+          <a:p>
+            <a:pPr marL="0" marR="0" lvl="0" indent="0" algn="l" rtl="0">
+              <a:spcBef>
+                <a:spcPts val="0"/>
+              </a:spcBef>
+              <a:spcAft>
+                <a:spcPts val="0"/>
+              </a:spcAft>
+              <a:buNone/>
+            </a:pPr>
+            <a:r>
+              <a:rPr lang="it-IT" sz="3000" b="0" i="0" u="none" strike="noStrike" cap="none" dirty="0">
+                <a:solidFill>
+                  <a:schemeClr val="bg1"/>
+                </a:solidFill>
+                <a:latin typeface="Poppins SemiBold"/>
+                <a:ea typeface="Poppins SemiBold"/>
+                <a:cs typeface="Poppins SemiBold"/>
+                <a:sym typeface="Poppins SemiBold"/>
+              </a:rPr>
+              <a:t>Matrici di confusione a confronto (Sperimentale)</a:t>
+            </a:r>
+            <a:endParaRPr lang="it-IT" dirty="0">
+              <a:solidFill>
+                <a:schemeClr val="bg1"/>
+              </a:solidFill>
+            </a:endParaRPr>
+          </a:p>
+        </p:txBody>
+      </p:sp>
+      <p:sp>
+        <p:nvSpPr>
+          <p:cNvPr id="5" name="Google Shape;94;p14">
+            <a:extLst>
+              <a:ext uri="{FF2B5EF4-FFF2-40B4-BE49-F238E27FC236}">
+                <a16:creationId xmlns:a16="http://schemas.microsoft.com/office/drawing/2014/main" id="{25730225-4782-4493-AC1B-59A1F0F48F5F}"/>
+              </a:ext>
+            </a:extLst>
+          </p:cNvPr>
+          <p:cNvSpPr txBox="1"/>
+          <p:nvPr/>
+        </p:nvSpPr>
+        <p:spPr>
+          <a:xfrm>
+            <a:off x="571499" y="1080720"/>
+            <a:ext cx="10355118" cy="332399"/>
+          </a:xfrm>
+          <a:prstGeom prst="rect">
+            <a:avLst/>
+          </a:prstGeom>
+          <a:noFill/>
+          <a:ln>
+            <a:noFill/>
+          </a:ln>
+        </p:spPr>
+        <p:txBody>
+          <a:bodyPr spcFirstLastPara="1" wrap="square" lIns="0" tIns="0" rIns="0" bIns="0" anchor="t" anchorCtr="0">
+            <a:spAutoFit/>
+          </a:bodyPr>
+          <a:lstStyle/>
+          <a:p>
+            <a:pPr marL="0" marR="0" lvl="0" indent="0" algn="l" rtl="0">
+              <a:lnSpc>
+                <a:spcPct val="160000"/>
+              </a:lnSpc>
+              <a:spcBef>
+                <a:spcPts val="0"/>
+              </a:spcBef>
+              <a:spcAft>
+                <a:spcPts val="0"/>
+              </a:spcAft>
+              <a:buNone/>
+            </a:pPr>
+            <a:r>
+              <a:rPr lang="it-IT" sz="1350" b="0" i="0" u="none" strike="noStrike" cap="none" dirty="0">
+                <a:solidFill>
+                  <a:srgbClr val="CBD5E1"/>
+                </a:solidFill>
+                <a:latin typeface="Inter"/>
+                <a:ea typeface="Inter"/>
+                <a:cs typeface="Inter"/>
+                <a:sym typeface="Inter"/>
+              </a:rPr>
+              <a:t>Rispettivamente: RF (</a:t>
+            </a:r>
+            <a:r>
+              <a:rPr lang="it-IT" sz="1350" dirty="0">
+                <a:solidFill>
+                  <a:srgbClr val="CBD5E1"/>
+                </a:solidFill>
+                <a:latin typeface="Inter"/>
+                <a:ea typeface="Inter"/>
+                <a:cs typeface="Inter"/>
+                <a:sym typeface="Inter"/>
+              </a:rPr>
+              <a:t>75</a:t>
+            </a:r>
+            <a:r>
+              <a:rPr lang="it-IT" sz="1350" b="0" i="0" u="none" strike="noStrike" cap="none" dirty="0">
+                <a:solidFill>
+                  <a:srgbClr val="CBD5E1"/>
+                </a:solidFill>
+                <a:latin typeface="Inter"/>
+                <a:ea typeface="Inter"/>
+                <a:cs typeface="Inter"/>
+                <a:sym typeface="Inter"/>
+              </a:rPr>
+              <a:t> </a:t>
+            </a:r>
+            <a:r>
+              <a:rPr lang="it-IT" sz="1350" b="0" i="0" u="none" strike="noStrike" cap="none" dirty="0" err="1">
+                <a:solidFill>
+                  <a:srgbClr val="CBD5E1"/>
+                </a:solidFill>
+                <a:latin typeface="Inter"/>
+                <a:ea typeface="Inter"/>
+                <a:cs typeface="Inter"/>
+                <a:sym typeface="Inter"/>
+              </a:rPr>
+              <a:t>Learners</a:t>
+            </a:r>
+            <a:r>
+              <a:rPr lang="it-IT" sz="1350" b="0" i="0" u="none" strike="noStrike" cap="none" dirty="0">
+                <a:solidFill>
+                  <a:srgbClr val="CBD5E1"/>
+                </a:solidFill>
+                <a:latin typeface="Inter"/>
+                <a:ea typeface="Inter"/>
+                <a:cs typeface="Inter"/>
+                <a:sym typeface="Inter"/>
+              </a:rPr>
+              <a:t>, 750 </a:t>
+            </a:r>
+            <a:r>
+              <a:rPr lang="it-IT" sz="1350" b="0" i="0" u="none" strike="noStrike" cap="none" dirty="0" err="1">
+                <a:solidFill>
+                  <a:srgbClr val="CBD5E1"/>
+                </a:solidFill>
+                <a:latin typeface="Inter"/>
+                <a:ea typeface="Inter"/>
+                <a:cs typeface="Inter"/>
+                <a:sym typeface="Inter"/>
+              </a:rPr>
+              <a:t>Splits</a:t>
+            </a:r>
+            <a:r>
+              <a:rPr lang="it-IT" sz="1350" b="0" i="0" u="none" strike="noStrike" cap="none" dirty="0">
+                <a:solidFill>
+                  <a:srgbClr val="CBD5E1"/>
+                </a:solidFill>
+                <a:latin typeface="Inter"/>
+                <a:ea typeface="Inter"/>
+                <a:cs typeface="Inter"/>
+                <a:sym typeface="Inter"/>
+              </a:rPr>
+              <a:t>), SVM (Kernel Cubico), </a:t>
+            </a:r>
+            <a:r>
+              <a:rPr lang="it-IT" sz="1350" b="0" i="0" u="none" strike="noStrike" cap="none" dirty="0" err="1">
+                <a:solidFill>
+                  <a:srgbClr val="CBD5E1"/>
+                </a:solidFill>
+                <a:latin typeface="Inter"/>
+                <a:ea typeface="Inter"/>
+                <a:cs typeface="Inter"/>
+                <a:sym typeface="Inter"/>
+              </a:rPr>
+              <a:t>Logistic</a:t>
+            </a:r>
+            <a:r>
+              <a:rPr lang="it-IT" sz="1350" b="0" i="0" u="none" strike="noStrike" cap="none" dirty="0">
+                <a:solidFill>
+                  <a:srgbClr val="CBD5E1"/>
+                </a:solidFill>
+                <a:latin typeface="Inter"/>
+                <a:ea typeface="Inter"/>
+                <a:cs typeface="Inter"/>
+                <a:sym typeface="Inter"/>
+              </a:rPr>
+              <a:t> </a:t>
+            </a:r>
+            <a:r>
+              <a:rPr lang="it-IT" sz="1350" b="0" i="0" u="none" strike="noStrike" cap="none" dirty="0" err="1">
+                <a:solidFill>
+                  <a:srgbClr val="CBD5E1"/>
+                </a:solidFill>
+                <a:latin typeface="Inter"/>
+                <a:ea typeface="Inter"/>
+                <a:cs typeface="Inter"/>
+                <a:sym typeface="Inter"/>
+              </a:rPr>
+              <a:t>Regression</a:t>
+            </a:r>
+            <a:r>
+              <a:rPr lang="it-IT" sz="1350" b="0" i="0" u="none" strike="noStrike" cap="none" dirty="0">
+                <a:solidFill>
+                  <a:srgbClr val="CBD5E1"/>
+                </a:solidFill>
+                <a:latin typeface="Inter"/>
+                <a:ea typeface="Inter"/>
+                <a:cs typeface="Inter"/>
+                <a:sym typeface="Inter"/>
+              </a:rPr>
+              <a:t> e </a:t>
+            </a:r>
+            <a:r>
+              <a:rPr lang="it-IT" sz="1350" b="0" i="0" u="none" strike="noStrike" cap="none" dirty="0" err="1">
+                <a:solidFill>
+                  <a:srgbClr val="CBD5E1"/>
+                </a:solidFill>
+                <a:latin typeface="Inter"/>
+                <a:ea typeface="Inter"/>
+                <a:cs typeface="Inter"/>
+                <a:sym typeface="Inter"/>
+              </a:rPr>
+              <a:t>RUSBoost</a:t>
+            </a:r>
+            <a:r>
+              <a:rPr lang="it-IT" sz="1350" b="0" i="0" u="none" strike="noStrike" cap="none" dirty="0">
+                <a:solidFill>
+                  <a:srgbClr val="CBD5E1"/>
+                </a:solidFill>
+                <a:latin typeface="Inter"/>
+                <a:ea typeface="Inter"/>
+                <a:cs typeface="Inter"/>
+                <a:sym typeface="Inter"/>
+              </a:rPr>
+              <a:t> (150 cicli, 15 </a:t>
+            </a:r>
+            <a:r>
+              <a:rPr lang="it-IT" sz="1350" dirty="0" err="1">
+                <a:solidFill>
+                  <a:srgbClr val="CBD5E1"/>
+                </a:solidFill>
+                <a:latin typeface="Inter"/>
+                <a:ea typeface="Inter"/>
+                <a:cs typeface="Inter"/>
+                <a:sym typeface="Inter"/>
+              </a:rPr>
+              <a:t>S</a:t>
+            </a:r>
+            <a:r>
+              <a:rPr lang="it-IT" sz="1350" b="0" i="0" u="none" strike="noStrike" cap="none" dirty="0" err="1">
+                <a:solidFill>
+                  <a:srgbClr val="CBD5E1"/>
+                </a:solidFill>
+                <a:latin typeface="Inter"/>
+                <a:ea typeface="Inter"/>
+                <a:cs typeface="Inter"/>
+                <a:sym typeface="Inter"/>
+              </a:rPr>
+              <a:t>plits</a:t>
+            </a:r>
+            <a:r>
+              <a:rPr lang="it-IT" sz="1350" b="0" i="0" u="none" strike="noStrike" cap="none" dirty="0">
+                <a:solidFill>
+                  <a:srgbClr val="CBD5E1"/>
+                </a:solidFill>
+                <a:latin typeface="Inter"/>
+                <a:ea typeface="Inter"/>
+                <a:cs typeface="Inter"/>
+                <a:sym typeface="Inter"/>
+              </a:rPr>
+              <a:t>) </a:t>
+            </a:r>
+            <a:endParaRPr lang="it-IT" dirty="0"/>
+          </a:p>
+        </p:txBody>
+      </p:sp>
+      <p:pic>
+        <p:nvPicPr>
+          <p:cNvPr id="4" name="Immagine 3">
+            <a:extLst>
+              <a:ext uri="{FF2B5EF4-FFF2-40B4-BE49-F238E27FC236}">
+                <a16:creationId xmlns:a16="http://schemas.microsoft.com/office/drawing/2014/main" id="{8C5375A9-28EF-EB41-5D77-C24A1B355B26}"/>
+              </a:ext>
+            </a:extLst>
+          </p:cNvPr>
+          <p:cNvPicPr>
+            <a:picLocks noChangeAspect="1"/>
+          </p:cNvPicPr>
+          <p:nvPr/>
+        </p:nvPicPr>
+        <p:blipFill>
+          <a:blip r:embed="rId4"/>
+          <a:stretch>
+            <a:fillRect/>
+          </a:stretch>
+        </p:blipFill>
+        <p:spPr>
+          <a:xfrm>
+            <a:off x="168200" y="1937538"/>
+            <a:ext cx="11855600" cy="3839742"/>
+          </a:xfrm>
+          <a:prstGeom prst="rect">
+            <a:avLst/>
+          </a:prstGeom>
+        </p:spPr>
+      </p:pic>
+    </p:spTree>
+    <p:extLst>
+      <p:ext uri="{BB962C8B-B14F-4D97-AF65-F5344CB8AC3E}">
+        <p14:creationId xmlns:p14="http://schemas.microsoft.com/office/powerpoint/2010/main" val="3784043608"/>
+      </p:ext>
+    </p:extLst>
+  </p:cSld>
+  <p:clrMapOvr>
+    <a:masterClrMapping/>
+  </p:clrMapOvr>
+</p:sld>
+</file>
+
+<file path=ppt/slides/slide12.xml><?xml version="1.0" encoding="utf-8"?>
 <p:sld xmlns:a="http://schemas.openxmlformats.org/drawingml/2006/main" xmlns:r="http://schemas.openxmlformats.org/officeDocument/2006/relationships" xmlns:p="http://schemas.openxmlformats.org/presentationml/2006/main">
   <p:cSld>
     <p:bg>
@@ -14158,6 +16658,89 @@
           </a:effectLst>
         </p:spPr>
       </p:pic>
+      <p:sp>
+        <p:nvSpPr>
+          <p:cNvPr id="2" name="Google Shape;94;p14">
+            <a:extLst>
+              <a:ext uri="{FF2B5EF4-FFF2-40B4-BE49-F238E27FC236}">
+                <a16:creationId xmlns:a16="http://schemas.microsoft.com/office/drawing/2014/main" id="{F7E61213-9736-9159-47D0-DCF87F822313}"/>
+              </a:ext>
+            </a:extLst>
+          </p:cNvPr>
+          <p:cNvSpPr txBox="1"/>
+          <p:nvPr/>
+        </p:nvSpPr>
+        <p:spPr>
+          <a:xfrm>
+            <a:off x="1559369" y="3591436"/>
+            <a:ext cx="3732753" cy="332399"/>
+          </a:xfrm>
+          <a:prstGeom prst="rect">
+            <a:avLst/>
+          </a:prstGeom>
+          <a:noFill/>
+          <a:ln>
+            <a:noFill/>
+          </a:ln>
+        </p:spPr>
+        <p:txBody>
+          <a:bodyPr spcFirstLastPara="1" wrap="square" lIns="0" tIns="0" rIns="0" bIns="0" anchor="t" anchorCtr="0">
+            <a:spAutoFit/>
+          </a:bodyPr>
+          <a:lstStyle/>
+          <a:p>
+            <a:pPr marL="0" marR="0" lvl="0" indent="0" algn="l" rtl="0">
+              <a:lnSpc>
+                <a:spcPct val="160000"/>
+              </a:lnSpc>
+              <a:spcBef>
+                <a:spcPts val="0"/>
+              </a:spcBef>
+              <a:spcAft>
+                <a:spcPts val="0"/>
+              </a:spcAft>
+              <a:buNone/>
+            </a:pPr>
+            <a:r>
+              <a:rPr lang="it-IT" sz="1350" b="0" i="0" u="none" strike="noStrike" cap="none" dirty="0">
+                <a:solidFill>
+                  <a:srgbClr val="CBD5E1"/>
+                </a:solidFill>
+                <a:latin typeface="Inter"/>
+                <a:ea typeface="Inter"/>
+                <a:cs typeface="Inter"/>
+                <a:sym typeface="Inter"/>
+              </a:rPr>
+              <a:t>Con soglia PPI 0.60 migliora a </a:t>
+            </a:r>
+            <a:r>
+              <a:rPr lang="it-IT" sz="1350" b="1" i="0" u="none" strike="noStrike" cap="none" dirty="0">
+                <a:solidFill>
+                  <a:srgbClr val="CBD5E1"/>
+                </a:solidFill>
+                <a:latin typeface="Inter"/>
+                <a:ea typeface="Inter"/>
+                <a:cs typeface="Inter"/>
+                <a:sym typeface="Inter"/>
+              </a:rPr>
+              <a:t>74,91%</a:t>
+            </a:r>
+            <a:r>
+              <a:rPr lang="it-IT" sz="1350" b="0" i="0" u="none" strike="noStrike" cap="none" dirty="0">
+                <a:solidFill>
+                  <a:srgbClr val="CBD5E1"/>
+                </a:solidFill>
+                <a:latin typeface="Inter"/>
+                <a:ea typeface="Inter"/>
+                <a:cs typeface="Inter"/>
+                <a:sym typeface="Inter"/>
+              </a:rPr>
+              <a:t> </a:t>
+            </a:r>
+            <a:endParaRPr lang="it-IT" dirty="0"/>
+          </a:p>
+        </p:txBody>
+      </p:sp>
     </p:spTree>
   </p:cSld>
   <p:clrMapOvr>
@@ -14166,7 +16749,7 @@
 </p:sld>
 </file>
 
-<file path=ppt/slides/slide12.xml><?xml version="1.0" encoding="utf-8"?>
+<file path=ppt/slides/slide13.xml><?xml version="1.0" encoding="utf-8"?>
 <p:sld xmlns:a="http://schemas.openxmlformats.org/drawingml/2006/main" xmlns:r="http://schemas.openxmlformats.org/officeDocument/2006/relationships" xmlns:p="http://schemas.openxmlformats.org/presentationml/2006/main">
   <p:cSld>
     <p:bg>
@@ -14226,7 +16809,7 @@
         </p:nvSpPr>
         <p:spPr>
           <a:xfrm>
-            <a:off x="1971600" y="1714500"/>
+            <a:off x="1971600" y="1543591"/>
             <a:ext cx="8248800" cy="3393237"/>
           </a:xfrm>
           <a:prstGeom prst="rect">
@@ -14301,7 +16884,7 @@
                 <a:cs typeface="Poppins Medium"/>
                 <a:sym typeface="Poppins Medium"/>
               </a:rPr>
-              <a:t> </a:t>
+              <a:t> del paper è </a:t>
             </a:r>
             <a:r>
               <a:rPr lang="en-US" sz="3150" dirty="0" err="1">
@@ -14313,7 +16896,7 @@
                 <a:cs typeface="Poppins Medium"/>
                 <a:sym typeface="Poppins Medium"/>
               </a:rPr>
-              <a:t>dei</a:t>
+              <a:t>stato</a:t>
             </a:r>
             <a:r>
               <a:rPr lang="en-US" sz="3150" dirty="0">
@@ -14325,7 +16908,7 @@
                 <a:cs typeface="Poppins Medium"/>
                 <a:sym typeface="Poppins Medium"/>
               </a:rPr>
-              <a:t> paper è </a:t>
+              <a:t> </a:t>
             </a:r>
             <a:r>
               <a:rPr lang="en-US" sz="3150" dirty="0" err="1">
@@ -14337,7 +16920,7 @@
                 <a:cs typeface="Poppins Medium"/>
                 <a:sym typeface="Poppins Medium"/>
               </a:rPr>
-              <a:t>stato</a:t>
+              <a:t>possibile</a:t>
             </a:r>
             <a:r>
               <a:rPr lang="en-US" sz="3150" dirty="0">
@@ -14361,7 +16944,7 @@
                 <a:cs typeface="Poppins Medium"/>
                 <a:sym typeface="Poppins Medium"/>
               </a:rPr>
-              <a:t>possibile</a:t>
+              <a:t>avvicinarsi</a:t>
             </a:r>
             <a:r>
               <a:rPr lang="en-US" sz="3150" dirty="0">
@@ -14373,7 +16956,7 @@
                 <a:cs typeface="Poppins Medium"/>
                 <a:sym typeface="Poppins Medium"/>
               </a:rPr>
-              <a:t> </a:t>
+              <a:t> alla </a:t>
             </a:r>
             <a:r>
               <a:rPr lang="en-US" sz="3150" dirty="0" err="1">
@@ -14385,7 +16968,7 @@
                 <a:cs typeface="Poppins Medium"/>
                 <a:sym typeface="Poppins Medium"/>
               </a:rPr>
-              <a:t>avvicinarsi</a:t>
+              <a:t>precisione</a:t>
             </a:r>
             <a:r>
               <a:rPr lang="en-US" sz="3150" dirty="0">
@@ -14397,7 +16980,7 @@
                 <a:cs typeface="Poppins Medium"/>
                 <a:sym typeface="Poppins Medium"/>
               </a:rPr>
-              <a:t> alla </a:t>
+              <a:t> </a:t>
             </a:r>
             <a:r>
               <a:rPr lang="en-US" sz="3150" dirty="0" err="1">
@@ -14409,7 +16992,7 @@
                 <a:cs typeface="Poppins Medium"/>
                 <a:sym typeface="Poppins Medium"/>
               </a:rPr>
-              <a:t>precisione</a:t>
+              <a:t>dichiarata</a:t>
             </a:r>
             <a:r>
               <a:rPr lang="en-US" sz="3150" dirty="0">
@@ -14421,7 +17004,7 @@
                 <a:cs typeface="Poppins Medium"/>
                 <a:sym typeface="Poppins Medium"/>
               </a:rPr>
-              <a:t> </a:t>
+              <a:t> (72.77% </a:t>
             </a:r>
             <a:r>
               <a:rPr lang="en-US" sz="3150" dirty="0" err="1">
@@ -14433,7 +17016,7 @@
                 <a:cs typeface="Poppins Medium"/>
                 <a:sym typeface="Poppins Medium"/>
               </a:rPr>
-              <a:t>dichiarata</a:t>
+              <a:t>contro</a:t>
             </a:r>
             <a:r>
               <a:rPr lang="en-US" sz="3150" dirty="0">
@@ -14445,7 +17028,7 @@
                 <a:cs typeface="Poppins Medium"/>
                 <a:sym typeface="Poppins Medium"/>
               </a:rPr>
-              <a:t> (72.77% </a:t>
+              <a:t> il 76.5%), con </a:t>
             </a:r>
             <a:r>
               <a:rPr lang="en-US" sz="3150" dirty="0" err="1">
@@ -14457,7 +17040,7 @@
                 <a:cs typeface="Poppins Medium"/>
                 <a:sym typeface="Poppins Medium"/>
               </a:rPr>
-              <a:t>contro</a:t>
+              <a:t>possibilità</a:t>
             </a:r>
             <a:r>
               <a:rPr lang="en-US" sz="3150" dirty="0">
@@ -14469,7 +17052,7 @@
                 <a:cs typeface="Poppins Medium"/>
                 <a:sym typeface="Poppins Medium"/>
               </a:rPr>
-              <a:t> il 76.5%), con </a:t>
+              <a:t> di </a:t>
             </a:r>
             <a:r>
               <a:rPr lang="en-US" sz="3150" dirty="0" err="1">
@@ -14481,7 +17064,7 @@
                 <a:cs typeface="Poppins Medium"/>
                 <a:sym typeface="Poppins Medium"/>
               </a:rPr>
-              <a:t>possibilità</a:t>
+              <a:t>miglioramento</a:t>
             </a:r>
             <a:r>
               <a:rPr lang="en-US" sz="3150" dirty="0">
@@ -14493,7 +17076,7 @@
                 <a:cs typeface="Poppins Medium"/>
                 <a:sym typeface="Poppins Medium"/>
               </a:rPr>
-              <a:t> di </a:t>
+              <a:t> </a:t>
             </a:r>
             <a:r>
               <a:rPr lang="en-US" sz="3150" dirty="0" err="1">
@@ -14505,7 +17088,7 @@
                 <a:cs typeface="Poppins Medium"/>
                 <a:sym typeface="Poppins Medium"/>
               </a:rPr>
-              <a:t>miglioramento</a:t>
+              <a:t>tramite</a:t>
             </a:r>
             <a:r>
               <a:rPr lang="en-US" sz="3150" dirty="0">
@@ -14517,7 +17100,55 @@
                 <a:cs typeface="Poppins Medium"/>
                 <a:sym typeface="Poppins Medium"/>
               </a:rPr>
-              <a:t> future.</a:t>
+              <a:t> PPI </a:t>
+            </a:r>
+            <a:r>
+              <a:rPr lang="en-US" sz="3150" dirty="0" err="1">
+                <a:solidFill>
+                  <a:schemeClr val="bg1"/>
+                </a:solidFill>
+                <a:latin typeface="Poppins Medium"/>
+                <a:ea typeface="Poppins Medium"/>
+                <a:cs typeface="Poppins Medium"/>
+                <a:sym typeface="Poppins Medium"/>
+              </a:rPr>
+              <a:t>diversi</a:t>
+            </a:r>
+            <a:r>
+              <a:rPr lang="en-US" sz="3150" dirty="0">
+                <a:solidFill>
+                  <a:schemeClr val="bg1"/>
+                </a:solidFill>
+                <a:latin typeface="Poppins Medium"/>
+                <a:ea typeface="Poppins Medium"/>
+                <a:cs typeface="Poppins Medium"/>
+                <a:sym typeface="Poppins Medium"/>
+              </a:rPr>
+              <a:t> e </a:t>
+            </a:r>
+            <a:r>
+              <a:rPr lang="en-US" sz="3150" dirty="0" err="1">
+                <a:solidFill>
+                  <a:schemeClr val="bg1"/>
+                </a:solidFill>
+                <a:latin typeface="Poppins Medium"/>
+                <a:ea typeface="Poppins Medium"/>
+                <a:cs typeface="Poppins Medium"/>
+                <a:sym typeface="Poppins Medium"/>
+              </a:rPr>
+              <a:t>ulteriore</a:t>
+            </a:r>
+            <a:r>
+              <a:rPr lang="en-US" sz="3150" dirty="0">
+                <a:solidFill>
+                  <a:schemeClr val="bg1"/>
+                </a:solidFill>
+                <a:latin typeface="Poppins Medium"/>
+                <a:ea typeface="Poppins Medium"/>
+                <a:cs typeface="Poppins Medium"/>
+                <a:sym typeface="Poppins Medium"/>
+              </a:rPr>
+              <a:t> tuning.</a:t>
             </a:r>
             <a:endParaRPr dirty="0">
               <a:solidFill>
@@ -14959,7 +17590,7 @@
         <p:spPr>
           <a:xfrm>
             <a:off x="571500" y="2051637"/>
-            <a:ext cx="5286300" cy="540300"/>
+            <a:ext cx="5286300" cy="664797"/>
           </a:xfrm>
           <a:prstGeom prst="rect">
             <a:avLst/>
@@ -15225,7 +17856,7 @@
                 <a:cs typeface="Inter"/>
                 <a:sym typeface="Inter"/>
               </a:rPr>
-              <a:t>).</a:t>
+              <a:t>/Rest).</a:t>
             </a:r>
             <a:endParaRPr dirty="0"/>
           </a:p>
@@ -15239,8 +17870,8 @@
         </p:nvSpPr>
         <p:spPr>
           <a:xfrm>
-            <a:off x="571500" y="2909292"/>
-            <a:ext cx="5286375" cy="664797"/>
+            <a:off x="571425" y="2805341"/>
+            <a:ext cx="5286375" cy="997196"/>
           </a:xfrm>
           <a:prstGeom prst="rect">
             <a:avLst/>
@@ -15557,6 +18188,54 @@
               <a:t>multisensoriali</a:t>
             </a:r>
             <a:r>
+              <a:rPr lang="en-US" sz="1350" dirty="0">
+                <a:solidFill>
+                  <a:srgbClr val="CBD5E1"/>
+                </a:solidFill>
+                <a:latin typeface="Inter"/>
+                <a:ea typeface="Inter"/>
+                <a:cs typeface="Inter"/>
+                <a:sym typeface="Inter"/>
+              </a:rPr>
+              <a:t>, </a:t>
+            </a:r>
+            <a:r>
+              <a:rPr lang="en-US" sz="1350" dirty="0" err="1">
+                <a:solidFill>
+                  <a:srgbClr val="CBD5E1"/>
+                </a:solidFill>
+                <a:latin typeface="Inter"/>
+                <a:ea typeface="Inter"/>
+                <a:cs typeface="Inter"/>
+                <a:sym typeface="Inter"/>
+              </a:rPr>
+              <a:t>nello</a:t>
+            </a:r>
+            <a:r>
+              <a:rPr lang="en-US" sz="1350" dirty="0">
+                <a:solidFill>
+                  <a:srgbClr val="CBD5E1"/>
+                </a:solidFill>
+                <a:latin typeface="Inter"/>
+                <a:ea typeface="Inter"/>
+                <a:cs typeface="Inter"/>
+                <a:sym typeface="Inter"/>
+              </a:rPr>
+              <a:t> specific con </a:t>
+            </a:r>
+            <a:r>
+              <a:rPr lang="en-US" sz="1350" b="0" i="0" u="none" strike="noStrike" cap="none" dirty="0" err="1">
+                <a:solidFill>
+                  <a:srgbClr val="CBD5E1"/>
+                </a:solidFill>
+                <a:latin typeface="Inter"/>
+                <a:ea typeface="Inter"/>
+                <a:cs typeface="Inter"/>
+                <a:sym typeface="Inter"/>
+              </a:rPr>
+              <a:t>Empatica</a:t>
+            </a:r>
+            <a:r>
               <a:rPr lang="en-US" sz="1350" b="0" i="0" u="none" strike="noStrike" cap="none" dirty="0">
                 <a:solidFill>
                   <a:srgbClr val="CBD5E1"/>
@@ -15566,31 +18245,7 @@
                 <a:cs typeface="Inter"/>
                 <a:sym typeface="Inter"/>
               </a:rPr>
-              <a:t> (</a:t>
-            </a:r>
-            <a:r>
-              <a:rPr lang="en-US" sz="1350" b="0" i="0" u="none" strike="noStrike" cap="none" dirty="0" err="1">
-                <a:solidFill>
-                  <a:srgbClr val="CBD5E1"/>
-                </a:solidFill>
-                <a:latin typeface="Inter"/>
-                <a:ea typeface="Inter"/>
-                <a:cs typeface="Inter"/>
-                <a:sym typeface="Inter"/>
-              </a:rPr>
-              <a:t>Empatica</a:t>
-            </a:r>
-            <a:r>
-              <a:rPr lang="en-US" sz="1350" b="0" i="0" u="none" strike="noStrike" cap="none" dirty="0">
-                <a:solidFill>
-                  <a:srgbClr val="CBD5E1"/>
-                </a:solidFill>
-                <a:latin typeface="Inter"/>
-                <a:ea typeface="Inter"/>
-                <a:cs typeface="Inter"/>
-                <a:sym typeface="Inter"/>
-              </a:rPr>
-              <a:t> E4).</a:t>
+              <a:t> E4.</a:t>
             </a:r>
             <a:endParaRPr dirty="0"/>
           </a:p>
@@ -15605,7 +18260,7 @@
         <p:spPr>
           <a:xfrm>
             <a:off x="571500" y="3891445"/>
-            <a:ext cx="5286300" cy="540300"/>
+            <a:ext cx="5286300" cy="997196"/>
           </a:xfrm>
           <a:prstGeom prst="rect">
             <a:avLst/>
@@ -15811,7 +18466,7 @@
                 <a:cs typeface="Inter"/>
                 <a:sym typeface="Inter"/>
               </a:rPr>
-              <a:t> </a:t>
+              <a:t> possible (</a:t>
             </a:r>
             <a:r>
               <a:rPr lang="en-US" sz="1350" dirty="0" err="1">
@@ -15823,7 +18478,19 @@
                 <a:cs typeface="Inter"/>
                 <a:sym typeface="Inter"/>
               </a:rPr>
-              <a:t>possibile</a:t>
+              <a:t>Principalmente</a:t>
+            </a:r>
+            <a:r>
+              <a:rPr lang="en-US" sz="1350" dirty="0">
+                <a:solidFill>
+                  <a:srgbClr val="CBD5E1"/>
+                </a:solidFill>
+                <a:latin typeface="Inter"/>
+                <a:ea typeface="Inter"/>
+                <a:cs typeface="Inter"/>
+                <a:sym typeface="Inter"/>
+              </a:rPr>
+              <a:t> RF, SVM e Logistic Regression)</a:t>
             </a:r>
             <a:r>
               <a:rPr lang="en-US" sz="1350" b="0" i="0" u="none" strike="noStrike" cap="none" dirty="0">
@@ -16400,7 +19067,7 @@
                 <a:cs typeface="Inter"/>
                 <a:sym typeface="Inter"/>
               </a:rPr>
-              <a:t> (EDA e PPG). La loro </a:t>
+              <a:t> (EDA e BVP). La loro </a:t>
             </a:r>
             <a:r>
               <a:rPr lang="en-US" sz="1350" b="0" i="0" u="none" strike="noStrike" cap="none" dirty="0" err="1">
@@ -16975,7 +19642,7 @@
                 <a:ea typeface="Inter"/>
                 <a:sym typeface="Inter"/>
               </a:rPr>
-              <a:t>) </a:t>
+              <a:t>) con </a:t>
             </a:r>
             <a:r>
               <a:rPr lang="en-US" sz="1350" dirty="0" err="1">
@@ -17129,7 +19796,29 @@
                 <a:ea typeface="Inter"/>
                 <a:sym typeface="Inter"/>
               </a:rPr>
-              <a:t>.</a:t>
+              <a:t>, e </a:t>
+            </a:r>
+            <a:r>
+              <a:rPr lang="en-US" sz="1350" dirty="0" err="1">
+                <a:solidFill>
+                  <a:srgbClr val="CBD5E1"/>
+                </a:solidFill>
+                <a:latin typeface="Inter"/>
+                <a:ea typeface="Inter"/>
+                <a:sym typeface="Inter"/>
+              </a:rPr>
+              <a:t>soglie</a:t>
+            </a:r>
+            <a:r>
+              <a:rPr lang="en-US" sz="1350" dirty="0">
+                <a:solidFill>
+                  <a:srgbClr val="CBD5E1"/>
+                </a:solidFill>
+                <a:latin typeface="Inter"/>
+                <a:ea typeface="Inter"/>
+                <a:sym typeface="Inter"/>
+              </a:rPr>
+              <a:t> PPI diverse.</a:t>
             </a:r>
             <a:endParaRPr dirty="0"/>
           </a:p>
@@ -18793,8 +21482,8 @@
         </p:nvSpPr>
         <p:spPr>
           <a:xfrm>
-            <a:off x="3370510" y="2769989"/>
-            <a:ext cx="2784300" cy="254100"/>
+            <a:off x="3370509" y="2769989"/>
+            <a:ext cx="3012705" cy="253916"/>
           </a:xfrm>
           <a:prstGeom prst="rect">
             <a:avLst/>
@@ -18841,10 +21530,10 @@
                 <a:cs typeface="Poppins Medium"/>
                 <a:sym typeface="Poppins Medium"/>
               </a:rPr>
-              <a:t> Lego </a:t>
-            </a:r>
-            <a:r>
-              <a:rPr lang="en-US" sz="1650" b="0" i="0" u="none" strike="noStrike" cap="none" dirty="0" err="1">
+              <a:t> Lego con </a:t>
+            </a:r>
+            <a:r>
+              <a:rPr lang="en-US" sz="1650" dirty="0" err="1">
                 <a:solidFill>
                   <a:srgbClr val="F8FAFC"/>
                 </a:solidFill>
@@ -18853,7 +21542,19 @@
                 <a:cs typeface="Poppins Medium"/>
                 <a:sym typeface="Poppins Medium"/>
               </a:rPr>
-              <a:t>Guidato</a:t>
+              <a:t>i</a:t>
+            </a:r>
+            <a:r>
+              <a:rPr lang="en-US" sz="1650" b="0" i="0" u="none" strike="noStrike" cap="none" dirty="0" err="1">
+                <a:solidFill>
+                  <a:srgbClr val="F8FAFC"/>
+                </a:solidFill>
+                <a:latin typeface="Poppins Medium"/>
+                <a:ea typeface="Poppins Medium"/>
+                <a:cs typeface="Poppins Medium"/>
+                <a:sym typeface="Poppins Medium"/>
+              </a:rPr>
+              <a:t>struzioni</a:t>
             </a:r>
             <a:endParaRPr dirty="0"/>
           </a:p>
@@ -19103,7 +21804,7 @@
               <a:buNone/>
             </a:pPr>
             <a:r>
-              <a:rPr lang="en-US" sz="1650">
+              <a:rPr lang="en-US" sz="1650" dirty="0">
                 <a:solidFill>
                   <a:srgbClr val="F8FAFC"/>
                 </a:solidFill>
@@ -19115,7 +21816,7 @@
               <a:t>3° e 4° Task</a:t>
             </a:r>
             <a:r>
-              <a:rPr lang="en-US" sz="1650" b="0" i="0" u="none" strike="noStrike" cap="none">
+              <a:rPr lang="en-US" sz="1650" b="0" i="0" u="none" strike="noStrike" cap="none" dirty="0">
                 <a:solidFill>
                   <a:srgbClr val="F8FAFC"/>
                 </a:solidFill>
@@ -19124,9 +21825,21 @@
                 <a:cs typeface="Poppins Medium"/>
                 <a:sym typeface="Poppins Medium"/>
               </a:rPr>
-              <a:t>: Matematica</a:t>
-            </a:r>
-            <a:endParaRPr/>
+              <a:t>: </a:t>
+            </a:r>
+            <a:r>
+              <a:rPr lang="en-US" sz="1650" b="0" i="0" u="none" strike="noStrike" cap="none" dirty="0" err="1">
+                <a:solidFill>
+                  <a:srgbClr val="F8FAFC"/>
+                </a:solidFill>
+                <a:latin typeface="Poppins Medium"/>
+                <a:ea typeface="Poppins Medium"/>
+                <a:cs typeface="Poppins Medium"/>
+                <a:sym typeface="Poppins Medium"/>
+              </a:rPr>
+              <a:t>Matematica</a:t>
+            </a:r>
+            <a:endParaRPr dirty="0"/>
           </a:p>
         </p:txBody>
       </p:sp>
@@ -19230,7 +21943,7 @@
               <a:buNone/>
             </a:pPr>
             <a:r>
-              <a:rPr lang="en-US" sz="1650">
+              <a:rPr lang="en-US" sz="1650" dirty="0">
                 <a:solidFill>
                   <a:srgbClr val="F8FAFC"/>
                 </a:solidFill>
@@ -19242,7 +21955,7 @@
               <a:t>5° Task</a:t>
             </a:r>
             <a:r>
-              <a:rPr lang="en-US" sz="1650" b="0" i="0" u="none" strike="noStrike" cap="none">
+              <a:rPr lang="en-US" sz="1650" b="0" i="0" u="none" strike="noStrike" cap="none" dirty="0">
                 <a:solidFill>
                   <a:srgbClr val="F8FAFC"/>
                 </a:solidFill>
@@ -19253,7 +21966,7 @@
               </a:rPr>
               <a:t>: Esposizione CV</a:t>
             </a:r>
-            <a:endParaRPr/>
+            <a:endParaRPr dirty="0"/>
           </a:p>
         </p:txBody>
       </p:sp>
@@ -20781,7 +23494,7 @@
         </p:nvSpPr>
         <p:spPr>
           <a:xfrm>
-            <a:off x="501438" y="1196784"/>
+            <a:off x="571500" y="3108720"/>
             <a:ext cx="5286375" cy="332399"/>
           </a:xfrm>
           <a:prstGeom prst="rect">
@@ -20889,7 +23602,7 @@
         </p:nvSpPr>
         <p:spPr>
           <a:xfrm>
-            <a:off x="571424" y="4160344"/>
+            <a:off x="571500" y="1325346"/>
             <a:ext cx="5286375" cy="249299"/>
           </a:xfrm>
           <a:prstGeom prst="rect">
@@ -21027,7 +23740,7 @@
         </p:nvSpPr>
         <p:spPr>
           <a:xfrm>
-            <a:off x="882438" y="1584069"/>
+            <a:off x="952500" y="3496005"/>
             <a:ext cx="4914900" cy="2326791"/>
           </a:xfrm>
           <a:prstGeom prst="rect">
@@ -21756,7 +24469,7 @@
         </p:nvSpPr>
         <p:spPr>
           <a:xfrm>
-            <a:off x="952499" y="4447925"/>
+            <a:off x="952575" y="1612927"/>
             <a:ext cx="4905300" cy="1661993"/>
           </a:xfrm>
           <a:prstGeom prst="rect">
@@ -22737,7 +25450,43 @@
                 <a:cs typeface="Poppins SemiBold"/>
                 <a:sym typeface="Poppins SemiBold"/>
               </a:rPr>
-              <a:t> 10-Fold CV</a:t>
+              <a:t> 10-Fold CV (con </a:t>
+            </a:r>
+            <a:r>
+              <a:rPr lang="en-US" sz="3000" dirty="0" err="1">
+                <a:solidFill>
+                  <a:srgbClr val="F8FAFC"/>
+                </a:solidFill>
+                <a:latin typeface="Poppins SemiBold"/>
+                <a:ea typeface="Poppins SemiBold"/>
+                <a:cs typeface="Poppins SemiBold"/>
+                <a:sym typeface="Poppins SemiBold"/>
+              </a:rPr>
+              <a:t>p</a:t>
+            </a:r>
+            <a:r>
+              <a:rPr lang="en-US" sz="3000" b="0" i="0" u="none" strike="noStrike" cap="none" dirty="0" err="1">
+                <a:solidFill>
+                  <a:srgbClr val="F8FAFC"/>
+                </a:solidFill>
+                <a:latin typeface="Poppins SemiBold"/>
+                <a:ea typeface="Poppins SemiBold"/>
+                <a:cs typeface="Poppins SemiBold"/>
+                <a:sym typeface="Poppins SemiBold"/>
+              </a:rPr>
+              <a:t>arametri</a:t>
+            </a:r>
+            <a:r>
+              <a:rPr lang="en-US" sz="3000" b="0" i="0" u="none" strike="noStrike" cap="none" dirty="0">
+                <a:solidFill>
+                  <a:srgbClr val="F8FAFC"/>
+                </a:solidFill>
+                <a:latin typeface="Poppins SemiBold"/>
+                <a:ea typeface="Poppins SemiBold"/>
+                <a:cs typeface="Poppins SemiBold"/>
+                <a:sym typeface="Poppins SemiBold"/>
+              </a:rPr>
+              <a:t> del Paper)</a:t>
             </a:r>
             <a:endParaRPr dirty="0"/>
           </a:p>
@@ -23948,10 +26697,10 @@
       </p:sp>
       <p:pic>
         <p:nvPicPr>
-          <p:cNvPr id="7" name="Immagine 6">
+          <p:cNvPr id="3" name="Immagine 2">
             <a:extLst>
               <a:ext uri="{FF2B5EF4-FFF2-40B4-BE49-F238E27FC236}">
-                <a16:creationId xmlns:a16="http://schemas.microsoft.com/office/drawing/2014/main" id="{A16EB073-200F-F3BB-B490-4C044385FCD1}"/>
+                <a16:creationId xmlns:a16="http://schemas.microsoft.com/office/drawing/2014/main" id="{3EE4CC44-C9ED-6D91-2D76-EFDF2DD61C5E}"/>
               </a:ext>
             </a:extLst>
           </p:cNvPr>
@@ -23968,36 +26717,12 @@
         </p:blipFill>
         <p:spPr>
           <a:xfrm>
-            <a:off x="538535" y="1745398"/>
-            <a:ext cx="11114930" cy="4780323"/>
+            <a:off x="529132" y="1807836"/>
+            <a:ext cx="11133736" cy="4478664"/>
           </a:xfrm>
-          <a:prstGeom prst="roundRect">
-            <a:avLst>
-              <a:gd name="adj" fmla="val 16667"/>
-            </a:avLst>
+          <a:prstGeom prst="rect">
+            <a:avLst/>
           </a:prstGeom>
-          <a:ln>
-            <a:noFill/>
-          </a:ln>
-          <a:effectLst>
-            <a:outerShdw blurRad="76200" dist="38100" dir="7800000" algn="tl" rotWithShape="0">
-              <a:srgbClr val="000000">
-                <a:alpha val="40000"/>
-              </a:srgbClr>
-            </a:outerShdw>
-          </a:effectLst>
-          <a:scene3d>
-            <a:camera prst="orthographicFront"/>
-            <a:lightRig rig="contrasting" dir="t">
-              <a:rot lat="0" lon="0" rev="4200000"/>
-            </a:lightRig>
-          </a:scene3d>
-          <a:sp3d prstMaterial="plastic">
-            <a:bevelT w="381000" h="114300" prst="relaxedInset"/>
-            <a:contourClr>
-              <a:srgbClr val="969696"/>
-            </a:contourClr>
-          </a:sp3d>
         </p:spPr>
       </p:pic>
     </p:spTree>

</xml_diff>

<commit_message>
Changelogs: - Caricato uno script matlab grafico. - Minori modifiche al codice
</commit_message>
<xml_diff>
--- a/Progetto Interfacce Uomo-Macchina.pptx
+++ b/Progetto Interfacce Uomo-Macchina.pptx
@@ -13501,11 +13501,9 @@
               <a:t> </a:t>
             </a:r>
             <a:r>
-              <a:rPr lang="en-US" sz="1350" dirty="0">
-                <a:solidFill>
-                  <a:schemeClr val="bg1">
-                    <a:lumMod val="85000"/>
-                  </a:schemeClr>
+              <a:rPr lang="en-US" sz="1350" b="1" dirty="0">
+                <a:solidFill>
+                  <a:srgbClr val="21EB9E"/>
                 </a:solidFill>
                 <a:latin typeface="Inter"/>
                 <a:ea typeface="Inter"/>
@@ -13514,18 +13512,6 @@
               </a:rPr>
               <a:t>74.91%</a:t>
             </a:r>
-            <a:endParaRPr lang="en-US" sz="1350" b="1" dirty="0">
-              <a:solidFill>
-                <a:schemeClr val="bg2">
-                  <a:lumMod val="20000"/>
-                  <a:lumOff val="80000"/>
-                </a:schemeClr>
-              </a:solidFill>
-              <a:latin typeface="Inter"/>
-              <a:ea typeface="Inter"/>
-              <a:cs typeface="Inter"/>
-              <a:sym typeface="Inter"/>
-            </a:endParaRPr>
           </a:p>
           <a:p>
             <a:pPr marL="0" marR="0" lvl="0" indent="0" algn="l" rtl="0">
@@ -19741,7 +19727,7 @@
                 <a:ea typeface="Inter"/>
                 <a:sym typeface="Inter"/>
               </a:rPr>
-              <a:t>comportano</a:t>
+              <a:t>comporta</a:t>
             </a:r>
             <a:r>
               <a:rPr lang="en-US" sz="1350" dirty="0">
@@ -21482,8 +21468,8 @@
         </p:nvSpPr>
         <p:spPr>
           <a:xfrm>
-            <a:off x="3370509" y="2769989"/>
-            <a:ext cx="3012705" cy="253916"/>
+            <a:off x="3370510" y="2632950"/>
+            <a:ext cx="3356862" cy="507831"/>
           </a:xfrm>
           <a:prstGeom prst="rect">
             <a:avLst/>
@@ -21518,7 +21504,7 @@
                 <a:cs typeface="Poppins Medium"/>
                 <a:sym typeface="Poppins Medium"/>
               </a:rPr>
-              <a:t>2° Task:</a:t>
+              <a:t>2° e 3° Task:</a:t>
             </a:r>
             <a:r>
               <a:rPr lang="en-US" sz="1650" b="0" i="0" u="none" strike="noStrike" cap="none" dirty="0">
@@ -21530,10 +21516,10 @@
                 <a:cs typeface="Poppins Medium"/>
                 <a:sym typeface="Poppins Medium"/>
               </a:rPr>
-              <a:t> Lego con </a:t>
-            </a:r>
-            <a:r>
-              <a:rPr lang="en-US" sz="1650" dirty="0" err="1">
+              <a:t> Lego </a:t>
+            </a:r>
+            <a:r>
+              <a:rPr lang="en-US" sz="1650" dirty="0">
                 <a:solidFill>
                   <a:srgbClr val="F8FAFC"/>
                 </a:solidFill>
@@ -21542,10 +21528,10 @@
                 <a:cs typeface="Poppins Medium"/>
                 <a:sym typeface="Poppins Medium"/>
               </a:rPr>
-              <a:t>i</a:t>
-            </a:r>
-            <a:r>
-              <a:rPr lang="en-US" sz="1650" b="0" i="0" u="none" strike="noStrike" cap="none" dirty="0" err="1">
+              <a:t>con/senza </a:t>
+            </a:r>
+            <a:r>
+              <a:rPr lang="en-US" sz="1650" dirty="0" err="1">
                 <a:solidFill>
                   <a:srgbClr val="F8FAFC"/>
                 </a:solidFill>
@@ -21554,7 +21540,7 @@
                 <a:cs typeface="Poppins Medium"/>
                 <a:sym typeface="Poppins Medium"/>
               </a:rPr>
-              <a:t>struzioni</a:t>
+              <a:t>istruzioni</a:t>
             </a:r>
             <a:endParaRPr dirty="0"/>
           </a:p>
@@ -21679,7 +21665,7 @@
                 <a:cs typeface="Inter"/>
                 <a:sym typeface="Inter"/>
               </a:rPr>
-              <a:t>dei</a:t>
+              <a:t>piccoli</a:t>
             </a:r>
             <a:r>
               <a:rPr lang="en-US" sz="1200" b="0" i="0" u="none" strike="noStrike" cap="none" dirty="0">
@@ -21715,7 +21701,31 @@
                 <a:cs typeface="Inter"/>
                 <a:sym typeface="Inter"/>
               </a:rPr>
-              <a:t> (</a:t>
+              <a:t>, e poi </a:t>
+            </a:r>
+            <a:r>
+              <a:rPr lang="en-US" sz="1200" b="0" i="0" u="none" strike="noStrike" cap="none" dirty="0" err="1">
+                <a:solidFill>
+                  <a:srgbClr val="94A3B8"/>
+                </a:solidFill>
+                <a:latin typeface="Inter"/>
+                <a:ea typeface="Inter"/>
+                <a:cs typeface="Inter"/>
+                <a:sym typeface="Inter"/>
+              </a:rPr>
+              <a:t>grandi</a:t>
+            </a:r>
+            <a:r>
+              <a:rPr lang="en-US" sz="1200" b="0" i="0" u="none" strike="noStrike" cap="none" dirty="0">
+                <a:solidFill>
+                  <a:srgbClr val="94A3B8"/>
+                </a:solidFill>
+                <a:latin typeface="Inter"/>
+                <a:ea typeface="Inter"/>
+                <a:cs typeface="Inter"/>
+                <a:sym typeface="Inter"/>
+              </a:rPr>
+              <a:t> senza (</a:t>
             </a:r>
             <a:r>
               <a:rPr lang="en-US" sz="1200" b="0" i="0" u="none" strike="noStrike" cap="none" dirty="0" err="1">
@@ -21813,7 +21823,7 @@
                 <a:cs typeface="Poppins Medium"/>
                 <a:sym typeface="Poppins Medium"/>
               </a:rPr>
-              <a:t>3° e 4° Task</a:t>
+              <a:t>4° Task</a:t>
             </a:r>
             <a:r>
               <a:rPr lang="en-US" sz="1650" b="0" i="0" u="none" strike="noStrike" cap="none" dirty="0">
@@ -22321,6 +22331,66 @@
           </a:p>
         </p:txBody>
       </p:sp>
+      <p:pic>
+        <p:nvPicPr>
+          <p:cNvPr id="3" name="Immagine 2">
+            <a:extLst>
+              <a:ext uri="{FF2B5EF4-FFF2-40B4-BE49-F238E27FC236}">
+                <a16:creationId xmlns:a16="http://schemas.microsoft.com/office/drawing/2014/main" id="{2CAD9EF4-5565-D5DA-7D1F-059E60C56332}"/>
+              </a:ext>
+            </a:extLst>
+          </p:cNvPr>
+          <p:cNvPicPr>
+            <a:picLocks noChangeAspect="1"/>
+          </p:cNvPicPr>
+          <p:nvPr/>
+        </p:nvPicPr>
+        <p:blipFill>
+          <a:blip r:embed="rId4"/>
+          <a:stretch>
+            <a:fillRect/>
+          </a:stretch>
+        </p:blipFill>
+        <p:spPr>
+          <a:xfrm>
+            <a:off x="6253463" y="421744"/>
+            <a:ext cx="4778782" cy="1851519"/>
+          </a:xfrm>
+          <a:prstGeom prst="snip2DiagRect">
+            <a:avLst/>
+          </a:prstGeom>
+          <a:solidFill>
+            <a:srgbClr val="FFFFFF">
+              <a:shade val="85000"/>
+            </a:srgbClr>
+          </a:solidFill>
+          <a:ln w="88900" cap="sq">
+            <a:solidFill>
+              <a:srgbClr val="FFFFFF"/>
+            </a:solidFill>
+            <a:miter lim="800000"/>
+          </a:ln>
+          <a:effectLst>
+            <a:outerShdw blurRad="88900" algn="tl" rotWithShape="0">
+              <a:srgbClr val="000000">
+                <a:alpha val="45000"/>
+              </a:srgbClr>
+            </a:outerShdw>
+          </a:effectLst>
+          <a:scene3d>
+            <a:camera prst="orthographicFront"/>
+            <a:lightRig rig="twoPt" dir="t">
+              <a:rot lat="0" lon="0" rev="7200000"/>
+            </a:lightRig>
+          </a:scene3d>
+          <a:sp3d>
+            <a:bevelT w="25400" h="19050"/>
+            <a:contourClr>
+              <a:srgbClr val="FFFFFF"/>
+            </a:contourClr>
+          </a:sp3d>
+        </p:spPr>
+      </p:pic>
     </p:spTree>
   </p:cSld>
   <p:clrMapOvr>
@@ -22729,7 +22799,31 @@
                 <a:cs typeface="Inter"/>
                 <a:sym typeface="Inter"/>
               </a:rPr>
-              <a:t> da 1 minute per </a:t>
+              <a:t> da 1 </a:t>
+            </a:r>
+            <a:r>
+              <a:rPr lang="en-US" sz="1350" dirty="0" err="1">
+                <a:solidFill>
+                  <a:srgbClr val="CBD5E1"/>
+                </a:solidFill>
+                <a:latin typeface="Inter"/>
+                <a:ea typeface="Inter"/>
+                <a:cs typeface="Inter"/>
+                <a:sym typeface="Inter"/>
+              </a:rPr>
+              <a:t>minuto</a:t>
+            </a:r>
+            <a:r>
+              <a:rPr lang="en-US" sz="1350" dirty="0">
+                <a:solidFill>
+                  <a:srgbClr val="CBD5E1"/>
+                </a:solidFill>
+                <a:latin typeface="Inter"/>
+                <a:ea typeface="Inter"/>
+                <a:cs typeface="Inter"/>
+                <a:sym typeface="Inter"/>
+              </a:rPr>
+              <a:t> per </a:t>
             </a:r>
             <a:r>
               <a:rPr lang="en-US" sz="1350" dirty="0" err="1">
@@ -22937,7 +23031,7 @@
                 <a:cs typeface="Inter"/>
                 <a:sym typeface="Inter"/>
               </a:rPr>
-              <a:t>Estrazione delle features per fornire al modello una rappresentazione chiara del segnale e dei dati su cui lavorare.</a:t>
+              <a:t>Estrazione delle features per fornire al modello una rappresentazione chiara del segnale e dei dati.</a:t>
             </a:r>
             <a:endParaRPr lang="it-IT" dirty="0"/>
           </a:p>
@@ -23139,7 +23233,7 @@
                 <a:ea typeface="Inter"/>
                 <a:sym typeface="Inter"/>
               </a:rPr>
-              <a:t> (Con Random Forest – RF e SVM) </a:t>
+              <a:t> (Con Random Forest – RF, SVM e Logistic Regression) </a:t>
             </a:r>
             <a:r>
               <a:rPr lang="en-US" sz="1350" dirty="0" err="1">
@@ -23741,7 +23835,7 @@
         <p:spPr>
           <a:xfrm>
             <a:off x="952500" y="3496005"/>
-            <a:ext cx="4914900" cy="2326791"/>
+            <a:ext cx="4914900" cy="1994392"/>
           </a:xfrm>
           <a:prstGeom prst="rect">
             <a:avLst/>
@@ -24241,7 +24335,7 @@
                 <a:cs typeface="Inter"/>
                 <a:sym typeface="Inter"/>
               </a:rPr>
-              <a:t> mini 0.4s)</a:t>
+              <a:t> minima 0.4s)</a:t>
             </a:r>
           </a:p>
           <a:p>
@@ -24417,7 +24511,7 @@
                 <a:cs typeface="Inter"/>
                 <a:sym typeface="Inter"/>
               </a:rPr>
-              <a:t> con intervalli anomaly (al di </a:t>
+              <a:t> con intervalli anomaly (</a:t>
             </a:r>
             <a:r>
               <a:rPr lang="en-US" sz="1350" dirty="0" err="1">
@@ -24431,7 +24525,7 @@
                 <a:cs typeface="Inter"/>
                 <a:sym typeface="Inter"/>
               </a:rPr>
-              <a:t>fuori</a:t>
+              <a:t>oltre</a:t>
             </a:r>
             <a:r>
               <a:rPr lang="en-US" sz="1350" dirty="0">
@@ -24445,7 +24539,7 @@
                 <a:cs typeface="Inter"/>
                 <a:sym typeface="Inter"/>
               </a:rPr>
-              <a:t> del 15%)</a:t>
+              <a:t> al 15%)</a:t>
             </a:r>
             <a:endParaRPr lang="en-US" sz="1350" b="0" i="0" u="none" strike="noStrike" cap="none" dirty="0">
               <a:solidFill>

</xml_diff>